<commit_message>
Úpravy prezentace: logo, titulní slide, limity na konec, závěr s odkazy, osnova jako stránka
- menší a ostřejší logo na titulní straně, bez oponenta
- nápověda ovládání vpravo dole s automatickým skrytím, číslo slidu v zápatí vlevo
- slide Limity přesunut za Závěr jako doplňující (12), Závěr je 11
- v závěru zmínka o otevřeném kódu (github.com/edustack-is) a webu is-edustack.org
- totéž promítnuto do PPTX a PDF, kartiček, scénáře a osnovy
- docs/osnova.html + odkaz z rozcestníku

Co-Authored-By: Claude Fable 5.1 <noreply@anthropic.com>
</commit_message>
<xml_diff>
--- a/obhajoba-edustack.pptx
+++ b/obhajoba-edustack.pptx
@@ -15,8 +15,8 @@
     <p:sldId id="263" r:id="rId9"/>
     <p:sldId id="264" r:id="rId10"/>
     <p:sldId id="265" r:id="rId11"/>
+    <p:sldId id="267" r:id="rId13"/>
     <p:sldId id="266" r:id="rId12"/>
-    <p:sldId id="267" r:id="rId13"/>
   </p:sldIdLst>
   <p:notesMasterIdLst>
     <p:notesMasterId r:id="rId14"/>
@@ -712,7 +712,7 @@
           <a:p>
             <a:fld id="{F7021451-1387-4CA6-816F-3879F97B5CBC}" type="slidenum">
               <a:rPr lang="en-US"/>
-              <a:t>11</a:t>
+              <a:t>12</a:t>
             </a:fld>
             <a:endParaRPr lang="en-US"/>
           </a:p>
@@ -777,7 +777,7 @@
           <a:p>
             <a:r>
               <a:rPr lang="en-US" dirty="0"/>
-              <a:t>Shrnutí: vymezil jsem kategorii edukačních IS, postavil prototyp s metodikou a ověřil ho ve výuce; pilotáž potvrdila hlavní hypotézu. Další rozvoj: ověření na SŠ a 1. stupni a na více školách. Děkuji za pozornost a rád odpovím na otázky.</a:t>
+              <a:t>Shrnutí: vymezil jsem kategorii edukačních IS, postavil prototyp s metodikou a ověřil ho ve výuce; pilotáž potvrdila hlavní hypotézu. Další rozvoj: ověření na SŠ a 1. stupni a na více školách. Kód je otevřený na GitHubu pod organizací edustack-is a k systému jsem připravil doprovodný web is-edustack.org s dokumentací pro učitele. Děkuji za pozornost a rád odpovím na otázky.</a:t>
             </a:r>
             <a:endParaRPr lang="en-US" dirty="0"/>
           </a:p>
@@ -800,7 +800,7 @@
           <a:p>
             <a:fld id="{F7021451-1387-4CA6-816F-3879F97B5CBC}" type="slidenum">
               <a:rPr lang="en-US"/>
-              <a:t>12</a:t>
+              <a:t>11</a:t>
             </a:fld>
             <a:endParaRPr lang="en-US"/>
           </a:p>
@@ -1895,8 +1895,8 @@
         </p:blipFill>
         <p:spPr>
           <a:xfrm>
-            <a:off x="594360" y="1188720"/>
-            <a:ext cx="2103120" cy="2596896"/>
+            <a:off x="990920" y="1764450"/>
+            <a:ext cx="1310000" cy="1614600"/>
           </a:xfrm>
           <a:prstGeom prst="rect">
             <a:avLst/>
@@ -2057,7 +2057,7 @@
                 <a:ea typeface="Calibri" pitchFamily="34" charset="-122"/>
                 <a:cs typeface="Calibri" pitchFamily="34" charset="-120"/>
               </a:rPr>
-              <a:t>Vedoucí: PhDr. Jakub Mazuch · Oponent: PhDr. Martin Beneš, Ph.D.</a:t>
+              <a:t>Vedoucí práce: PhDr. Jakub Mazuch</a:t>
             </a:r>
             <a:endParaRPr lang="en-US" sz="1200" dirty="0"/>
           </a:p>
@@ -2694,6 +2694,15 @@
               </a:rPr>
               <a:t>Limity práce a reakce na posudky</a:t>
             </a:r>
+            <a:r>
+              <a:rPr lang="en-US" sz="1400" b="0" dirty="0">
+                <a:solidFill>
+                  <a:srgbClr val="6B6680"/>
+                </a:solidFill>
+                <a:latin typeface="Calibri" pitchFamily="34" charset="0"/>
+              </a:rPr>
+              <a:t xml:space="preserve">  · doplňující slide k diskusi</a:t>
+            </a:r>
             <a:endParaRPr lang="en-US" sz="3000" dirty="0"/>
           </a:p>
         </p:txBody>
@@ -3126,7 +3135,7 @@
                 <a:ea typeface="Calibri" pitchFamily="34" charset="-122"/>
                 <a:cs typeface="Calibri" pitchFamily="34" charset="-120"/>
               </a:rPr>
-              <a:t>11</a:t>
+              <a:t>12</a:t>
             </a:r>
             <a:endParaRPr lang="en-US" sz="900" dirty="0"/>
           </a:p>
@@ -3256,7 +3265,7 @@
               <a:buChar char="•"/>
             </a:pPr>
             <a:r>
-              <a:rPr lang="en-US" sz="1400" dirty="0">
+              <a:rPr lang="en-US" sz="1300" dirty="0">
                 <a:solidFill>
                   <a:srgbClr val="24203A"/>
                 </a:solidFill>
@@ -3266,7 +3275,7 @@
               </a:rPr>
               <a:t>Vymezena nová kategorie: edukační IS – doménově věrný, otevřený, sandboxový, vícevrstvý</a:t>
             </a:r>
-            <a:endParaRPr lang="en-US" sz="1400" dirty="0"/>
+            <a:endParaRPr lang="en-US" sz="1300" dirty="0"/>
           </a:p>
           <a:p>
             <a:pPr marL="177800" indent="-177800">
@@ -3277,7 +3286,7 @@
               <a:buChar char="•"/>
             </a:pPr>
             <a:r>
-              <a:rPr lang="en-US" sz="1400" dirty="0">
+              <a:rPr lang="en-US" sz="1300" dirty="0">
                 <a:solidFill>
                   <a:srgbClr val="24203A"/>
                 </a:solidFill>
@@ -3287,7 +3296,7 @@
               </a:rPr>
               <a:t>Funkční prototyp Edu Stack IS + tři pracovní listy s klíčem pro učitele + dotazníky</a:t>
             </a:r>
-            <a:endParaRPr lang="en-US" sz="1400" dirty="0"/>
+            <a:endParaRPr lang="en-US" sz="1300" dirty="0"/>
           </a:p>
           <a:p>
             <a:pPr marL="177800" indent="-177800">
@@ -3298,7 +3307,7 @@
               <a:buChar char="•"/>
             </a:pPr>
             <a:r>
-              <a:rPr lang="en-US" sz="1400" dirty="0">
+              <a:rPr lang="en-US" sz="1300" dirty="0">
                 <a:solidFill>
                   <a:srgbClr val="24203A"/>
                 </a:solidFill>
@@ -3308,7 +3317,7 @@
               </a:rPr>
               <a:t>Pilotáž potvrdila: prožitek role vede k pochopení oprávnění; simulace je srozumitelná a motivační</a:t>
             </a:r>
-            <a:endParaRPr lang="en-US" sz="1400" dirty="0"/>
+            <a:endParaRPr lang="en-US" sz="1300" dirty="0"/>
           </a:p>
           <a:p>
             <a:pPr marL="177800" indent="-177800">
@@ -3319,7 +3328,7 @@
               <a:buChar char="•"/>
             </a:pPr>
             <a:r>
-              <a:rPr lang="en-US" sz="1400" dirty="0">
+              <a:rPr lang="en-US" sz="1300" dirty="0">
                 <a:solidFill>
                   <a:srgbClr val="24203A"/>
                 </a:solidFill>
@@ -3329,7 +3338,28 @@
               </a:rPr>
               <a:t>Další rozvoj: pilotáže na SŠ a 1. stupni, více škol, listy k bezpečnosti a GDPR, mobilní rozhraní, komunita učitelů</a:t>
             </a:r>
-            <a:endParaRPr lang="en-US" sz="1400" dirty="0"/>
+            <a:endParaRPr lang="en-US" sz="1300" dirty="0"/>
+          </a:p>
+          <a:p>
+            <a:pPr marL="177800" indent="-177800">
+              <a:spcAft>
+                <a:spcPts val="800"/>
+              </a:spcAft>
+              <a:buSzPct val="100000"/>
+              <a:buChar char="•"/>
+            </a:pPr>
+            <a:r>
+              <a:rPr lang="en-US" sz="1300" dirty="0">
+                <a:solidFill>
+                  <a:srgbClr val="24203A"/>
+                </a:solidFill>
+                <a:latin typeface="Calibri" pitchFamily="34" charset="0"/>
+                <a:ea typeface="Calibri" pitchFamily="34" charset="-122"/>
+                <a:cs typeface="Calibri" pitchFamily="34" charset="-120"/>
+              </a:rPr>
+              <a:t>Kód je otevřený na GitHubu (github.com/edustack-is), k systému vznikl doprovodný web is-edustack.org</a:t>
+            </a:r>
+            <a:endParaRPr lang="en-US" sz="1300" dirty="0"/>
           </a:p>
         </p:txBody>
       </p:sp>
@@ -3471,7 +3501,7 @@
                 <a:ea typeface="Calibri" pitchFamily="34" charset="-122"/>
                 <a:cs typeface="Calibri" pitchFamily="34" charset="-120"/>
               </a:rPr>
-              <a:t>12</a:t>
+              <a:t>11</a:t>
             </a:r>
             <a:endParaRPr lang="en-US" sz="900" dirty="0"/>
           </a:p>

</xml_diff>

<commit_message>
PPTX: Závěr a Limity prohozeny i fyzicky v souborech slidů (slide11 = Závěr, slide12 = Limity)
Co-Authored-By: Claude Fable 5.1 <noreply@anthropic.com>
</commit_message>
<xml_diff>
--- a/obhajoba-edustack.pptx
+++ b/obhajoba-edustack.pptx
@@ -15,8 +15,8 @@
     <p:sldId id="263" r:id="rId9"/>
     <p:sldId id="264" r:id="rId10"/>
     <p:sldId id="265" r:id="rId11"/>
+    <p:sldId id="266" r:id="rId12"/>
     <p:sldId id="267" r:id="rId13"/>
-    <p:sldId id="266" r:id="rId12"/>
   </p:sldIdLst>
   <p:notesMasterIdLst>
     <p:notesMasterId r:id="rId14"/>
@@ -689,7 +689,7 @@
           <a:p>
             <a:r>
               <a:rPr lang="en-US" dirty="0"/>
-              <a:t>Otevřeně k limitům – vedoucí je pojmenoval přesně. (1) Ověření jen na 2. stupni; SŠ pilotáž bych vedl na odborné škole s 3. listem a přesně popsal vzorek a podmínky. (2) Kurikulární analýza – pracoval jsem hlavně s RVP ZV, gymnaziální a odborné kurikulum si zaslouží samostatné zpracování. (3) Dotazník nebyl standardizovaný v metodologickém smyslu – správně 'vlastní strukturovaný'. (4) Rozpor v popisu MCP: autorizaci vynucuje backend – MCP nástroj volá REST API s oprávněními uživatele dané relace, MCP vrstva sama guard nemá. Formulaci v klíči listu sjednotím.</a:t>
+              <a:t>Shrnutí: vymezil jsem kategorii edukačních IS, postavil prototyp s metodikou a ověřil ho ve výuce; pilotáž potvrdila hlavní hypotézu. Další rozvoj: ověření na SŠ a 1. stupni a na více školách. Kód je otevřený na GitHubu pod organizací edustack-is a k systému jsem připravil doprovodný web is-edustack.org s dokumentací pro učitele. Děkuji za pozornost a rád odpovím na otázky.</a:t>
             </a:r>
             <a:endParaRPr lang="en-US" dirty="0"/>
           </a:p>
@@ -712,7 +712,7 @@
           <a:p>
             <a:fld id="{F7021451-1387-4CA6-816F-3879F97B5CBC}" type="slidenum">
               <a:rPr lang="en-US"/>
-              <a:t>12</a:t>
+              <a:t>11</a:t>
             </a:fld>
             <a:endParaRPr lang="en-US"/>
           </a:p>
@@ -777,7 +777,7 @@
           <a:p>
             <a:r>
               <a:rPr lang="en-US" dirty="0"/>
-              <a:t>Shrnutí: vymezil jsem kategorii edukačních IS, postavil prototyp s metodikou a ověřil ho ve výuce; pilotáž potvrdila hlavní hypotézu. Další rozvoj: ověření na SŠ a 1. stupni a na více školách. Kód je otevřený na GitHubu pod organizací edustack-is a k systému jsem připravil doprovodný web is-edustack.org s dokumentací pro učitele. Děkuji za pozornost a rád odpovím na otázky.</a:t>
+              <a:t>Otevřeně k limitům – vedoucí je pojmenoval přesně. (1) Ověření jen na 2. stupni; SŠ pilotáž bych vedl na odborné škole s 3. listem a přesně popsal vzorek a podmínky. (2) Kurikulární analýza – pracoval jsem hlavně s RVP ZV, gymnaziální a odborné kurikulum si zaslouží samostatné zpracování. (3) Dotazník nebyl standardizovaný v metodologickém smyslu – správně 'vlastní strukturovaný'. (4) Rozpor v popisu MCP: autorizaci vynucuje backend – MCP nástroj volá REST API s oprávněními uživatele dané relace, MCP vrstva sama guard nemá. Formulaci v klíči listu sjednotím.</a:t>
             </a:r>
             <a:endParaRPr lang="en-US" dirty="0"/>
           </a:p>
@@ -800,7 +800,7 @@
           <a:p>
             <a:fld id="{F7021451-1387-4CA6-816F-3879F97B5CBC}" type="slidenum">
               <a:rPr lang="en-US"/>
-              <a:t>11</a:t>
+              <a:t>12</a:t>
             </a:fld>
             <a:endParaRPr lang="en-US"/>
           </a:p>
@@ -2637,6 +2637,372 @@
 
 <file path=ppt/slides/slide11.xml><?xml version="1.0" encoding="utf-8"?>
 <p:sld xmlns:a="http://schemas.openxmlformats.org/drawingml/2006/main" xmlns:r="http://schemas.openxmlformats.org/officeDocument/2006/relationships" xmlns:p="http://schemas.openxmlformats.org/presentationml/2006/main">
+  <p:cSld name="Slide 12">
+    <p:bg>
+      <p:bgPr>
+        <a:solidFill>
+          <a:srgbClr val="FFFFFF"/>
+        </a:solidFill>
+      </p:bgPr>
+    </p:bg>
+    <p:spTree>
+      <p:nvGrpSpPr>
+        <p:cNvPr id="1" name=""/>
+        <p:cNvGrpSpPr/>
+        <p:nvPr/>
+      </p:nvGrpSpPr>
+      <p:grpSpPr>
+        <a:xfrm>
+          <a:off x="0" y="0"/>
+          <a:ext cx="0" cy="0"/>
+          <a:chOff x="0" y="0"/>
+          <a:chExt cx="0" cy="0"/>
+        </a:xfrm>
+      </p:grpSpPr>
+      <p:sp>
+        <p:nvSpPr>
+          <p:cNvPr id="2" name="Text 0"/>
+          <p:cNvSpPr txBox="1"/>
+          <p:nvPr/>
+        </p:nvSpPr>
+        <p:spPr>
+          <a:xfrm>
+            <a:off x="548640" y="320040"/>
+            <a:ext cx="8046720" cy="640080"/>
+          </a:xfrm>
+          <a:prstGeom prst="rect">
+            <a:avLst/>
+          </a:prstGeom>
+          <a:noFill/>
+          <a:ln/>
+        </p:spPr>
+        <p:txBody>
+          <a:bodyPr wrap="square" lIns="0" tIns="0" rIns="0" bIns="0" rtlCol="0" anchor="ctr"/>
+          <a:lstStyle/>
+          <a:p>
+            <a:pPr indent="0" marL="0">
+              <a:buNone/>
+            </a:pPr>
+            <a:r>
+              <a:rPr lang="en-US" sz="3000" b="1" dirty="0">
+                <a:solidFill>
+                  <a:srgbClr val="3F2A78"/>
+                </a:solidFill>
+                <a:latin typeface="Calibri" pitchFamily="34" charset="0"/>
+                <a:ea typeface="Calibri" pitchFamily="34" charset="-122"/>
+                <a:cs typeface="Calibri" pitchFamily="34" charset="-120"/>
+              </a:rPr>
+              <a:t>Závěr</a:t>
+            </a:r>
+            <a:endParaRPr lang="en-US" sz="3000" dirty="0"/>
+          </a:p>
+        </p:txBody>
+      </p:sp>
+      <p:pic>
+        <p:nvPicPr>
+          <p:cNvPr id="3" name="Image 0" descr="logo.png">    </p:cNvPr>
+          <p:cNvPicPr>
+            <a:picLocks noChangeAspect="1"/>
+          </p:cNvPicPr>
+          <p:nvPr/>
+        </p:nvPicPr>
+        <p:blipFill>
+          <a:blip r:embed="rId1"/>
+          <a:stretch>
+            <a:fillRect/>
+          </a:stretch>
+        </p:blipFill>
+        <p:spPr>
+          <a:xfrm>
+            <a:off x="6766560" y="1188720"/>
+            <a:ext cx="1737360" cy="2139696"/>
+          </a:xfrm>
+          <a:prstGeom prst="rect">
+            <a:avLst/>
+          </a:prstGeom>
+        </p:spPr>
+      </p:pic>
+      <p:sp>
+        <p:nvSpPr>
+          <p:cNvPr id="4" name="Text 1"/>
+          <p:cNvSpPr txBox="1"/>
+          <p:nvPr/>
+        </p:nvSpPr>
+        <p:spPr>
+          <a:xfrm>
+            <a:off x="548640" y="1188720"/>
+            <a:ext cx="5943600" cy="2468880"/>
+          </a:xfrm>
+          <a:prstGeom prst="rect">
+            <a:avLst/>
+          </a:prstGeom>
+          <a:noFill/>
+          <a:ln/>
+        </p:spPr>
+        <p:txBody>
+          <a:bodyPr wrap="square" lIns="0" tIns="0" rIns="0" bIns="0" rtlCol="0" anchor="t"/>
+          <a:lstStyle/>
+          <a:p>
+            <a:pPr marL="177800" indent="-177800">
+              <a:spcAft>
+                <a:spcPts val="800"/>
+              </a:spcAft>
+              <a:buSzPct val="100000"/>
+              <a:buChar char="•"/>
+            </a:pPr>
+            <a:r>
+              <a:rPr lang="en-US" sz="1300" dirty="0">
+                <a:solidFill>
+                  <a:srgbClr val="24203A"/>
+                </a:solidFill>
+                <a:latin typeface="Calibri" pitchFamily="34" charset="0"/>
+                <a:ea typeface="Calibri" pitchFamily="34" charset="-122"/>
+                <a:cs typeface="Calibri" pitchFamily="34" charset="-120"/>
+              </a:rPr>
+              <a:t>Vymezena nová kategorie: edukační IS – doménově věrný, otevřený, sandboxový, vícevrstvý</a:t>
+            </a:r>
+            <a:endParaRPr lang="en-US" sz="1300" dirty="0"/>
+          </a:p>
+          <a:p>
+            <a:pPr marL="177800" indent="-177800">
+              <a:spcAft>
+                <a:spcPts val="800"/>
+              </a:spcAft>
+              <a:buSzPct val="100000"/>
+              <a:buChar char="•"/>
+            </a:pPr>
+            <a:r>
+              <a:rPr lang="en-US" sz="1300" dirty="0">
+                <a:solidFill>
+                  <a:srgbClr val="24203A"/>
+                </a:solidFill>
+                <a:latin typeface="Calibri" pitchFamily="34" charset="0"/>
+                <a:ea typeface="Calibri" pitchFamily="34" charset="-122"/>
+                <a:cs typeface="Calibri" pitchFamily="34" charset="-120"/>
+              </a:rPr>
+              <a:t>Funkční prototyp Edu Stack IS + tři pracovní listy s klíčem pro učitele + dotazníky</a:t>
+            </a:r>
+            <a:endParaRPr lang="en-US" sz="1300" dirty="0"/>
+          </a:p>
+          <a:p>
+            <a:pPr marL="177800" indent="-177800">
+              <a:spcAft>
+                <a:spcPts val="800"/>
+              </a:spcAft>
+              <a:buSzPct val="100000"/>
+              <a:buChar char="•"/>
+            </a:pPr>
+            <a:r>
+              <a:rPr lang="en-US" sz="1300" dirty="0">
+                <a:solidFill>
+                  <a:srgbClr val="24203A"/>
+                </a:solidFill>
+                <a:latin typeface="Calibri" pitchFamily="34" charset="0"/>
+                <a:ea typeface="Calibri" pitchFamily="34" charset="-122"/>
+                <a:cs typeface="Calibri" pitchFamily="34" charset="-120"/>
+              </a:rPr>
+              <a:t>Pilotáž potvrdila: prožitek role vede k pochopení oprávnění; simulace je srozumitelná a motivační</a:t>
+            </a:r>
+            <a:endParaRPr lang="en-US" sz="1300" dirty="0"/>
+          </a:p>
+          <a:p>
+            <a:pPr marL="177800" indent="-177800">
+              <a:spcAft>
+                <a:spcPts val="800"/>
+              </a:spcAft>
+              <a:buSzPct val="100000"/>
+              <a:buChar char="•"/>
+            </a:pPr>
+            <a:r>
+              <a:rPr lang="en-US" sz="1300" dirty="0">
+                <a:solidFill>
+                  <a:srgbClr val="24203A"/>
+                </a:solidFill>
+                <a:latin typeface="Calibri" pitchFamily="34" charset="0"/>
+                <a:ea typeface="Calibri" pitchFamily="34" charset="-122"/>
+                <a:cs typeface="Calibri" pitchFamily="34" charset="-120"/>
+              </a:rPr>
+              <a:t>Další rozvoj: pilotáže na SŠ a 1. stupni, více škol, listy k bezpečnosti a GDPR, mobilní rozhraní, komunita učitelů</a:t>
+            </a:r>
+            <a:endParaRPr lang="en-US" sz="1300" dirty="0"/>
+          </a:p>
+          <a:p>
+            <a:pPr marL="177800" indent="-177800">
+              <a:spcAft>
+                <a:spcPts val="800"/>
+              </a:spcAft>
+              <a:buSzPct val="100000"/>
+              <a:buChar char="•"/>
+            </a:pPr>
+            <a:r>
+              <a:rPr lang="en-US" sz="1300" dirty="0">
+                <a:solidFill>
+                  <a:srgbClr val="24203A"/>
+                </a:solidFill>
+                <a:latin typeface="Calibri" pitchFamily="34" charset="0"/>
+                <a:ea typeface="Calibri" pitchFamily="34" charset="-122"/>
+                <a:cs typeface="Calibri" pitchFamily="34" charset="-120"/>
+              </a:rPr>
+              <a:t>Kód je otevřený na GitHubu (github.com/edustack-is), k systému vznikl doprovodný web is-edustack.org</a:t>
+            </a:r>
+            <a:endParaRPr lang="en-US" sz="1300" dirty="0"/>
+          </a:p>
+        </p:txBody>
+      </p:sp>
+      <p:sp>
+        <p:nvSpPr>
+          <p:cNvPr id="5" name="Shape 2"/>
+          <p:cNvSpPr/>
+          <p:nvPr/>
+        </p:nvSpPr>
+        <p:spPr>
+          <a:xfrm>
+            <a:off x="548640" y="3794760"/>
+            <a:ext cx="8046720" cy="777240"/>
+          </a:xfrm>
+          <a:prstGeom prst="roundRect">
+            <a:avLst>
+              <a:gd name="adj" fmla="val 11765"/>
+            </a:avLst>
+          </a:prstGeom>
+          <a:solidFill>
+            <a:srgbClr val="3F2A78"/>
+          </a:solidFill>
+          <a:ln w="12700">
+            <a:solidFill>
+              <a:srgbClr val="3F2A78"/>
+            </a:solidFill>
+            <a:prstDash val="solid"/>
+          </a:ln>
+        </p:spPr>
+      </p:sp>
+      <p:sp>
+        <p:nvSpPr>
+          <p:cNvPr id="6" name="Text 3"/>
+          <p:cNvSpPr txBox="1"/>
+          <p:nvPr/>
+        </p:nvSpPr>
+        <p:spPr>
+          <a:xfrm>
+            <a:off x="731520" y="3794760"/>
+            <a:ext cx="7680960" cy="777240"/>
+          </a:xfrm>
+          <a:prstGeom prst="rect">
+            <a:avLst/>
+          </a:prstGeom>
+          <a:noFill/>
+          <a:ln/>
+        </p:spPr>
+        <p:txBody>
+          <a:bodyPr wrap="square" lIns="0" tIns="0" rIns="0" bIns="0" rtlCol="0" anchor="ctr"/>
+          <a:lstStyle/>
+          <a:p>
+            <a:pPr indent="0" marL="0">
+              <a:buNone/>
+            </a:pPr>
+            <a:r>
+              <a:rPr lang="en-US" sz="1300" dirty="0">
+                <a:solidFill>
+                  <a:srgbClr val="FFFFFF"/>
+                </a:solidFill>
+                <a:latin typeface="Calibri" pitchFamily="34" charset="0"/>
+                <a:ea typeface="Calibri" pitchFamily="34" charset="-122"/>
+                <a:cs typeface="Calibri" pitchFamily="34" charset="-120"/>
+              </a:rPr>
+              <a:t>Děkuji za pozornost. Informační systém nemusí být ve škole jen administrativní nutnost – může být pomůckou, na které si žák digitální svět sám postaví.</a:t>
+            </a:r>
+            <a:endParaRPr lang="en-US" sz="1300" dirty="0"/>
+          </a:p>
+        </p:txBody>
+      </p:sp>
+      <p:sp>
+        <p:nvSpPr>
+          <p:cNvPr id="7" name="Text 4"/>
+          <p:cNvSpPr txBox="1"/>
+          <p:nvPr/>
+        </p:nvSpPr>
+        <p:spPr>
+          <a:xfrm>
+            <a:off x="548640" y="4754880"/>
+            <a:ext cx="5486400" cy="274320"/>
+          </a:xfrm>
+          <a:prstGeom prst="rect">
+            <a:avLst/>
+          </a:prstGeom>
+          <a:noFill/>
+          <a:ln/>
+        </p:spPr>
+        <p:txBody>
+          <a:bodyPr wrap="square" lIns="0" tIns="0" rIns="0" bIns="0" rtlCol="0" anchor="ctr"/>
+          <a:lstStyle/>
+          <a:p>
+            <a:pPr indent="0" marL="0">
+              <a:buNone/>
+            </a:pPr>
+            <a:r>
+              <a:rPr lang="en-US" sz="900" dirty="0">
+                <a:solidFill>
+                  <a:srgbClr val="6B6680"/>
+                </a:solidFill>
+                <a:latin typeface="Calibri" pitchFamily="34" charset="0"/>
+                <a:ea typeface="Calibri" pitchFamily="34" charset="-122"/>
+                <a:cs typeface="Calibri" pitchFamily="34" charset="-120"/>
+              </a:rPr>
+              <a:t>Edu Stack IS · Obhajoba bakalářské práce · Petr Vích</a:t>
+            </a:r>
+            <a:endParaRPr lang="en-US" sz="900" dirty="0"/>
+          </a:p>
+        </p:txBody>
+      </p:sp>
+      <p:sp>
+        <p:nvSpPr>
+          <p:cNvPr id="8" name="Text 5"/>
+          <p:cNvSpPr txBox="1"/>
+          <p:nvPr/>
+        </p:nvSpPr>
+        <p:spPr>
+          <a:xfrm>
+            <a:off x="8138160" y="4754880"/>
+            <a:ext cx="457200" cy="274320"/>
+          </a:xfrm>
+          <a:prstGeom prst="rect">
+            <a:avLst/>
+          </a:prstGeom>
+          <a:noFill/>
+          <a:ln/>
+        </p:spPr>
+        <p:txBody>
+          <a:bodyPr wrap="square" lIns="0" tIns="0" rIns="0" bIns="0" rtlCol="0" anchor="ctr"/>
+          <a:lstStyle/>
+          <a:p>
+            <a:pPr algn="r" indent="0" marL="0">
+              <a:buNone/>
+            </a:pPr>
+            <a:r>
+              <a:rPr lang="en-US" sz="900" dirty="0">
+                <a:solidFill>
+                  <a:srgbClr val="6B6680"/>
+                </a:solidFill>
+                <a:latin typeface="Calibri" pitchFamily="34" charset="0"/>
+                <a:ea typeface="Calibri" pitchFamily="34" charset="-122"/>
+                <a:cs typeface="Calibri" pitchFamily="34" charset="-120"/>
+              </a:rPr>
+              <a:t>11</a:t>
+            </a:r>
+            <a:endParaRPr lang="en-US" sz="900" dirty="0"/>
+          </a:p>
+        </p:txBody>
+      </p:sp>
+    </p:spTree>
+  </p:cSld>
+  <p:clrMapOvr>
+    <a:masterClrMapping/>
+  </p:clrMapOvr>
+</p:sld>
+</file>
+
+<file path=ppt/slides/slide12.xml><?xml version="1.0" encoding="utf-8"?>
+<p:sld xmlns:a="http://schemas.openxmlformats.org/drawingml/2006/main" xmlns:r="http://schemas.openxmlformats.org/officeDocument/2006/relationships" xmlns:p="http://schemas.openxmlformats.org/presentationml/2006/main">
   <p:cSld name="Slide 11">
     <p:bg>
       <p:bgPr>
@@ -3136,372 +3502,6 @@
                 <a:cs typeface="Calibri" pitchFamily="34" charset="-120"/>
               </a:rPr>
               <a:t>12</a:t>
-            </a:r>
-            <a:endParaRPr lang="en-US" sz="900" dirty="0"/>
-          </a:p>
-        </p:txBody>
-      </p:sp>
-    </p:spTree>
-  </p:cSld>
-  <p:clrMapOvr>
-    <a:masterClrMapping/>
-  </p:clrMapOvr>
-</p:sld>
-</file>
-
-<file path=ppt/slides/slide12.xml><?xml version="1.0" encoding="utf-8"?>
-<p:sld xmlns:a="http://schemas.openxmlformats.org/drawingml/2006/main" xmlns:r="http://schemas.openxmlformats.org/officeDocument/2006/relationships" xmlns:p="http://schemas.openxmlformats.org/presentationml/2006/main">
-  <p:cSld name="Slide 12">
-    <p:bg>
-      <p:bgPr>
-        <a:solidFill>
-          <a:srgbClr val="FFFFFF"/>
-        </a:solidFill>
-      </p:bgPr>
-    </p:bg>
-    <p:spTree>
-      <p:nvGrpSpPr>
-        <p:cNvPr id="1" name=""/>
-        <p:cNvGrpSpPr/>
-        <p:nvPr/>
-      </p:nvGrpSpPr>
-      <p:grpSpPr>
-        <a:xfrm>
-          <a:off x="0" y="0"/>
-          <a:ext cx="0" cy="0"/>
-          <a:chOff x="0" y="0"/>
-          <a:chExt cx="0" cy="0"/>
-        </a:xfrm>
-      </p:grpSpPr>
-      <p:sp>
-        <p:nvSpPr>
-          <p:cNvPr id="2" name="Text 0"/>
-          <p:cNvSpPr txBox="1"/>
-          <p:nvPr/>
-        </p:nvSpPr>
-        <p:spPr>
-          <a:xfrm>
-            <a:off x="548640" y="320040"/>
-            <a:ext cx="8046720" cy="640080"/>
-          </a:xfrm>
-          <a:prstGeom prst="rect">
-            <a:avLst/>
-          </a:prstGeom>
-          <a:noFill/>
-          <a:ln/>
-        </p:spPr>
-        <p:txBody>
-          <a:bodyPr wrap="square" lIns="0" tIns="0" rIns="0" bIns="0" rtlCol="0" anchor="ctr"/>
-          <a:lstStyle/>
-          <a:p>
-            <a:pPr indent="0" marL="0">
-              <a:buNone/>
-            </a:pPr>
-            <a:r>
-              <a:rPr lang="en-US" sz="3000" b="1" dirty="0">
-                <a:solidFill>
-                  <a:srgbClr val="3F2A78"/>
-                </a:solidFill>
-                <a:latin typeface="Calibri" pitchFamily="34" charset="0"/>
-                <a:ea typeface="Calibri" pitchFamily="34" charset="-122"/>
-                <a:cs typeface="Calibri" pitchFamily="34" charset="-120"/>
-              </a:rPr>
-              <a:t>Závěr</a:t>
-            </a:r>
-            <a:endParaRPr lang="en-US" sz="3000" dirty="0"/>
-          </a:p>
-        </p:txBody>
-      </p:sp>
-      <p:pic>
-        <p:nvPicPr>
-          <p:cNvPr id="3" name="Image 0" descr="logo.png">    </p:cNvPr>
-          <p:cNvPicPr>
-            <a:picLocks noChangeAspect="1"/>
-          </p:cNvPicPr>
-          <p:nvPr/>
-        </p:nvPicPr>
-        <p:blipFill>
-          <a:blip r:embed="rId1"/>
-          <a:stretch>
-            <a:fillRect/>
-          </a:stretch>
-        </p:blipFill>
-        <p:spPr>
-          <a:xfrm>
-            <a:off x="6766560" y="1188720"/>
-            <a:ext cx="1737360" cy="2139696"/>
-          </a:xfrm>
-          <a:prstGeom prst="rect">
-            <a:avLst/>
-          </a:prstGeom>
-        </p:spPr>
-      </p:pic>
-      <p:sp>
-        <p:nvSpPr>
-          <p:cNvPr id="4" name="Text 1"/>
-          <p:cNvSpPr txBox="1"/>
-          <p:nvPr/>
-        </p:nvSpPr>
-        <p:spPr>
-          <a:xfrm>
-            <a:off x="548640" y="1188720"/>
-            <a:ext cx="5943600" cy="2468880"/>
-          </a:xfrm>
-          <a:prstGeom prst="rect">
-            <a:avLst/>
-          </a:prstGeom>
-          <a:noFill/>
-          <a:ln/>
-        </p:spPr>
-        <p:txBody>
-          <a:bodyPr wrap="square" lIns="0" tIns="0" rIns="0" bIns="0" rtlCol="0" anchor="t"/>
-          <a:lstStyle/>
-          <a:p>
-            <a:pPr marL="177800" indent="-177800">
-              <a:spcAft>
-                <a:spcPts val="800"/>
-              </a:spcAft>
-              <a:buSzPct val="100000"/>
-              <a:buChar char="•"/>
-            </a:pPr>
-            <a:r>
-              <a:rPr lang="en-US" sz="1300" dirty="0">
-                <a:solidFill>
-                  <a:srgbClr val="24203A"/>
-                </a:solidFill>
-                <a:latin typeface="Calibri" pitchFamily="34" charset="0"/>
-                <a:ea typeface="Calibri" pitchFamily="34" charset="-122"/>
-                <a:cs typeface="Calibri" pitchFamily="34" charset="-120"/>
-              </a:rPr>
-              <a:t>Vymezena nová kategorie: edukační IS – doménově věrný, otevřený, sandboxový, vícevrstvý</a:t>
-            </a:r>
-            <a:endParaRPr lang="en-US" sz="1300" dirty="0"/>
-          </a:p>
-          <a:p>
-            <a:pPr marL="177800" indent="-177800">
-              <a:spcAft>
-                <a:spcPts val="800"/>
-              </a:spcAft>
-              <a:buSzPct val="100000"/>
-              <a:buChar char="•"/>
-            </a:pPr>
-            <a:r>
-              <a:rPr lang="en-US" sz="1300" dirty="0">
-                <a:solidFill>
-                  <a:srgbClr val="24203A"/>
-                </a:solidFill>
-                <a:latin typeface="Calibri" pitchFamily="34" charset="0"/>
-                <a:ea typeface="Calibri" pitchFamily="34" charset="-122"/>
-                <a:cs typeface="Calibri" pitchFamily="34" charset="-120"/>
-              </a:rPr>
-              <a:t>Funkční prototyp Edu Stack IS + tři pracovní listy s klíčem pro učitele + dotazníky</a:t>
-            </a:r>
-            <a:endParaRPr lang="en-US" sz="1300" dirty="0"/>
-          </a:p>
-          <a:p>
-            <a:pPr marL="177800" indent="-177800">
-              <a:spcAft>
-                <a:spcPts val="800"/>
-              </a:spcAft>
-              <a:buSzPct val="100000"/>
-              <a:buChar char="•"/>
-            </a:pPr>
-            <a:r>
-              <a:rPr lang="en-US" sz="1300" dirty="0">
-                <a:solidFill>
-                  <a:srgbClr val="24203A"/>
-                </a:solidFill>
-                <a:latin typeface="Calibri" pitchFamily="34" charset="0"/>
-                <a:ea typeface="Calibri" pitchFamily="34" charset="-122"/>
-                <a:cs typeface="Calibri" pitchFamily="34" charset="-120"/>
-              </a:rPr>
-              <a:t>Pilotáž potvrdila: prožitek role vede k pochopení oprávnění; simulace je srozumitelná a motivační</a:t>
-            </a:r>
-            <a:endParaRPr lang="en-US" sz="1300" dirty="0"/>
-          </a:p>
-          <a:p>
-            <a:pPr marL="177800" indent="-177800">
-              <a:spcAft>
-                <a:spcPts val="800"/>
-              </a:spcAft>
-              <a:buSzPct val="100000"/>
-              <a:buChar char="•"/>
-            </a:pPr>
-            <a:r>
-              <a:rPr lang="en-US" sz="1300" dirty="0">
-                <a:solidFill>
-                  <a:srgbClr val="24203A"/>
-                </a:solidFill>
-                <a:latin typeface="Calibri" pitchFamily="34" charset="0"/>
-                <a:ea typeface="Calibri" pitchFamily="34" charset="-122"/>
-                <a:cs typeface="Calibri" pitchFamily="34" charset="-120"/>
-              </a:rPr>
-              <a:t>Další rozvoj: pilotáže na SŠ a 1. stupni, více škol, listy k bezpečnosti a GDPR, mobilní rozhraní, komunita učitelů</a:t>
-            </a:r>
-            <a:endParaRPr lang="en-US" sz="1300" dirty="0"/>
-          </a:p>
-          <a:p>
-            <a:pPr marL="177800" indent="-177800">
-              <a:spcAft>
-                <a:spcPts val="800"/>
-              </a:spcAft>
-              <a:buSzPct val="100000"/>
-              <a:buChar char="•"/>
-            </a:pPr>
-            <a:r>
-              <a:rPr lang="en-US" sz="1300" dirty="0">
-                <a:solidFill>
-                  <a:srgbClr val="24203A"/>
-                </a:solidFill>
-                <a:latin typeface="Calibri" pitchFamily="34" charset="0"/>
-                <a:ea typeface="Calibri" pitchFamily="34" charset="-122"/>
-                <a:cs typeface="Calibri" pitchFamily="34" charset="-120"/>
-              </a:rPr>
-              <a:t>Kód je otevřený na GitHubu (github.com/edustack-is), k systému vznikl doprovodný web is-edustack.org</a:t>
-            </a:r>
-            <a:endParaRPr lang="en-US" sz="1300" dirty="0"/>
-          </a:p>
-        </p:txBody>
-      </p:sp>
-      <p:sp>
-        <p:nvSpPr>
-          <p:cNvPr id="5" name="Shape 2"/>
-          <p:cNvSpPr/>
-          <p:nvPr/>
-        </p:nvSpPr>
-        <p:spPr>
-          <a:xfrm>
-            <a:off x="548640" y="3794760"/>
-            <a:ext cx="8046720" cy="777240"/>
-          </a:xfrm>
-          <a:prstGeom prst="roundRect">
-            <a:avLst>
-              <a:gd name="adj" fmla="val 11765"/>
-            </a:avLst>
-          </a:prstGeom>
-          <a:solidFill>
-            <a:srgbClr val="3F2A78"/>
-          </a:solidFill>
-          <a:ln w="12700">
-            <a:solidFill>
-              <a:srgbClr val="3F2A78"/>
-            </a:solidFill>
-            <a:prstDash val="solid"/>
-          </a:ln>
-        </p:spPr>
-      </p:sp>
-      <p:sp>
-        <p:nvSpPr>
-          <p:cNvPr id="6" name="Text 3"/>
-          <p:cNvSpPr txBox="1"/>
-          <p:nvPr/>
-        </p:nvSpPr>
-        <p:spPr>
-          <a:xfrm>
-            <a:off x="731520" y="3794760"/>
-            <a:ext cx="7680960" cy="777240"/>
-          </a:xfrm>
-          <a:prstGeom prst="rect">
-            <a:avLst/>
-          </a:prstGeom>
-          <a:noFill/>
-          <a:ln/>
-        </p:spPr>
-        <p:txBody>
-          <a:bodyPr wrap="square" lIns="0" tIns="0" rIns="0" bIns="0" rtlCol="0" anchor="ctr"/>
-          <a:lstStyle/>
-          <a:p>
-            <a:pPr indent="0" marL="0">
-              <a:buNone/>
-            </a:pPr>
-            <a:r>
-              <a:rPr lang="en-US" sz="1300" dirty="0">
-                <a:solidFill>
-                  <a:srgbClr val="FFFFFF"/>
-                </a:solidFill>
-                <a:latin typeface="Calibri" pitchFamily="34" charset="0"/>
-                <a:ea typeface="Calibri" pitchFamily="34" charset="-122"/>
-                <a:cs typeface="Calibri" pitchFamily="34" charset="-120"/>
-              </a:rPr>
-              <a:t>Děkuji za pozornost. Informační systém nemusí být ve škole jen administrativní nutnost – může být pomůckou, na které si žák digitální svět sám postaví.</a:t>
-            </a:r>
-            <a:endParaRPr lang="en-US" sz="1300" dirty="0"/>
-          </a:p>
-        </p:txBody>
-      </p:sp>
-      <p:sp>
-        <p:nvSpPr>
-          <p:cNvPr id="7" name="Text 4"/>
-          <p:cNvSpPr txBox="1"/>
-          <p:nvPr/>
-        </p:nvSpPr>
-        <p:spPr>
-          <a:xfrm>
-            <a:off x="548640" y="4754880"/>
-            <a:ext cx="5486400" cy="274320"/>
-          </a:xfrm>
-          <a:prstGeom prst="rect">
-            <a:avLst/>
-          </a:prstGeom>
-          <a:noFill/>
-          <a:ln/>
-        </p:spPr>
-        <p:txBody>
-          <a:bodyPr wrap="square" lIns="0" tIns="0" rIns="0" bIns="0" rtlCol="0" anchor="ctr"/>
-          <a:lstStyle/>
-          <a:p>
-            <a:pPr indent="0" marL="0">
-              <a:buNone/>
-            </a:pPr>
-            <a:r>
-              <a:rPr lang="en-US" sz="900" dirty="0">
-                <a:solidFill>
-                  <a:srgbClr val="6B6680"/>
-                </a:solidFill>
-                <a:latin typeface="Calibri" pitchFamily="34" charset="0"/>
-                <a:ea typeface="Calibri" pitchFamily="34" charset="-122"/>
-                <a:cs typeface="Calibri" pitchFamily="34" charset="-120"/>
-              </a:rPr>
-              <a:t>Edu Stack IS · Obhajoba bakalářské práce · Petr Vích</a:t>
-            </a:r>
-            <a:endParaRPr lang="en-US" sz="900" dirty="0"/>
-          </a:p>
-        </p:txBody>
-      </p:sp>
-      <p:sp>
-        <p:nvSpPr>
-          <p:cNvPr id="8" name="Text 5"/>
-          <p:cNvSpPr txBox="1"/>
-          <p:nvPr/>
-        </p:nvSpPr>
-        <p:spPr>
-          <a:xfrm>
-            <a:off x="8138160" y="4754880"/>
-            <a:ext cx="457200" cy="274320"/>
-          </a:xfrm>
-          <a:prstGeom prst="rect">
-            <a:avLst/>
-          </a:prstGeom>
-          <a:noFill/>
-          <a:ln/>
-        </p:spPr>
-        <p:txBody>
-          <a:bodyPr wrap="square" lIns="0" tIns="0" rIns="0" bIns="0" rtlCol="0" anchor="ctr"/>
-          <a:lstStyle/>
-          <a:p>
-            <a:pPr algn="r" indent="0" marL="0">
-              <a:buNone/>
-            </a:pPr>
-            <a:r>
-              <a:rPr lang="en-US" sz="900" dirty="0">
-                <a:solidFill>
-                  <a:srgbClr val="6B6680"/>
-                </a:solidFill>
-                <a:latin typeface="Calibri" pitchFamily="34" charset="0"/>
-                <a:ea typeface="Calibri" pitchFamily="34" charset="-122"/>
-                <a:cs typeface="Calibri" pitchFamily="34" charset="-120"/>
-              </a:rPr>
-              <a:t>11</a:t>
             </a:r>
             <a:endParaRPr lang="en-US" sz="900" dirty="0"/>
           </a:p>

</xml_diff>

<commit_message>
Úpravy slidů 1–9 podle zpětné vazby, nový slide o jednom nástroji
- titulní strana: celý název studijního programu, datum na samostatném řádku
- slide 3: konkrétní nástroje a čtyři kritéria, návrh prototypu v bodech, předpoklad místo výzkumné otázky
- slide 4: nový nadpis „Nejde o software, jde o to, co se na něm žák naučí“, žebřík podle rolí žáka
- nový slide 5 „Jeden nástroj pro všechny fáze učení“ – porovnání výukových nástrojů, nižší kognitivní zátěž
- pořadí bloku principů: didaktika, jeden nástroj, jeden systém, chyba (13 slidů, Limity doplňující)
- slide 7: cvičná škola na pár kliků, stovky záznamů, oddělený datový prostor pro každou školu
- slide 8: role Žák = nejnižší role: co smím vidět a co ne
- slide 9: návěští Nasazení a Bezpečnost
- kartičky (17 karet, 5 stran), osnova, scénář a rozcestník přečíslované a sladěné
- web: čísla slidů v patičce generovaná automaticky
- PPTX a PDF přestavěné, PPTX validováno

Co-Authored-By: Claude Fable 5.1 <noreply@anthropic.com>
</commit_message>
<xml_diff>
--- a/obhajoba-edustack.pptx
+++ b/obhajoba-edustack.pptx
@@ -9,8 +9,9 @@
     <p:sldId id="257" r:id="rId3"/>
     <p:sldId id="258" r:id="rId4"/>
     <p:sldId id="259" r:id="rId5"/>
+    <p:sldId id="268" r:id="rId19"/>
+    <p:sldId id="261" r:id="rId7"/>
     <p:sldId id="260" r:id="rId6"/>
-    <p:sldId id="261" r:id="rId7"/>
     <p:sldId id="262" r:id="rId8"/>
     <p:sldId id="263" r:id="rId9"/>
     <p:sldId id="264" r:id="rId10"/>
@@ -624,7 +625,7 @@
           <a:p>
             <a:fld id="{F7021451-1387-4CA6-816F-3879F97B5CBC}" type="slidenum">
               <a:rPr lang="en-US"/>
-              <a:t>10</a:t>
+              <a:t>11</a:t>
             </a:fld>
             <a:endParaRPr lang="en-US"/>
           </a:p>
@@ -689,7 +690,7 @@
           <a:p>
             <a:r>
               <a:rPr lang="en-US" dirty="0"/>
-              <a:t>Shrnutí: vymezil jsem kategorii edukačních IS, postavil prototyp s metodikou a ověřil ho ve výuce; pilotáž potvrdila hlavní hypotézu. Další rozvoj: ověření na SŠ a 1. stupni a na více školách. Kód je otevřený na GitHubu pod organizací edustack-is a k systému jsem připravil doprovodný web is-edustack.org s dokumentací pro učitele. Děkuji za pozornost a rád odpovím na otázky.</a:t>
+              <a:t>Shrnutí: vymezil jsem kategorii edukačních IS, postavil prototyp s metodikou a ověřil ho ve výuce; pilotáž tento předpoklad podpořila. Další rozvoj: ověření na SŠ a 1. stupni a na více školách. Kód je otevřený na GitHubu pod organizací edustack-is a k systému jsem připravil doprovodný web is-edustack.org s dokumentací pro učitele. Děkuji za pozornost a rád odpovím na otázky.</a:t>
             </a:r>
             <a:endParaRPr lang="en-US" dirty="0"/>
           </a:p>
@@ -712,7 +713,7 @@
           <a:p>
             <a:fld id="{F7021451-1387-4CA6-816F-3879F97B5CBC}" type="slidenum">
               <a:rPr lang="en-US"/>
-              <a:t>11</a:t>
+              <a:t>12</a:t>
             </a:fld>
             <a:endParaRPr lang="en-US"/>
           </a:p>
@@ -800,7 +801,95 @@
           <a:p>
             <a:fld id="{F7021451-1387-4CA6-816F-3879F97B5CBC}" type="slidenum">
               <a:rPr lang="en-US"/>
-              <a:t>12</a:t>
+              <a:t>13</a:t>
+            </a:fld>
+            <a:endParaRPr lang="en-US"/>
+          </a:p>
+        </p:txBody>
+      </p:sp>
+    </p:spTree>
+    <p:extLst>
+      <p:ext uri="{BB962C8B-B14F-4D97-AF65-F5344CB8AC3E}">
+        <p14:creationId xmlns:p14="http://schemas.microsoft.com/office/powerpoint/2010/main" val="1024086991"/>
+      </p:ext>
+    </p:extLst>
+  </p:cSld>
+  <p:clrMapOvr>
+    <a:masterClrMapping/>
+  </p:clrMapOvr>
+</p:notes>
+</file>
+
+<file path=ppt/notesSlides/notesSlide13.xml><?xml version="1.0" encoding="utf-8"?>
+<p:notes xmlns:a="http://schemas.openxmlformats.org/drawingml/2006/main" xmlns:r="http://schemas.openxmlformats.org/officeDocument/2006/relationships" xmlns:p="http://schemas.openxmlformats.org/presentationml/2006/main">
+  <p:cSld>
+    <p:spTree>
+      <p:nvGrpSpPr>
+        <p:cNvPr id="1" name=""/>
+        <p:cNvGrpSpPr/>
+        <p:nvPr/>
+      </p:nvGrpSpPr>
+      <p:grpSpPr>
+        <a:xfrm>
+          <a:off x="0" y="0"/>
+          <a:ext cx="0" cy="0"/>
+          <a:chOff x="0" y="0"/>
+          <a:chExt cx="0" cy="0"/>
+        </a:xfrm>
+      </p:grpSpPr>
+      <p:sp>
+        <p:nvSpPr>
+          <p:cNvPr id="2" name="Slide Image Placeholder 1"/>
+          <p:cNvSpPr>
+            <a:spLocks noGrp="1" noRot="1" noChangeAspect="1"/>
+          </p:cNvSpPr>
+          <p:nvPr>
+            <p:ph type="sldImg"/>
+          </p:nvPr>
+        </p:nvSpPr>
+        <p:spPr/>
+      </p:sp>
+      <p:sp>
+        <p:nvSpPr>
+          <p:cNvPr id="3" name="Notes Placeholder 2"/>
+          <p:cNvSpPr>
+            <a:spLocks noGrp="1"/>
+          </p:cNvSpPr>
+          <p:nvPr>
+            <p:ph type="body" idx="1"/>
+          </p:nvPr>
+        </p:nvSpPr>
+        <p:spPr/>
+        <p:txBody>
+          <a:bodyPr/>
+          <a:lstStyle/>
+          <a:p>
+            <a:r>
+              <a:rPr lang="en-US" dirty="0"/>
+              <a:t>Proč jeden nástroj. V běžné praxi by žák potřeboval tři prostředí – něco na algoritmy, něco na modelování dat, něco na správu systému – a v každém se znovu učit ovládání. Edu Stack IS pokrývá všechny fáze v jednom prostředí: tatáž škola, tytéž role a data. Nižší kognitivní zátěž – žák se neučí nový nástroj, ale nový pohled na známý systém. Tím zbývá víc času na obsah: role, oprávnění, datové toky. Porovnání vychází ze srovnávací tabulky v kapitole 5 práce. Přechod: a ten jeden systém roste se žákem – tři vrstvy hloubky.</a:t>
+            </a:r>
+            <a:endParaRPr lang="en-US" dirty="0"/>
+          </a:p>
+        </p:txBody>
+      </p:sp>
+      <p:sp>
+        <p:nvSpPr>
+          <p:cNvPr id="4" name="Slide Number Placeholder 3"/>
+          <p:cNvSpPr>
+            <a:spLocks noGrp="1"/>
+          </p:cNvSpPr>
+          <p:nvPr>
+            <p:ph type="sldNum" sz="quarter" idx="10"/>
+          </p:nvPr>
+        </p:nvSpPr>
+        <p:spPr/>
+        <p:txBody>
+          <a:bodyPr/>
+          <a:lstStyle/>
+          <a:p>
+            <a:fld id="{F7021451-1387-4CA6-816F-3879F97B5CBC}" type="slidenum">
+              <a:rPr lang="en-US"/>
+              <a:t>5</a:t>
             </a:fld>
             <a:endParaRPr lang="en-US"/>
           </a:p>
@@ -953,7 +1042,7 @@
           <a:p>
             <a:r>
               <a:rPr lang="en-US" dirty="0"/>
-              <a:t>Tři dílčí cíle: (1) teoreticky vymezit kategorii edukačních IS, (2) navrhnout prototyp naplňující tuto kategorii včetně metodické podpory – pracovních listů, (3) ověřit ho přímo ve výuce. Výzkumná otázka: lze simulací správy školy dovést žáka od používání k porozumění rolím, oprávněním a datovým tokům.</a:t>
+              <a:t>Tři dílčí cíle. Vymezit kategorii edukačních IS a odlišit ji od tří sousedních: komerční školní systémy (doména školy, ale uzavřené a žák pasivní), low-code nástroje (otevřené a aktivní, ale bez domény školy) a výukové platformy informatiky (algoritmizace, informační systémy jen okrajově) – podle účelu, role žáka, prostředí a otevřenosti. Navrhnout prototyp: doménový model věrný škole, otevřený, bezpečně resetovatelný, tři vrstvy hloubky – uživatelská pro 1. stupeň, konfigurační pro 2. stupeň, vývojářská pro SŠ – a připravit pracovní listy. Ověřit ho ve výuce. Předpoklad (v textu práce formulovaný jako výzkumná otázka): simulace správy školy dovede žáka od používání k porozumění rolím, oprávněním a datovým tokům.</a:t>
             </a:r>
             <a:endParaRPr lang="en-US" dirty="0"/>
           </a:p>
@@ -1041,7 +1130,7 @@
           <a:p>
             <a:r>
               <a:rPr lang="en-US" dirty="0"/>
-              <a:t>Chci zdůraznit: nejde o technickou práci. Software je pomůcka; hlavní text je didaktický – role, procesy, úrovně, úlohy – a technika je v přílohách. Pedagogické jádro: posun po Bloomově taxonomii. V komerčním systému žák jen čte (zapamatovat, porozumět). V Edu Stack IS aplikuje a analyzuje (založí třídu, řeší kolizi) a na SŠ hodnotí a tvoří (navrhne modul, čte ER diagram).</a:t>
+              <a:t>Nejde o technickou práci. Software je pomůcka; hlavní text je didaktický a technika je v přílohách. Pedagogické jádro: posun po Bloomově taxonomii – žák jako uživatel jen čte známku; jako správce aplikuje a analyzuje (založí třídu, řeší kolizi); jako spolutvůrce hodnotí a tvoří (navrhne modul, čte ER diagram). Přechod: a proč na to stačí jeden nástroj.</a:t>
             </a:r>
             <a:endParaRPr lang="en-US" dirty="0"/>
           </a:p>
@@ -1129,7 +1218,7 @@
           <a:p>
             <a:r>
               <a:rPr lang="en-US" dirty="0"/>
-              <a:t>Druhý princip: práce s chybou. Systém pracuje výhradně s fiktivními daty, která lze kdykoli přegenerovat, a každá třída má vlastní instanci s resetem. Když žák něco omylem smaže – nebo schválně v rámci úkolu – nic se neděje; naopak je to příležitost: proč to šlo smazat? kdo to mohl? co se ztratilo? V pilotáži se to potvrdilo – záměrná kolize v rozvrhu byla tématem diskuse, ne problémem.</a:t>
+              <a:t>Třetí princip: práce s chybou. Systém pracuje výhradně s fiktivními daty, která lze kdykoli přegenerovat, a každá cvičná škola má vlastní oddělený datový prostor a lze ji resetovat. Když žák něco omylem smaže – nebo schválně v rámci úkolu – nic se neděje; naopak je to příležitost: proč to šlo smazat? kdo to mohl? co se ztratilo? V pilotáži se to potvrdilo – záměrná kolize v rozvrhu byla tématem diskuse, ne problémem.</a:t>
             </a:r>
             <a:endParaRPr lang="en-US" dirty="0"/>
           </a:p>
@@ -1152,7 +1241,7 @@
           <a:p>
             <a:fld id="{F7021451-1387-4CA6-816F-3879F97B5CBC}" type="slidenum">
               <a:rPr lang="en-US"/>
-              <a:t>5</a:t>
+              <a:t>7</a:t>
             </a:fld>
             <a:endParaRPr lang="en-US"/>
           </a:p>
@@ -1217,7 +1306,7 @@
           <a:p>
             <a:r>
               <a:rPr lang="en-US" dirty="0"/>
-              <a:t>Třetí princip: není to tři různé aplikace, ale jeden plnohodnotný systém se třemi vrstvami hloubky. Na 1. stupni žák pozoruje – role jako pohled. Na 2. stupni spravuje strukturu – třídy, předměty, rozvrh. Na SŠ jde pod kapotu – ER diagram, API, vlastní modul. Mění se jen kompetence žáka v čase, systém zůstává. Podle stupňů existují tři pracovní listy s klíčem pro učitele.</a:t>
+              <a:t>Druhý princip: není to tři různé aplikace, ale jeden plnohodnotný systém se třemi vrstvami hloubky. Na 1. stupni žák pozoruje – role jako pohled. Na 2. stupni spravuje strukturu – třídy, předměty, rozvrh. Na SŠ jde pod kapotu – ER diagram, API, vlastní modul. Mění se jen kompetence žáka v čase, systém zůstává. Podle stupňů existují tři pracovní listy s klíčem pro učitele. Přechod: aby to fungovalo, musí být dovoleno dělat chyby.</a:t>
             </a:r>
             <a:endParaRPr lang="en-US" dirty="0"/>
           </a:p>
@@ -1328,7 +1417,7 @@
           <a:p>
             <a:fld id="{F7021451-1387-4CA6-816F-3879F97B5CBC}" type="slidenum">
               <a:rPr lang="en-US"/>
-              <a:t>7</a:t>
+              <a:t>8</a:t>
             </a:fld>
             <a:endParaRPr lang="en-US"/>
           </a:p>
@@ -1416,7 +1505,7 @@
           <a:p>
             <a:fld id="{F7021451-1387-4CA6-816F-3879F97B5CBC}" type="slidenum">
               <a:rPr lang="en-US"/>
-              <a:t>8</a:t>
+              <a:t>9</a:t>
             </a:fld>
             <a:endParaRPr lang="en-US"/>
           </a:p>
@@ -1504,7 +1593,7 @@
           <a:p>
             <a:fld id="{F7021451-1387-4CA6-816F-3879F97B5CBC}" type="slidenum">
               <a:rPr lang="en-US"/>
-              <a:t>9</a:t>
+              <a:t>10</a:t>
             </a:fld>
             <a:endParaRPr lang="en-US"/>
           </a:p>
@@ -1989,8 +2078,8 @@
         </p:nvSpPr>
         <p:spPr>
           <a:xfrm>
-            <a:off x="3749040" y="3474720"/>
-            <a:ext cx="4937760" cy="1188720"/>
+            <a:off x="3749040" y="3291840"/>
+            <a:ext cx="4937760" cy="1554480"/>
           </a:xfrm>
           <a:prstGeom prst="rect">
             <a:avLst/>
@@ -2037,7 +2126,7 @@
                 <a:ea typeface="Calibri" pitchFamily="34" charset="-122"/>
                 <a:cs typeface="Calibri" pitchFamily="34" charset="-120"/>
               </a:rPr>
-              <a:t>Obhajoba bakalářské práce · B IT</a:t>
+              <a:t>Obhajoba bakalářské práce</a:t>
             </a:r>
             <a:endParaRPr lang="en-US" sz="1200" dirty="0"/>
           </a:p>
@@ -2057,7 +2146,7 @@
                 <a:ea typeface="Calibri" pitchFamily="34" charset="-122"/>
                 <a:cs typeface="Calibri" pitchFamily="34" charset="-120"/>
               </a:rPr>
-              <a:t>Vedoucí práce: PhDr. Jakub Mazuch</a:t>
+              <a:t>Studijní program Informační technologie se zaměřením na vzdělávání</a:t>
             </a:r>
             <a:endParaRPr lang="en-US" sz="1200" dirty="0"/>
           </a:p>
@@ -2077,7 +2166,47 @@
                 <a:ea typeface="Calibri" pitchFamily="34" charset="-122"/>
                 <a:cs typeface="Calibri" pitchFamily="34" charset="-120"/>
               </a:rPr>
-              <a:t>KITTV, Pedagogická fakulta UK · září 2026</a:t>
+              <a:t>Vedoucí práce: PhDr. Jakub Mazuch</a:t>
+            </a:r>
+            <a:endParaRPr lang="en-US" sz="1200" dirty="0"/>
+          </a:p>
+          <a:p>
+            <a:pPr indent="0" marL="0">
+              <a:spcAft>
+                <a:spcPts val="300"/>
+              </a:spcAft>
+              <a:buNone/>
+            </a:pPr>
+            <a:r>
+              <a:rPr lang="en-US" sz="1200" dirty="0">
+                <a:solidFill>
+                  <a:srgbClr val="FFFFFF"/>
+                </a:solidFill>
+                <a:latin typeface="Calibri" pitchFamily="34" charset="0"/>
+                <a:ea typeface="Calibri" pitchFamily="34" charset="-122"/>
+                <a:cs typeface="Calibri" pitchFamily="34" charset="-120"/>
+              </a:rPr>
+              <a:t>KITTV, Pedagogická fakulta UK</a:t>
+            </a:r>
+            <a:endParaRPr lang="en-US" sz="1200" dirty="0"/>
+          </a:p>
+          <a:p>
+            <a:pPr indent="0" marL="0">
+              <a:spcAft>
+                <a:spcPts val="300"/>
+              </a:spcAft>
+              <a:buNone/>
+            </a:pPr>
+            <a:r>
+              <a:rPr lang="en-US" sz="1200" dirty="0">
+                <a:solidFill>
+                  <a:srgbClr val="FFFFFF"/>
+                </a:solidFill>
+                <a:latin typeface="Calibri" pitchFamily="34" charset="0"/>
+                <a:ea typeface="Calibri" pitchFamily="34" charset="-122"/>
+                <a:cs typeface="Calibri" pitchFamily="34" charset="-120"/>
+              </a:rPr>
+              <a:t>září 2026</a:t>
             </a:r>
             <a:endParaRPr lang="en-US" sz="1200" dirty="0"/>
           </a:p>
@@ -2621,7 +2750,7 @@
                 <a:ea typeface="Calibri" pitchFamily="34" charset="-122"/>
                 <a:cs typeface="Calibri" pitchFamily="34" charset="-120"/>
               </a:rPr>
-              <a:t>10</a:t>
+              <a:t>11</a:t>
             </a:r>
             <a:endParaRPr lang="en-US" sz="900" dirty="0"/>
           </a:p>
@@ -2987,7 +3116,7 @@
                 <a:ea typeface="Calibri" pitchFamily="34" charset="-122"/>
                 <a:cs typeface="Calibri" pitchFamily="34" charset="-120"/>
               </a:rPr>
-              <a:t>11</a:t>
+              <a:t>12</a:t>
             </a:r>
             <a:endParaRPr lang="en-US" sz="900" dirty="0"/>
           </a:p>
@@ -3501,7 +3630,1850 @@
                 <a:ea typeface="Calibri" pitchFamily="34" charset="-122"/>
                 <a:cs typeface="Calibri" pitchFamily="34" charset="-120"/>
               </a:rPr>
-              <a:t>12</a:t>
+              <a:t>13</a:t>
+            </a:r>
+            <a:endParaRPr lang="en-US" sz="900" dirty="0"/>
+          </a:p>
+        </p:txBody>
+      </p:sp>
+    </p:spTree>
+  </p:cSld>
+  <p:clrMapOvr>
+    <a:masterClrMapping/>
+  </p:clrMapOvr>
+</p:sld>
+</file>
+
+<file path=ppt/slides/slide13.xml><?xml version="1.0" encoding="utf-8"?>
+<p:sld xmlns:a="http://schemas.openxmlformats.org/drawingml/2006/main" xmlns:r="http://schemas.openxmlformats.org/officeDocument/2006/relationships" xmlns:p="http://schemas.openxmlformats.org/presentationml/2006/main">
+  <p:cSld name="Slide 4">
+    <p:bg>
+      <p:bgPr>
+        <a:solidFill>
+          <a:srgbClr val="FFFFFF"/>
+        </a:solidFill>
+      </p:bgPr>
+    </p:bg>
+    <p:spTree>
+      <p:nvGrpSpPr>
+        <p:cNvPr id="1" name=""/>
+        <p:cNvGrpSpPr/>
+        <p:nvPr/>
+      </p:nvGrpSpPr>
+      <p:grpSpPr>
+        <a:xfrm>
+          <a:off x="0" y="0"/>
+          <a:ext cx="0" cy="0"/>
+          <a:chOff x="0" y="0"/>
+          <a:chExt cx="0" cy="0"/>
+        </a:xfrm>
+      </p:grpSpPr>
+      <p:sp>
+        <p:nvSpPr>
+          <p:cNvPr id="2" name="Text 0"/>
+          <p:cNvSpPr txBox="1"/>
+          <p:nvPr/>
+        </p:nvSpPr>
+        <p:spPr>
+          <a:xfrm>
+            <a:off x="548640" y="320040"/>
+            <a:ext cx="8046720" cy="640080"/>
+          </a:xfrm>
+          <a:prstGeom prst="rect">
+            <a:avLst/>
+          </a:prstGeom>
+          <a:noFill/>
+          <a:ln/>
+        </p:spPr>
+        <p:txBody>
+          <a:bodyPr wrap="square" lIns="0" tIns="0" rIns="0" bIns="0" rtlCol="0" anchor="ctr"/>
+          <a:lstStyle/>
+          <a:p>
+            <a:pPr indent="0" marL="0">
+              <a:buNone/>
+            </a:pPr>
+            <a:r>
+              <a:rPr lang="en-US" sz="3000" b="1" dirty="0">
+                <a:solidFill>
+                  <a:srgbClr val="3F2A78"/>
+                </a:solidFill>
+                <a:latin typeface="Calibri" pitchFamily="34" charset="0"/>
+                <a:ea typeface="Calibri" pitchFamily="34" charset="-122"/>
+                <a:cs typeface="Calibri" pitchFamily="34" charset="-120"/>
+              </a:rPr>
+              <a:t>Jeden nástroj pro všechny fáze učení</a:t>
+            </a:r>
+            <a:endParaRPr lang="en-US" sz="3000" dirty="0"/>
+          </a:p>
+        </p:txBody>
+      </p:sp>
+      <p:sp>
+        <p:nvSpPr>
+          <p:cNvPr id="3" name="Text 1"/>
+          <p:cNvSpPr txBox="1"/>
+          <p:nvPr/>
+        </p:nvSpPr>
+        <p:spPr>
+          <a:xfrm>
+            <a:off x="548640" y="1005840"/>
+            <a:ext cx="8046720" cy="365760"/>
+          </a:xfrm>
+          <a:prstGeom prst="rect">
+            <a:avLst/>
+          </a:prstGeom>
+          <a:noFill/>
+          <a:ln/>
+        </p:spPr>
+        <p:txBody>
+          <a:bodyPr wrap="square" lIns="0" tIns="0" rIns="0" bIns="0" rtlCol="0" anchor="ctr"/>
+          <a:lstStyle/>
+          <a:p>
+            <a:pPr indent="0" marL="0">
+              <a:buNone/>
+            </a:pPr>
+            <a:r>
+              <a:rPr lang="en-US" sz="1300" dirty="0">
+                <a:solidFill>
+                  <a:srgbClr val="24203A"/>
+                </a:solidFill>
+                <a:latin typeface="Calibri" pitchFamily="34" charset="0"/>
+                <a:ea typeface="Calibri" pitchFamily="34" charset="-122"/>
+                <a:cs typeface="Calibri" pitchFamily="34" charset="-120"/>
+              </a:rPr>
+              <a:t>Co se žák naučí o informačním systému v různých výukových nástrojích – a proč záleží na tom, že je to jeden nástroj.</a:t>
+            </a:r>
+            <a:endParaRPr lang="en-US" sz="1300" dirty="0"/>
+          </a:p>
+        </p:txBody>
+      </p:sp>
+      <p:sp>
+        <p:nvSpPr>
+          <p:cNvPr id="201" name="Shape 201"/>
+          <p:cNvSpPr/>
+          <p:nvPr/>
+        </p:nvSpPr>
+        <p:spPr>
+          <a:xfrm>
+            <a:off x="6858000" y="1463040"/>
+            <a:ext cx="1737360" cy="2313432"/>
+          </a:xfrm>
+          <a:prstGeom prst="rect">
+            <a:avLst>
+              <a:gd name="adj" fmla="val 8000"/>
+            </a:avLst>
+          </a:prstGeom>
+          <a:solidFill>
+            <a:srgbClr val="F1EDFA"/>
+          </a:solidFill>
+          <a:ln>
+            <a:noFill/>
+          </a:ln>
+        </p:spPr>
+      </p:sp>
+      <p:sp>
+        <p:nvSpPr>
+          <p:cNvPr id="202" name="Shape 202"/>
+          <p:cNvSpPr/>
+          <p:nvPr/>
+        </p:nvSpPr>
+        <p:spPr>
+          <a:xfrm>
+            <a:off x="6858000" y="1463040"/>
+            <a:ext cx="1737360" cy="457200"/>
+          </a:xfrm>
+          <a:prstGeom prst="rect">
+            <a:avLst>
+              <a:gd name="adj" fmla="val 8000"/>
+            </a:avLst>
+          </a:prstGeom>
+          <a:solidFill>
+            <a:srgbClr val="3F2A78"/>
+          </a:solidFill>
+          <a:ln>
+            <a:noFill/>
+          </a:ln>
+        </p:spPr>
+      </p:sp>
+      <p:sp>
+        <p:nvSpPr>
+          <p:cNvPr id="203" name="Text 203"/>
+          <p:cNvSpPr txBox="1"/>
+          <p:nvPr/>
+        </p:nvSpPr>
+        <p:spPr>
+          <a:xfrm>
+            <a:off x="3383280" y="1463040"/>
+            <a:ext cx="1737360" cy="457200"/>
+          </a:xfrm>
+          <a:prstGeom prst="rect">
+            <a:avLst/>
+          </a:prstGeom>
+          <a:noFill/>
+          <a:ln/>
+        </p:spPr>
+        <p:txBody>
+          <a:bodyPr wrap="square" lIns="45720" tIns="0" rIns="45720" bIns="0" rtlCol="0" anchor="b"/>
+          <a:lstStyle/>
+          <a:p>
+            <a:pPr algn="ctr" indent="0" marL="0">
+              <a:buNone/>
+            </a:pPr>
+            <a:r>
+              <a:rPr lang="cs-CZ" sz="1000" b="1" dirty="0">
+                <a:solidFill>
+                  <a:srgbClr val="3F2A78"/>
+                </a:solidFill>
+                <a:latin typeface="Calibri" pitchFamily="34" charset="0"/>
+                <a:ea typeface="Calibri" pitchFamily="34" charset="-122"/>
+                <a:cs typeface="Calibri" pitchFamily="34" charset="-120"/>
+              </a:rPr>
+              <a:t>Drag-and-drop programování</a:t>
+            </a:r>
+          </a:p>
+          <a:p>
+            <a:pPr algn="ctr" indent="0" marL="0">
+              <a:buNone/>
+            </a:pPr>
+            <a:r>
+              <a:rPr lang="cs-CZ" sz="800" i="1" dirty="0">
+                <a:solidFill>
+                  <a:srgbClr val="6B6680"/>
+                </a:solidFill>
+                <a:latin typeface="Calibri" pitchFamily="34" charset="0"/>
+                <a:ea typeface="Calibri" pitchFamily="34" charset="-122"/>
+                <a:cs typeface="Calibri" pitchFamily="34" charset="-120"/>
+              </a:rPr>
+              <a:t>Scratch, Umíme to</a:t>
+            </a:r>
+          </a:p>
+        </p:txBody>
+      </p:sp>
+      <p:sp>
+        <p:nvSpPr>
+          <p:cNvPr id="204" name="Text 204"/>
+          <p:cNvSpPr txBox="1"/>
+          <p:nvPr/>
+        </p:nvSpPr>
+        <p:spPr>
+          <a:xfrm>
+            <a:off x="5120640" y="1463040"/>
+            <a:ext cx="1737360" cy="457200"/>
+          </a:xfrm>
+          <a:prstGeom prst="rect">
+            <a:avLst/>
+          </a:prstGeom>
+          <a:noFill/>
+          <a:ln/>
+        </p:spPr>
+        <p:txBody>
+          <a:bodyPr wrap="square" lIns="45720" tIns="0" rIns="45720" bIns="0" rtlCol="0" anchor="b"/>
+          <a:lstStyle/>
+          <a:p>
+            <a:pPr algn="ctr" indent="0" marL="0">
+              <a:buNone/>
+            </a:pPr>
+            <a:r>
+              <a:rPr lang="cs-CZ" sz="1000" b="1" dirty="0">
+                <a:solidFill>
+                  <a:srgbClr val="3F2A78"/>
+                </a:solidFill>
+                <a:latin typeface="Calibri" pitchFamily="34" charset="0"/>
+                <a:ea typeface="Calibri" pitchFamily="34" charset="-122"/>
+                <a:cs typeface="Calibri" pitchFamily="34" charset="-120"/>
+              </a:rPr>
+              <a:t>Modelátory databází</a:t>
+            </a:r>
+          </a:p>
+          <a:p>
+            <a:pPr algn="ctr" indent="0" marL="0">
+              <a:buNone/>
+            </a:pPr>
+            <a:r>
+              <a:rPr lang="cs-CZ" sz="800" i="1" dirty="0">
+                <a:solidFill>
+                  <a:srgbClr val="6B6680"/>
+                </a:solidFill>
+                <a:latin typeface="Calibri" pitchFamily="34" charset="0"/>
+                <a:ea typeface="Calibri" pitchFamily="34" charset="-122"/>
+                <a:cs typeface="Calibri" pitchFamily="34" charset="-120"/>
+              </a:rPr>
+              <a:t>Airtable, Notion, Coda</a:t>
+            </a:r>
+          </a:p>
+        </p:txBody>
+      </p:sp>
+      <p:sp>
+        <p:nvSpPr>
+          <p:cNvPr id="205" name="Text 205"/>
+          <p:cNvSpPr txBox="1"/>
+          <p:nvPr/>
+        </p:nvSpPr>
+        <p:spPr>
+          <a:xfrm>
+            <a:off x="6858000" y="1463040"/>
+            <a:ext cx="1737360" cy="457200"/>
+          </a:xfrm>
+          <a:prstGeom prst="rect">
+            <a:avLst/>
+          </a:prstGeom>
+          <a:noFill/>
+          <a:ln/>
+        </p:spPr>
+        <p:txBody>
+          <a:bodyPr wrap="square" lIns="45720" tIns="0" rIns="45720" bIns="0" rtlCol="0" anchor="b"/>
+          <a:lstStyle/>
+          <a:p>
+            <a:pPr algn="ctr" indent="0" marL="0">
+              <a:buNone/>
+            </a:pPr>
+            <a:r>
+              <a:rPr lang="cs-CZ" sz="1000" b="1" dirty="0">
+                <a:solidFill>
+                  <a:srgbClr val="FFFFFF"/>
+                </a:solidFill>
+                <a:latin typeface="Calibri" pitchFamily="34" charset="0"/>
+                <a:ea typeface="Calibri" pitchFamily="34" charset="-122"/>
+                <a:cs typeface="Calibri" pitchFamily="34" charset="-120"/>
+              </a:rPr>
+              <a:t>Edu Stack IS</a:t>
+            </a:r>
+          </a:p>
+          <a:p>
+            <a:pPr algn="ctr" indent="0" marL="0">
+              <a:buNone/>
+            </a:pPr>
+            <a:r>
+              <a:rPr lang="cs-CZ" sz="800" i="1" dirty="0">
+                <a:solidFill>
+                  <a:srgbClr val="C9BFE8"/>
+                </a:solidFill>
+                <a:latin typeface="Calibri" pitchFamily="34" charset="0"/>
+                <a:ea typeface="Calibri" pitchFamily="34" charset="-122"/>
+                <a:cs typeface="Calibri" pitchFamily="34" charset="-120"/>
+              </a:rPr>
+              <a:t>edukační IS</a:t>
+            </a:r>
+          </a:p>
+        </p:txBody>
+      </p:sp>
+      <p:cxnSp>
+        <p:nvCxnSpPr>
+          <p:cNvPr id="206" name="Line 206"/>
+          <p:cNvCxnSpPr/>
+          <p:nvPr/>
+        </p:nvCxnSpPr>
+        <p:spPr>
+          <a:xfrm>
+            <a:off x="548640" y="1920240"/>
+            <a:ext cx="8046720" cy="0"/>
+          </a:xfrm>
+          <a:prstGeom prst="line">
+            <a:avLst/>
+          </a:prstGeom>
+          <a:ln w="6350">
+            <a:solidFill>
+              <a:srgbClr val="E4DFF2"/>
+            </a:solidFill>
+          </a:ln>
+        </p:spPr>
+      </p:cxnSp>
+      <p:sp>
+        <p:nvSpPr>
+          <p:cNvPr id="207" name="Text 207"/>
+          <p:cNvSpPr txBox="1"/>
+          <p:nvPr/>
+        </p:nvSpPr>
+        <p:spPr>
+          <a:xfrm>
+            <a:off x="548640" y="1920240"/>
+            <a:ext cx="2834640" cy="265176"/>
+          </a:xfrm>
+          <a:prstGeom prst="rect">
+            <a:avLst/>
+          </a:prstGeom>
+          <a:noFill/>
+          <a:ln/>
+        </p:spPr>
+        <p:txBody>
+          <a:bodyPr wrap="square" lIns="45720" tIns="0" rIns="45720" bIns="0" rtlCol="0" anchor="ctr"/>
+          <a:lstStyle/>
+          <a:p>
+            <a:pPr algn="l" indent="0" marL="0">
+              <a:buNone/>
+            </a:pPr>
+            <a:r>
+              <a:rPr lang="cs-CZ" sz="1000" dirty="0">
+                <a:solidFill>
+                  <a:srgbClr val="24203A"/>
+                </a:solidFill>
+                <a:latin typeface="Calibri" pitchFamily="34" charset="0"/>
+                <a:ea typeface="Calibri" pitchFamily="34" charset="-122"/>
+                <a:cs typeface="Calibri" pitchFamily="34" charset="-120"/>
+              </a:rPr>
+              <a:t>Doména školy (třídy, rozvrh, známky)</a:t>
+            </a:r>
+          </a:p>
+        </p:txBody>
+      </p:sp>
+      <p:sp>
+        <p:nvSpPr>
+          <p:cNvPr id="208" name="Text 208"/>
+          <p:cNvSpPr txBox="1"/>
+          <p:nvPr/>
+        </p:nvSpPr>
+        <p:spPr>
+          <a:xfrm>
+            <a:off x="3383280" y="1920240"/>
+            <a:ext cx="1737360" cy="265176"/>
+          </a:xfrm>
+          <a:prstGeom prst="rect">
+            <a:avLst/>
+          </a:prstGeom>
+          <a:noFill/>
+          <a:ln/>
+        </p:spPr>
+        <p:txBody>
+          <a:bodyPr wrap="square" lIns="45720" tIns="0" rIns="45720" bIns="0" rtlCol="0" anchor="ctr"/>
+          <a:lstStyle/>
+          <a:p>
+            <a:pPr algn="ctr" indent="0" marL="0">
+              <a:buNone/>
+            </a:pPr>
+            <a:r>
+              <a:rPr lang="cs-CZ" sz="1200" dirty="0">
+                <a:solidFill>
+                  <a:srgbClr val="B54A6A"/>
+                </a:solidFill>
+                <a:latin typeface="Calibri" pitchFamily="34" charset="0"/>
+                <a:ea typeface="Calibri" pitchFamily="34" charset="-122"/>
+                <a:cs typeface="Calibri" pitchFamily="34" charset="-120"/>
+              </a:rPr>
+              <a:t>✗</a:t>
+            </a:r>
+          </a:p>
+        </p:txBody>
+      </p:sp>
+      <p:sp>
+        <p:nvSpPr>
+          <p:cNvPr id="209" name="Text 209"/>
+          <p:cNvSpPr txBox="1"/>
+          <p:nvPr/>
+        </p:nvSpPr>
+        <p:spPr>
+          <a:xfrm>
+            <a:off x="5120640" y="1920240"/>
+            <a:ext cx="1737360" cy="265176"/>
+          </a:xfrm>
+          <a:prstGeom prst="rect">
+            <a:avLst/>
+          </a:prstGeom>
+          <a:noFill/>
+          <a:ln/>
+        </p:spPr>
+        <p:txBody>
+          <a:bodyPr wrap="square" lIns="45720" tIns="0" rIns="45720" bIns="0" rtlCol="0" anchor="ctr"/>
+          <a:lstStyle/>
+          <a:p>
+            <a:pPr algn="ctr" indent="0" marL="0">
+              <a:buNone/>
+            </a:pPr>
+            <a:r>
+              <a:rPr lang="cs-CZ" sz="1200" dirty="0">
+                <a:solidFill>
+                  <a:srgbClr val="B54A6A"/>
+                </a:solidFill>
+                <a:latin typeface="Calibri" pitchFamily="34" charset="0"/>
+                <a:ea typeface="Calibri" pitchFamily="34" charset="-122"/>
+                <a:cs typeface="Calibri" pitchFamily="34" charset="-120"/>
+              </a:rPr>
+              <a:t>✗</a:t>
+            </a:r>
+          </a:p>
+        </p:txBody>
+      </p:sp>
+      <p:sp>
+        <p:nvSpPr>
+          <p:cNvPr id="210" name="Text 210"/>
+          <p:cNvSpPr txBox="1"/>
+          <p:nvPr/>
+        </p:nvSpPr>
+        <p:spPr>
+          <a:xfrm>
+            <a:off x="6858000" y="1920240"/>
+            <a:ext cx="1737360" cy="265176"/>
+          </a:xfrm>
+          <a:prstGeom prst="rect">
+            <a:avLst/>
+          </a:prstGeom>
+          <a:noFill/>
+          <a:ln/>
+        </p:spPr>
+        <p:txBody>
+          <a:bodyPr wrap="square" lIns="45720" tIns="0" rIns="45720" bIns="0" rtlCol="0" anchor="ctr"/>
+          <a:lstStyle/>
+          <a:p>
+            <a:pPr algn="ctr" indent="0" marL="0">
+              <a:buNone/>
+            </a:pPr>
+            <a:r>
+              <a:rPr lang="cs-CZ" sz="1200" b="1" dirty="0">
+                <a:solidFill>
+                  <a:srgbClr val="4CAF6A"/>
+                </a:solidFill>
+                <a:latin typeface="Calibri" pitchFamily="34" charset="0"/>
+                <a:ea typeface="Calibri" pitchFamily="34" charset="-122"/>
+                <a:cs typeface="Calibri" pitchFamily="34" charset="-120"/>
+              </a:rPr>
+              <a:t>✓</a:t>
+            </a:r>
+          </a:p>
+        </p:txBody>
+      </p:sp>
+      <p:cxnSp>
+        <p:nvCxnSpPr>
+          <p:cNvPr id="211" name="Line 211"/>
+          <p:cNvCxnSpPr/>
+          <p:nvPr/>
+        </p:nvCxnSpPr>
+        <p:spPr>
+          <a:xfrm>
+            <a:off x="548640" y="2185416"/>
+            <a:ext cx="8046720" cy="0"/>
+          </a:xfrm>
+          <a:prstGeom prst="line">
+            <a:avLst/>
+          </a:prstGeom>
+          <a:ln w="6350">
+            <a:solidFill>
+              <a:srgbClr val="E4DFF2"/>
+            </a:solidFill>
+          </a:ln>
+        </p:spPr>
+      </p:cxnSp>
+      <p:sp>
+        <p:nvSpPr>
+          <p:cNvPr id="212" name="Text 212"/>
+          <p:cNvSpPr txBox="1"/>
+          <p:nvPr/>
+        </p:nvSpPr>
+        <p:spPr>
+          <a:xfrm>
+            <a:off x="548640" y="2185416"/>
+            <a:ext cx="2834640" cy="265176"/>
+          </a:xfrm>
+          <a:prstGeom prst="rect">
+            <a:avLst/>
+          </a:prstGeom>
+          <a:noFill/>
+          <a:ln/>
+        </p:spPr>
+        <p:txBody>
+          <a:bodyPr wrap="square" lIns="45720" tIns="0" rIns="45720" bIns="0" rtlCol="0" anchor="ctr"/>
+          <a:lstStyle/>
+          <a:p>
+            <a:pPr algn="l" indent="0" marL="0">
+              <a:buNone/>
+            </a:pPr>
+            <a:r>
+              <a:rPr lang="cs-CZ" sz="1000" dirty="0">
+                <a:solidFill>
+                  <a:srgbClr val="24203A"/>
+                </a:solidFill>
+                <a:latin typeface="Calibri" pitchFamily="34" charset="0"/>
+                <a:ea typeface="Calibri" pitchFamily="34" charset="-122"/>
+                <a:cs typeface="Calibri" pitchFamily="34" charset="-120"/>
+              </a:rPr>
+              <a:t>Role a oprávnění (RBAC)</a:t>
+            </a:r>
+          </a:p>
+        </p:txBody>
+      </p:sp>
+      <p:sp>
+        <p:nvSpPr>
+          <p:cNvPr id="213" name="Text 213"/>
+          <p:cNvSpPr txBox="1"/>
+          <p:nvPr/>
+        </p:nvSpPr>
+        <p:spPr>
+          <a:xfrm>
+            <a:off x="3383280" y="2185416"/>
+            <a:ext cx="1737360" cy="265176"/>
+          </a:xfrm>
+          <a:prstGeom prst="rect">
+            <a:avLst/>
+          </a:prstGeom>
+          <a:noFill/>
+          <a:ln/>
+        </p:spPr>
+        <p:txBody>
+          <a:bodyPr wrap="square" lIns="45720" tIns="0" rIns="45720" bIns="0" rtlCol="0" anchor="ctr"/>
+          <a:lstStyle/>
+          <a:p>
+            <a:pPr algn="ctr" indent="0" marL="0">
+              <a:buNone/>
+            </a:pPr>
+            <a:r>
+              <a:rPr lang="cs-CZ" sz="1200" dirty="0">
+                <a:solidFill>
+                  <a:srgbClr val="B54A6A"/>
+                </a:solidFill>
+                <a:latin typeface="Calibri" pitchFamily="34" charset="0"/>
+                <a:ea typeface="Calibri" pitchFamily="34" charset="-122"/>
+                <a:cs typeface="Calibri" pitchFamily="34" charset="-120"/>
+              </a:rPr>
+              <a:t>✗</a:t>
+            </a:r>
+          </a:p>
+        </p:txBody>
+      </p:sp>
+      <p:sp>
+        <p:nvSpPr>
+          <p:cNvPr id="214" name="Text 214"/>
+          <p:cNvSpPr txBox="1"/>
+          <p:nvPr/>
+        </p:nvSpPr>
+        <p:spPr>
+          <a:xfrm>
+            <a:off x="5120640" y="2185416"/>
+            <a:ext cx="1737360" cy="265176"/>
+          </a:xfrm>
+          <a:prstGeom prst="rect">
+            <a:avLst/>
+          </a:prstGeom>
+          <a:noFill/>
+          <a:ln/>
+        </p:spPr>
+        <p:txBody>
+          <a:bodyPr wrap="square" lIns="45720" tIns="0" rIns="45720" bIns="0" rtlCol="0" anchor="ctr"/>
+          <a:lstStyle/>
+          <a:p>
+            <a:pPr algn="ctr" indent="0" marL="0">
+              <a:buNone/>
+            </a:pPr>
+            <a:r>
+              <a:rPr lang="cs-CZ" sz="1000" dirty="0">
+                <a:solidFill>
+                  <a:srgbClr val="F28C28"/>
+                </a:solidFill>
+                <a:latin typeface="Calibri" pitchFamily="34" charset="0"/>
+                <a:ea typeface="Calibri" pitchFamily="34" charset="-122"/>
+                <a:cs typeface="Calibri" pitchFamily="34" charset="-120"/>
+              </a:rPr>
+              <a:t>částečně</a:t>
+            </a:r>
+          </a:p>
+        </p:txBody>
+      </p:sp>
+      <p:sp>
+        <p:nvSpPr>
+          <p:cNvPr id="215" name="Text 215"/>
+          <p:cNvSpPr txBox="1"/>
+          <p:nvPr/>
+        </p:nvSpPr>
+        <p:spPr>
+          <a:xfrm>
+            <a:off x="6858000" y="2185416"/>
+            <a:ext cx="1737360" cy="265176"/>
+          </a:xfrm>
+          <a:prstGeom prst="rect">
+            <a:avLst/>
+          </a:prstGeom>
+          <a:noFill/>
+          <a:ln/>
+        </p:spPr>
+        <p:txBody>
+          <a:bodyPr wrap="square" lIns="45720" tIns="0" rIns="45720" bIns="0" rtlCol="0" anchor="ctr"/>
+          <a:lstStyle/>
+          <a:p>
+            <a:pPr algn="ctr" indent="0" marL="0">
+              <a:buNone/>
+            </a:pPr>
+            <a:r>
+              <a:rPr lang="cs-CZ" sz="1200" b="1" dirty="0">
+                <a:solidFill>
+                  <a:srgbClr val="4CAF6A"/>
+                </a:solidFill>
+                <a:latin typeface="Calibri" pitchFamily="34" charset="0"/>
+                <a:ea typeface="Calibri" pitchFamily="34" charset="-122"/>
+                <a:cs typeface="Calibri" pitchFamily="34" charset="-120"/>
+              </a:rPr>
+              <a:t>✓</a:t>
+            </a:r>
+          </a:p>
+        </p:txBody>
+      </p:sp>
+      <p:cxnSp>
+        <p:nvCxnSpPr>
+          <p:cNvPr id="216" name="Line 216"/>
+          <p:cNvCxnSpPr/>
+          <p:nvPr/>
+        </p:nvCxnSpPr>
+        <p:spPr>
+          <a:xfrm>
+            <a:off x="548640" y="2450592"/>
+            <a:ext cx="8046720" cy="0"/>
+          </a:xfrm>
+          <a:prstGeom prst="line">
+            <a:avLst/>
+          </a:prstGeom>
+          <a:ln w="6350">
+            <a:solidFill>
+              <a:srgbClr val="E4DFF2"/>
+            </a:solidFill>
+          </a:ln>
+        </p:spPr>
+      </p:cxnSp>
+      <p:sp>
+        <p:nvSpPr>
+          <p:cNvPr id="217" name="Text 217"/>
+          <p:cNvSpPr txBox="1"/>
+          <p:nvPr/>
+        </p:nvSpPr>
+        <p:spPr>
+          <a:xfrm>
+            <a:off x="548640" y="2450592"/>
+            <a:ext cx="2834640" cy="265176"/>
+          </a:xfrm>
+          <a:prstGeom prst="rect">
+            <a:avLst/>
+          </a:prstGeom>
+          <a:noFill/>
+          <a:ln/>
+        </p:spPr>
+        <p:txBody>
+          <a:bodyPr wrap="square" lIns="45720" tIns="0" rIns="45720" bIns="0" rtlCol="0" anchor="ctr"/>
+          <a:lstStyle/>
+          <a:p>
+            <a:pPr algn="l" indent="0" marL="0">
+              <a:buNone/>
+            </a:pPr>
+            <a:r>
+              <a:rPr lang="cs-CZ" sz="1000" dirty="0">
+                <a:solidFill>
+                  <a:srgbClr val="24203A"/>
+                </a:solidFill>
+                <a:latin typeface="Calibri" pitchFamily="34" charset="0"/>
+                <a:ea typeface="Calibri" pitchFamily="34" charset="-122"/>
+                <a:cs typeface="Calibri" pitchFamily="34" charset="-120"/>
+              </a:rPr>
+              <a:t>Viditelný datový model</a:t>
+            </a:r>
+          </a:p>
+        </p:txBody>
+      </p:sp>
+      <p:sp>
+        <p:nvSpPr>
+          <p:cNvPr id="218" name="Text 218"/>
+          <p:cNvSpPr txBox="1"/>
+          <p:nvPr/>
+        </p:nvSpPr>
+        <p:spPr>
+          <a:xfrm>
+            <a:off x="3383280" y="2450592"/>
+            <a:ext cx="1737360" cy="265176"/>
+          </a:xfrm>
+          <a:prstGeom prst="rect">
+            <a:avLst/>
+          </a:prstGeom>
+          <a:noFill/>
+          <a:ln/>
+        </p:spPr>
+        <p:txBody>
+          <a:bodyPr wrap="square" lIns="45720" tIns="0" rIns="45720" bIns="0" rtlCol="0" anchor="ctr"/>
+          <a:lstStyle/>
+          <a:p>
+            <a:pPr algn="ctr" indent="0" marL="0">
+              <a:buNone/>
+            </a:pPr>
+            <a:r>
+              <a:rPr lang="cs-CZ" sz="1200" dirty="0">
+                <a:solidFill>
+                  <a:srgbClr val="B54A6A"/>
+                </a:solidFill>
+                <a:latin typeface="Calibri" pitchFamily="34" charset="0"/>
+                <a:ea typeface="Calibri" pitchFamily="34" charset="-122"/>
+                <a:cs typeface="Calibri" pitchFamily="34" charset="-120"/>
+              </a:rPr>
+              <a:t>–</a:t>
+            </a:r>
+          </a:p>
+        </p:txBody>
+      </p:sp>
+      <p:sp>
+        <p:nvSpPr>
+          <p:cNvPr id="219" name="Text 219"/>
+          <p:cNvSpPr txBox="1"/>
+          <p:nvPr/>
+        </p:nvSpPr>
+        <p:spPr>
+          <a:xfrm>
+            <a:off x="5120640" y="2450592"/>
+            <a:ext cx="1737360" cy="265176"/>
+          </a:xfrm>
+          <a:prstGeom prst="rect">
+            <a:avLst/>
+          </a:prstGeom>
+          <a:noFill/>
+          <a:ln/>
+        </p:spPr>
+        <p:txBody>
+          <a:bodyPr wrap="square" lIns="45720" tIns="0" rIns="45720" bIns="0" rtlCol="0" anchor="ctr"/>
+          <a:lstStyle/>
+          <a:p>
+            <a:pPr algn="ctr" indent="0" marL="0">
+              <a:buNone/>
+            </a:pPr>
+            <a:r>
+              <a:rPr lang="cs-CZ" sz="1200" b="1" dirty="0">
+                <a:solidFill>
+                  <a:srgbClr val="4CAF6A"/>
+                </a:solidFill>
+                <a:latin typeface="Calibri" pitchFamily="34" charset="0"/>
+                <a:ea typeface="Calibri" pitchFamily="34" charset="-122"/>
+                <a:cs typeface="Calibri" pitchFamily="34" charset="-120"/>
+              </a:rPr>
+              <a:t>✓</a:t>
+            </a:r>
+          </a:p>
+        </p:txBody>
+      </p:sp>
+      <p:sp>
+        <p:nvSpPr>
+          <p:cNvPr id="220" name="Text 220"/>
+          <p:cNvSpPr txBox="1"/>
+          <p:nvPr/>
+        </p:nvSpPr>
+        <p:spPr>
+          <a:xfrm>
+            <a:off x="6858000" y="2450592"/>
+            <a:ext cx="1737360" cy="265176"/>
+          </a:xfrm>
+          <a:prstGeom prst="rect">
+            <a:avLst/>
+          </a:prstGeom>
+          <a:noFill/>
+          <a:ln/>
+        </p:spPr>
+        <p:txBody>
+          <a:bodyPr wrap="square" lIns="45720" tIns="0" rIns="45720" bIns="0" rtlCol="0" anchor="ctr"/>
+          <a:lstStyle/>
+          <a:p>
+            <a:pPr algn="ctr" indent="0" marL="0">
+              <a:buNone/>
+            </a:pPr>
+            <a:r>
+              <a:rPr lang="cs-CZ" sz="1200" b="1" dirty="0">
+                <a:solidFill>
+                  <a:srgbClr val="4CAF6A"/>
+                </a:solidFill>
+                <a:latin typeface="Calibri" pitchFamily="34" charset="0"/>
+                <a:ea typeface="Calibri" pitchFamily="34" charset="-122"/>
+                <a:cs typeface="Calibri" pitchFamily="34" charset="-120"/>
+              </a:rPr>
+              <a:t>✓</a:t>
+            </a:r>
+          </a:p>
+        </p:txBody>
+      </p:sp>
+      <p:cxnSp>
+        <p:nvCxnSpPr>
+          <p:cNvPr id="221" name="Line 221"/>
+          <p:cNvCxnSpPr/>
+          <p:nvPr/>
+        </p:nvCxnSpPr>
+        <p:spPr>
+          <a:xfrm>
+            <a:off x="548640" y="2715768"/>
+            <a:ext cx="8046720" cy="0"/>
+          </a:xfrm>
+          <a:prstGeom prst="line">
+            <a:avLst/>
+          </a:prstGeom>
+          <a:ln w="6350">
+            <a:solidFill>
+              <a:srgbClr val="E4DFF2"/>
+            </a:solidFill>
+          </a:ln>
+        </p:spPr>
+      </p:cxnSp>
+      <p:sp>
+        <p:nvSpPr>
+          <p:cNvPr id="222" name="Text 222"/>
+          <p:cNvSpPr txBox="1"/>
+          <p:nvPr/>
+        </p:nvSpPr>
+        <p:spPr>
+          <a:xfrm>
+            <a:off x="548640" y="2715768"/>
+            <a:ext cx="2834640" cy="265176"/>
+          </a:xfrm>
+          <a:prstGeom prst="rect">
+            <a:avLst/>
+          </a:prstGeom>
+          <a:noFill/>
+          <a:ln/>
+        </p:spPr>
+        <p:txBody>
+          <a:bodyPr wrap="square" lIns="45720" tIns="0" rIns="45720" bIns="0" rtlCol="0" anchor="ctr"/>
+          <a:lstStyle/>
+          <a:p>
+            <a:pPr algn="l" indent="0" marL="0">
+              <a:buNone/>
+            </a:pPr>
+            <a:r>
+              <a:rPr lang="cs-CZ" sz="1000" dirty="0">
+                <a:solidFill>
+                  <a:srgbClr val="24203A"/>
+                </a:solidFill>
+                <a:latin typeface="Calibri" pitchFamily="34" charset="0"/>
+                <a:ea typeface="Calibri" pitchFamily="34" charset="-122"/>
+                <a:cs typeface="Calibri" pitchFamily="34" charset="-120"/>
+              </a:rPr>
+              <a:t>Bezpečné experimentování s daty</a:t>
+            </a:r>
+          </a:p>
+        </p:txBody>
+      </p:sp>
+      <p:sp>
+        <p:nvSpPr>
+          <p:cNvPr id="223" name="Text 223"/>
+          <p:cNvSpPr txBox="1"/>
+          <p:nvPr/>
+        </p:nvSpPr>
+        <p:spPr>
+          <a:xfrm>
+            <a:off x="3383280" y="2715768"/>
+            <a:ext cx="1737360" cy="265176"/>
+          </a:xfrm>
+          <a:prstGeom prst="rect">
+            <a:avLst/>
+          </a:prstGeom>
+          <a:noFill/>
+          <a:ln/>
+        </p:spPr>
+        <p:txBody>
+          <a:bodyPr wrap="square" lIns="45720" tIns="0" rIns="45720" bIns="0" rtlCol="0" anchor="ctr"/>
+          <a:lstStyle/>
+          <a:p>
+            <a:pPr algn="ctr" indent="0" marL="0">
+              <a:buNone/>
+            </a:pPr>
+            <a:r>
+              <a:rPr lang="cs-CZ" sz="1200" b="1" dirty="0">
+                <a:solidFill>
+                  <a:srgbClr val="4CAF6A"/>
+                </a:solidFill>
+                <a:latin typeface="Calibri" pitchFamily="34" charset="0"/>
+                <a:ea typeface="Calibri" pitchFamily="34" charset="-122"/>
+                <a:cs typeface="Calibri" pitchFamily="34" charset="-120"/>
+              </a:rPr>
+              <a:t>✓</a:t>
+            </a:r>
+          </a:p>
+        </p:txBody>
+      </p:sp>
+      <p:sp>
+        <p:nvSpPr>
+          <p:cNvPr id="224" name="Text 224"/>
+          <p:cNvSpPr txBox="1"/>
+          <p:nvPr/>
+        </p:nvSpPr>
+        <p:spPr>
+          <a:xfrm>
+            <a:off x="5120640" y="2715768"/>
+            <a:ext cx="1737360" cy="265176"/>
+          </a:xfrm>
+          <a:prstGeom prst="rect">
+            <a:avLst/>
+          </a:prstGeom>
+          <a:noFill/>
+          <a:ln/>
+        </p:spPr>
+        <p:txBody>
+          <a:bodyPr wrap="square" lIns="45720" tIns="0" rIns="45720" bIns="0" rtlCol="0" anchor="ctr"/>
+          <a:lstStyle/>
+          <a:p>
+            <a:pPr algn="ctr" indent="0" marL="0">
+              <a:buNone/>
+            </a:pPr>
+            <a:r>
+              <a:rPr lang="cs-CZ" sz="1200" b="1" dirty="0">
+                <a:solidFill>
+                  <a:srgbClr val="4CAF6A"/>
+                </a:solidFill>
+                <a:latin typeface="Calibri" pitchFamily="34" charset="0"/>
+                <a:ea typeface="Calibri" pitchFamily="34" charset="-122"/>
+                <a:cs typeface="Calibri" pitchFamily="34" charset="-120"/>
+              </a:rPr>
+              <a:t>✓</a:t>
+            </a:r>
+          </a:p>
+        </p:txBody>
+      </p:sp>
+      <p:sp>
+        <p:nvSpPr>
+          <p:cNvPr id="225" name="Text 225"/>
+          <p:cNvSpPr txBox="1"/>
+          <p:nvPr/>
+        </p:nvSpPr>
+        <p:spPr>
+          <a:xfrm>
+            <a:off x="6858000" y="2715768"/>
+            <a:ext cx="1737360" cy="265176"/>
+          </a:xfrm>
+          <a:prstGeom prst="rect">
+            <a:avLst/>
+          </a:prstGeom>
+          <a:noFill/>
+          <a:ln/>
+        </p:spPr>
+        <p:txBody>
+          <a:bodyPr wrap="square" lIns="45720" tIns="0" rIns="45720" bIns="0" rtlCol="0" anchor="ctr"/>
+          <a:lstStyle/>
+          <a:p>
+            <a:pPr algn="ctr" indent="0" marL="0">
+              <a:buNone/>
+            </a:pPr>
+            <a:r>
+              <a:rPr lang="cs-CZ" sz="1200" b="1" dirty="0">
+                <a:solidFill>
+                  <a:srgbClr val="4CAF6A"/>
+                </a:solidFill>
+                <a:latin typeface="Calibri" pitchFamily="34" charset="0"/>
+                <a:ea typeface="Calibri" pitchFamily="34" charset="-122"/>
+                <a:cs typeface="Calibri" pitchFamily="34" charset="-120"/>
+              </a:rPr>
+              <a:t>✓</a:t>
+            </a:r>
+          </a:p>
+        </p:txBody>
+      </p:sp>
+      <p:cxnSp>
+        <p:nvCxnSpPr>
+          <p:cNvPr id="226" name="Line 226"/>
+          <p:cNvCxnSpPr/>
+          <p:nvPr/>
+        </p:nvCxnSpPr>
+        <p:spPr>
+          <a:xfrm>
+            <a:off x="548640" y="2980944"/>
+            <a:ext cx="8046720" cy="0"/>
+          </a:xfrm>
+          <a:prstGeom prst="line">
+            <a:avLst/>
+          </a:prstGeom>
+          <a:ln w="6350">
+            <a:solidFill>
+              <a:srgbClr val="E4DFF2"/>
+            </a:solidFill>
+          </a:ln>
+        </p:spPr>
+      </p:cxnSp>
+      <p:sp>
+        <p:nvSpPr>
+          <p:cNvPr id="227" name="Text 227"/>
+          <p:cNvSpPr txBox="1"/>
+          <p:nvPr/>
+        </p:nvSpPr>
+        <p:spPr>
+          <a:xfrm>
+            <a:off x="548640" y="2980944"/>
+            <a:ext cx="2834640" cy="265176"/>
+          </a:xfrm>
+          <a:prstGeom prst="rect">
+            <a:avLst/>
+          </a:prstGeom>
+          <a:noFill/>
+          <a:ln/>
+        </p:spPr>
+        <p:txBody>
+          <a:bodyPr wrap="square" lIns="45720" tIns="0" rIns="45720" bIns="0" rtlCol="0" anchor="ctr"/>
+          <a:lstStyle/>
+          <a:p>
+            <a:pPr algn="l" indent="0" marL="0">
+              <a:buNone/>
+            </a:pPr>
+            <a:r>
+              <a:rPr lang="cs-CZ" sz="1000" dirty="0">
+                <a:solidFill>
+                  <a:srgbClr val="24203A"/>
+                </a:solidFill>
+                <a:latin typeface="Calibri" pitchFamily="34" charset="0"/>
+                <a:ea typeface="Calibri" pitchFamily="34" charset="-122"/>
+                <a:cs typeface="Calibri" pitchFamily="34" charset="-120"/>
+              </a:rPr>
+              <a:t>Otevřený kód</a:t>
+            </a:r>
+          </a:p>
+        </p:txBody>
+      </p:sp>
+      <p:sp>
+        <p:nvSpPr>
+          <p:cNvPr id="228" name="Text 228"/>
+          <p:cNvSpPr txBox="1"/>
+          <p:nvPr/>
+        </p:nvSpPr>
+        <p:spPr>
+          <a:xfrm>
+            <a:off x="3383280" y="2980944"/>
+            <a:ext cx="1737360" cy="265176"/>
+          </a:xfrm>
+          <a:prstGeom prst="rect">
+            <a:avLst/>
+          </a:prstGeom>
+          <a:noFill/>
+          <a:ln/>
+        </p:spPr>
+        <p:txBody>
+          <a:bodyPr wrap="square" lIns="45720" tIns="0" rIns="45720" bIns="0" rtlCol="0" anchor="ctr"/>
+          <a:lstStyle/>
+          <a:p>
+            <a:pPr algn="ctr" indent="0" marL="0">
+              <a:buNone/>
+            </a:pPr>
+            <a:r>
+              <a:rPr lang="cs-CZ" sz="1000" dirty="0">
+                <a:solidFill>
+                  <a:srgbClr val="F28C28"/>
+                </a:solidFill>
+                <a:latin typeface="Calibri" pitchFamily="34" charset="0"/>
+                <a:ea typeface="Calibri" pitchFamily="34" charset="-122"/>
+                <a:cs typeface="Calibri" pitchFamily="34" charset="-120"/>
+              </a:rPr>
+              <a:t>Scratch ano</a:t>
+            </a:r>
+          </a:p>
+        </p:txBody>
+      </p:sp>
+      <p:sp>
+        <p:nvSpPr>
+          <p:cNvPr id="229" name="Text 229"/>
+          <p:cNvSpPr txBox="1"/>
+          <p:nvPr/>
+        </p:nvSpPr>
+        <p:spPr>
+          <a:xfrm>
+            <a:off x="5120640" y="2980944"/>
+            <a:ext cx="1737360" cy="265176"/>
+          </a:xfrm>
+          <a:prstGeom prst="rect">
+            <a:avLst/>
+          </a:prstGeom>
+          <a:noFill/>
+          <a:ln/>
+        </p:spPr>
+        <p:txBody>
+          <a:bodyPr wrap="square" lIns="45720" tIns="0" rIns="45720" bIns="0" rtlCol="0" anchor="ctr"/>
+          <a:lstStyle/>
+          <a:p>
+            <a:pPr algn="ctr" indent="0" marL="0">
+              <a:buNone/>
+            </a:pPr>
+            <a:r>
+              <a:rPr lang="cs-CZ" sz="1000" dirty="0">
+                <a:solidFill>
+                  <a:srgbClr val="F28C28"/>
+                </a:solidFill>
+                <a:latin typeface="Calibri" pitchFamily="34" charset="0"/>
+                <a:ea typeface="Calibri" pitchFamily="34" charset="-122"/>
+                <a:cs typeface="Calibri" pitchFamily="34" charset="-120"/>
+              </a:rPr>
+              <a:t>částečně</a:t>
+            </a:r>
+          </a:p>
+        </p:txBody>
+      </p:sp>
+      <p:sp>
+        <p:nvSpPr>
+          <p:cNvPr id="230" name="Text 230"/>
+          <p:cNvSpPr txBox="1"/>
+          <p:nvPr/>
+        </p:nvSpPr>
+        <p:spPr>
+          <a:xfrm>
+            <a:off x="6858000" y="2980944"/>
+            <a:ext cx="1737360" cy="265176"/>
+          </a:xfrm>
+          <a:prstGeom prst="rect">
+            <a:avLst/>
+          </a:prstGeom>
+          <a:noFill/>
+          <a:ln/>
+        </p:spPr>
+        <p:txBody>
+          <a:bodyPr wrap="square" lIns="45720" tIns="0" rIns="45720" bIns="0" rtlCol="0" anchor="ctr"/>
+          <a:lstStyle/>
+          <a:p>
+            <a:pPr algn="ctr" indent="0" marL="0">
+              <a:buNone/>
+            </a:pPr>
+            <a:r>
+              <a:rPr lang="cs-CZ" sz="1200" b="1" dirty="0">
+                <a:solidFill>
+                  <a:srgbClr val="4CAF6A"/>
+                </a:solidFill>
+                <a:latin typeface="Calibri" pitchFamily="34" charset="0"/>
+                <a:ea typeface="Calibri" pitchFamily="34" charset="-122"/>
+                <a:cs typeface="Calibri" pitchFamily="34" charset="-120"/>
+              </a:rPr>
+              <a:t>✓</a:t>
+            </a:r>
+          </a:p>
+        </p:txBody>
+      </p:sp>
+      <p:cxnSp>
+        <p:nvCxnSpPr>
+          <p:cNvPr id="231" name="Line 231"/>
+          <p:cNvCxnSpPr/>
+          <p:nvPr/>
+        </p:nvCxnSpPr>
+        <p:spPr>
+          <a:xfrm>
+            <a:off x="548640" y="3246120"/>
+            <a:ext cx="8046720" cy="0"/>
+          </a:xfrm>
+          <a:prstGeom prst="line">
+            <a:avLst/>
+          </a:prstGeom>
+          <a:ln w="6350">
+            <a:solidFill>
+              <a:srgbClr val="E4DFF2"/>
+            </a:solidFill>
+          </a:ln>
+        </p:spPr>
+      </p:cxnSp>
+      <p:sp>
+        <p:nvSpPr>
+          <p:cNvPr id="232" name="Text 232"/>
+          <p:cNvSpPr txBox="1"/>
+          <p:nvPr/>
+        </p:nvSpPr>
+        <p:spPr>
+          <a:xfrm>
+            <a:off x="548640" y="3246120"/>
+            <a:ext cx="2834640" cy="265176"/>
+          </a:xfrm>
+          <a:prstGeom prst="rect">
+            <a:avLst/>
+          </a:prstGeom>
+          <a:noFill/>
+          <a:ln/>
+        </p:spPr>
+        <p:txBody>
+          <a:bodyPr wrap="square" lIns="45720" tIns="0" rIns="45720" bIns="0" rtlCol="0" anchor="ctr"/>
+          <a:lstStyle/>
+          <a:p>
+            <a:pPr algn="l" indent="0" marL="0">
+              <a:buNone/>
+            </a:pPr>
+            <a:r>
+              <a:rPr lang="cs-CZ" sz="1000" dirty="0">
+                <a:solidFill>
+                  <a:srgbClr val="24203A"/>
+                </a:solidFill>
+                <a:latin typeface="Calibri" pitchFamily="34" charset="0"/>
+                <a:ea typeface="Calibri" pitchFamily="34" charset="-122"/>
+                <a:cs typeface="Calibri" pitchFamily="34" charset="-120"/>
+              </a:rPr>
+              <a:t>Blok „Informační systémy“ v RVP</a:t>
+            </a:r>
+          </a:p>
+        </p:txBody>
+      </p:sp>
+      <p:sp>
+        <p:nvSpPr>
+          <p:cNvPr id="233" name="Text 233"/>
+          <p:cNvSpPr txBox="1"/>
+          <p:nvPr/>
+        </p:nvSpPr>
+        <p:spPr>
+          <a:xfrm>
+            <a:off x="3383280" y="3246120"/>
+            <a:ext cx="1737360" cy="265176"/>
+          </a:xfrm>
+          <a:prstGeom prst="rect">
+            <a:avLst/>
+          </a:prstGeom>
+          <a:noFill/>
+          <a:ln/>
+        </p:spPr>
+        <p:txBody>
+          <a:bodyPr wrap="square" lIns="45720" tIns="0" rIns="45720" bIns="0" rtlCol="0" anchor="ctr"/>
+          <a:lstStyle/>
+          <a:p>
+            <a:pPr algn="ctr" indent="0" marL="0">
+              <a:buNone/>
+            </a:pPr>
+            <a:r>
+              <a:rPr lang="cs-CZ" sz="1000" dirty="0">
+                <a:solidFill>
+                  <a:srgbClr val="F28C28"/>
+                </a:solidFill>
+                <a:latin typeface="Calibri" pitchFamily="34" charset="0"/>
+                <a:ea typeface="Calibri" pitchFamily="34" charset="-122"/>
+                <a:cs typeface="Calibri" pitchFamily="34" charset="-120"/>
+              </a:rPr>
+              <a:t>okrajově</a:t>
+            </a:r>
+          </a:p>
+        </p:txBody>
+      </p:sp>
+      <p:sp>
+        <p:nvSpPr>
+          <p:cNvPr id="234" name="Text 234"/>
+          <p:cNvSpPr txBox="1"/>
+          <p:nvPr/>
+        </p:nvSpPr>
+        <p:spPr>
+          <a:xfrm>
+            <a:off x="5120640" y="3246120"/>
+            <a:ext cx="1737360" cy="265176"/>
+          </a:xfrm>
+          <a:prstGeom prst="rect">
+            <a:avLst/>
+          </a:prstGeom>
+          <a:noFill/>
+          <a:ln/>
+        </p:spPr>
+        <p:txBody>
+          <a:bodyPr wrap="square" lIns="45720" tIns="0" rIns="45720" bIns="0" rtlCol="0" anchor="ctr"/>
+          <a:lstStyle/>
+          <a:p>
+            <a:pPr algn="ctr" indent="0" marL="0">
+              <a:buNone/>
+            </a:pPr>
+            <a:r>
+              <a:rPr lang="cs-CZ" sz="1000" dirty="0">
+                <a:solidFill>
+                  <a:srgbClr val="F28C28"/>
+                </a:solidFill>
+                <a:latin typeface="Calibri" pitchFamily="34" charset="0"/>
+                <a:ea typeface="Calibri" pitchFamily="34" charset="-122"/>
+                <a:cs typeface="Calibri" pitchFamily="34" charset="-120"/>
+              </a:rPr>
+              <a:t>částečně</a:t>
+            </a:r>
+          </a:p>
+        </p:txBody>
+      </p:sp>
+      <p:sp>
+        <p:nvSpPr>
+          <p:cNvPr id="235" name="Text 235"/>
+          <p:cNvSpPr txBox="1"/>
+          <p:nvPr/>
+        </p:nvSpPr>
+        <p:spPr>
+          <a:xfrm>
+            <a:off x="6858000" y="3246120"/>
+            <a:ext cx="1737360" cy="265176"/>
+          </a:xfrm>
+          <a:prstGeom prst="rect">
+            <a:avLst/>
+          </a:prstGeom>
+          <a:noFill/>
+          <a:ln/>
+        </p:spPr>
+        <p:txBody>
+          <a:bodyPr wrap="square" lIns="45720" tIns="0" rIns="45720" bIns="0" rtlCol="0" anchor="ctr"/>
+          <a:lstStyle/>
+          <a:p>
+            <a:pPr algn="ctr" indent="0" marL="0">
+              <a:buNone/>
+            </a:pPr>
+            <a:r>
+              <a:rPr lang="cs-CZ" sz="1000" b="1" dirty="0">
+                <a:solidFill>
+                  <a:srgbClr val="4CAF6A"/>
+                </a:solidFill>
+                <a:latin typeface="Calibri" pitchFamily="34" charset="0"/>
+                <a:ea typeface="Calibri" pitchFamily="34" charset="-122"/>
+                <a:cs typeface="Calibri" pitchFamily="34" charset="-120"/>
+              </a:rPr>
+              <a:t>přímo</a:t>
+            </a:r>
+          </a:p>
+        </p:txBody>
+      </p:sp>
+      <p:cxnSp>
+        <p:nvCxnSpPr>
+          <p:cNvPr id="236" name="Line 236"/>
+          <p:cNvCxnSpPr/>
+          <p:nvPr/>
+        </p:nvCxnSpPr>
+        <p:spPr>
+          <a:xfrm>
+            <a:off x="548640" y="3511296"/>
+            <a:ext cx="8046720" cy="0"/>
+          </a:xfrm>
+          <a:prstGeom prst="line">
+            <a:avLst/>
+          </a:prstGeom>
+          <a:ln w="6350">
+            <a:solidFill>
+              <a:srgbClr val="E4DFF2"/>
+            </a:solidFill>
+          </a:ln>
+        </p:spPr>
+      </p:cxnSp>
+      <p:sp>
+        <p:nvSpPr>
+          <p:cNvPr id="237" name="Text 237"/>
+          <p:cNvSpPr txBox="1"/>
+          <p:nvPr/>
+        </p:nvSpPr>
+        <p:spPr>
+          <a:xfrm>
+            <a:off x="548640" y="3511296"/>
+            <a:ext cx="2834640" cy="265176"/>
+          </a:xfrm>
+          <a:prstGeom prst="rect">
+            <a:avLst/>
+          </a:prstGeom>
+          <a:noFill/>
+          <a:ln/>
+        </p:spPr>
+        <p:txBody>
+          <a:bodyPr wrap="square" lIns="45720" tIns="0" rIns="45720" bIns="0" rtlCol="0" anchor="ctr"/>
+          <a:lstStyle/>
+          <a:p>
+            <a:pPr algn="l" indent="0" marL="0">
+              <a:buNone/>
+            </a:pPr>
+            <a:r>
+              <a:rPr lang="cs-CZ" sz="1000" dirty="0">
+                <a:solidFill>
+                  <a:srgbClr val="24203A"/>
+                </a:solidFill>
+                <a:latin typeface="Calibri" pitchFamily="34" charset="0"/>
+                <a:ea typeface="Calibri" pitchFamily="34" charset="-122"/>
+                <a:cs typeface="Calibri" pitchFamily="34" charset="-120"/>
+              </a:rPr>
+              <a:t>Uživatel → správce → spolutvůrce v jednom prostředí</a:t>
+            </a:r>
+          </a:p>
+        </p:txBody>
+      </p:sp>
+      <p:sp>
+        <p:nvSpPr>
+          <p:cNvPr id="238" name="Text 238"/>
+          <p:cNvSpPr txBox="1"/>
+          <p:nvPr/>
+        </p:nvSpPr>
+        <p:spPr>
+          <a:xfrm>
+            <a:off x="3383280" y="3511296"/>
+            <a:ext cx="1737360" cy="265176"/>
+          </a:xfrm>
+          <a:prstGeom prst="rect">
+            <a:avLst/>
+          </a:prstGeom>
+          <a:noFill/>
+          <a:ln/>
+        </p:spPr>
+        <p:txBody>
+          <a:bodyPr wrap="square" lIns="45720" tIns="0" rIns="45720" bIns="0" rtlCol="0" anchor="ctr"/>
+          <a:lstStyle/>
+          <a:p>
+            <a:pPr algn="ctr" indent="0" marL="0">
+              <a:buNone/>
+            </a:pPr>
+            <a:r>
+              <a:rPr lang="cs-CZ" sz="1200" dirty="0">
+                <a:solidFill>
+                  <a:srgbClr val="B54A6A"/>
+                </a:solidFill>
+                <a:latin typeface="Calibri" pitchFamily="34" charset="0"/>
+                <a:ea typeface="Calibri" pitchFamily="34" charset="-122"/>
+                <a:cs typeface="Calibri" pitchFamily="34" charset="-120"/>
+              </a:rPr>
+              <a:t>✗</a:t>
+            </a:r>
+          </a:p>
+        </p:txBody>
+      </p:sp>
+      <p:sp>
+        <p:nvSpPr>
+          <p:cNvPr id="239" name="Text 239"/>
+          <p:cNvSpPr txBox="1"/>
+          <p:nvPr/>
+        </p:nvSpPr>
+        <p:spPr>
+          <a:xfrm>
+            <a:off x="5120640" y="3511296"/>
+            <a:ext cx="1737360" cy="265176"/>
+          </a:xfrm>
+          <a:prstGeom prst="rect">
+            <a:avLst/>
+          </a:prstGeom>
+          <a:noFill/>
+          <a:ln/>
+        </p:spPr>
+        <p:txBody>
+          <a:bodyPr wrap="square" lIns="45720" tIns="0" rIns="45720" bIns="0" rtlCol="0" anchor="ctr"/>
+          <a:lstStyle/>
+          <a:p>
+            <a:pPr algn="ctr" indent="0" marL="0">
+              <a:buNone/>
+            </a:pPr>
+            <a:r>
+              <a:rPr lang="cs-CZ" sz="1000" dirty="0">
+                <a:solidFill>
+                  <a:srgbClr val="F28C28"/>
+                </a:solidFill>
+                <a:latin typeface="Calibri" pitchFamily="34" charset="0"/>
+                <a:ea typeface="Calibri" pitchFamily="34" charset="-122"/>
+                <a:cs typeface="Calibri" pitchFamily="34" charset="-120"/>
+              </a:rPr>
+              <a:t>částečně</a:t>
+            </a:r>
+          </a:p>
+        </p:txBody>
+      </p:sp>
+      <p:sp>
+        <p:nvSpPr>
+          <p:cNvPr id="240" name="Text 240"/>
+          <p:cNvSpPr txBox="1"/>
+          <p:nvPr/>
+        </p:nvSpPr>
+        <p:spPr>
+          <a:xfrm>
+            <a:off x="6858000" y="3511296"/>
+            <a:ext cx="1737360" cy="265176"/>
+          </a:xfrm>
+          <a:prstGeom prst="rect">
+            <a:avLst/>
+          </a:prstGeom>
+          <a:noFill/>
+          <a:ln/>
+        </p:spPr>
+        <p:txBody>
+          <a:bodyPr wrap="square" lIns="45720" tIns="0" rIns="45720" bIns="0" rtlCol="0" anchor="ctr"/>
+          <a:lstStyle/>
+          <a:p>
+            <a:pPr algn="ctr" indent="0" marL="0">
+              <a:buNone/>
+            </a:pPr>
+            <a:r>
+              <a:rPr lang="cs-CZ" sz="1200" b="1" dirty="0">
+                <a:solidFill>
+                  <a:srgbClr val="4CAF6A"/>
+                </a:solidFill>
+                <a:latin typeface="Calibri" pitchFamily="34" charset="0"/>
+                <a:ea typeface="Calibri" pitchFamily="34" charset="-122"/>
+                <a:cs typeface="Calibri" pitchFamily="34" charset="-120"/>
+              </a:rPr>
+              <a:t>✓</a:t>
+            </a:r>
+          </a:p>
+        </p:txBody>
+      </p:sp>
+      <p:sp>
+        <p:nvSpPr>
+          <p:cNvPr id="241" name="Shape 241"/>
+          <p:cNvSpPr/>
+          <p:nvPr/>
+        </p:nvSpPr>
+        <p:spPr>
+          <a:xfrm>
+            <a:off x="548640" y="3959352"/>
+            <a:ext cx="2606040" cy="640080"/>
+          </a:xfrm>
+          <a:prstGeom prst="roundRect">
+            <a:avLst>
+              <a:gd name="adj" fmla="val 8000"/>
+            </a:avLst>
+          </a:prstGeom>
+          <a:solidFill>
+            <a:srgbClr val="F1EDFA"/>
+          </a:solidFill>
+          <a:ln>
+            <a:noFill/>
+          </a:ln>
+        </p:spPr>
+      </p:sp>
+      <p:sp>
+        <p:nvSpPr>
+          <p:cNvPr id="242" name="Text 242"/>
+          <p:cNvSpPr txBox="1"/>
+          <p:nvPr/>
+        </p:nvSpPr>
+        <p:spPr>
+          <a:xfrm>
+            <a:off x="640080" y="4005072"/>
+            <a:ext cx="2423160" cy="548640"/>
+          </a:xfrm>
+          <a:prstGeom prst="rect">
+            <a:avLst/>
+          </a:prstGeom>
+          <a:noFill/>
+          <a:ln/>
+        </p:spPr>
+        <p:txBody>
+          <a:bodyPr wrap="square" lIns="45720" tIns="0" rIns="45720" bIns="0" rtlCol="0" anchor="ctr"/>
+          <a:lstStyle/>
+          <a:p>
+            <a:pPr algn="l" indent="0" marL="0">
+              <a:buNone/>
+            </a:pPr>
+            <a:r>
+              <a:rPr lang="cs-CZ" sz="1100" b="1" dirty="0">
+                <a:solidFill>
+                  <a:srgbClr val="3F2A78"/>
+                </a:solidFill>
+                <a:latin typeface="Calibri" pitchFamily="34" charset="0"/>
+                <a:ea typeface="Calibri" pitchFamily="34" charset="-122"/>
+                <a:cs typeface="Calibri" pitchFamily="34" charset="-120"/>
+              </a:rPr>
+              <a:t>Jeden nástroj</a:t>
+            </a:r>
+          </a:p>
+          <a:p>
+            <a:pPr algn="l" indent="0" marL="0">
+              <a:buNone/>
+            </a:pPr>
+            <a:r>
+              <a:rPr lang="cs-CZ" sz="900" dirty="0">
+                <a:solidFill>
+                  <a:srgbClr val="24203A"/>
+                </a:solidFill>
+                <a:latin typeface="Calibri" pitchFamily="34" charset="0"/>
+                <a:ea typeface="Calibri" pitchFamily="34" charset="-122"/>
+                <a:cs typeface="Calibri" pitchFamily="34" charset="-120"/>
+              </a:rPr>
+              <a:t>Tatáž škola, tytéž role a data ve všech fázích – od klikání po vlastní skript.</a:t>
+            </a:r>
+          </a:p>
+        </p:txBody>
+      </p:sp>
+      <p:sp>
+        <p:nvSpPr>
+          <p:cNvPr id="243" name="Shape 243"/>
+          <p:cNvSpPr/>
+          <p:nvPr/>
+        </p:nvSpPr>
+        <p:spPr>
+          <a:xfrm>
+            <a:off x="3268980" y="3959352"/>
+            <a:ext cx="2606040" cy="640080"/>
+          </a:xfrm>
+          <a:prstGeom prst="roundRect">
+            <a:avLst>
+              <a:gd name="adj" fmla="val 8000"/>
+            </a:avLst>
+          </a:prstGeom>
+          <a:solidFill>
+            <a:srgbClr val="F1EDFA"/>
+          </a:solidFill>
+          <a:ln>
+            <a:noFill/>
+          </a:ln>
+        </p:spPr>
+      </p:sp>
+      <p:sp>
+        <p:nvSpPr>
+          <p:cNvPr id="244" name="Text 244"/>
+          <p:cNvSpPr txBox="1"/>
+          <p:nvPr/>
+        </p:nvSpPr>
+        <p:spPr>
+          <a:xfrm>
+            <a:off x="3360420" y="4005072"/>
+            <a:ext cx="2423160" cy="548640"/>
+          </a:xfrm>
+          <a:prstGeom prst="rect">
+            <a:avLst/>
+          </a:prstGeom>
+          <a:noFill/>
+          <a:ln/>
+        </p:spPr>
+        <p:txBody>
+          <a:bodyPr wrap="square" lIns="45720" tIns="0" rIns="45720" bIns="0" rtlCol="0" anchor="ctr"/>
+          <a:lstStyle/>
+          <a:p>
+            <a:pPr algn="l" indent="0" marL="0">
+              <a:buNone/>
+            </a:pPr>
+            <a:r>
+              <a:rPr lang="cs-CZ" sz="1100" b="1" dirty="0">
+                <a:solidFill>
+                  <a:srgbClr val="3F2A78"/>
+                </a:solidFill>
+                <a:latin typeface="Calibri" pitchFamily="34" charset="0"/>
+                <a:ea typeface="Calibri" pitchFamily="34" charset="-122"/>
+                <a:cs typeface="Calibri" pitchFamily="34" charset="-120"/>
+              </a:rPr>
+              <a:t>Nižší kognitivní zátěž</a:t>
+            </a:r>
+          </a:p>
+          <a:p>
+            <a:pPr algn="l" indent="0" marL="0">
+              <a:buNone/>
+            </a:pPr>
+            <a:r>
+              <a:rPr lang="cs-CZ" sz="900" dirty="0">
+                <a:solidFill>
+                  <a:srgbClr val="24203A"/>
+                </a:solidFill>
+                <a:latin typeface="Calibri" pitchFamily="34" charset="0"/>
+                <a:ea typeface="Calibri" pitchFamily="34" charset="-122"/>
+                <a:cs typeface="Calibri" pitchFamily="34" charset="-120"/>
+              </a:rPr>
+              <a:t>Žák se neučí v každé fázi nové prostředí, ale nový pohled na systém, který už zná.</a:t>
+            </a:r>
+          </a:p>
+        </p:txBody>
+      </p:sp>
+      <p:sp>
+        <p:nvSpPr>
+          <p:cNvPr id="245" name="Shape 245"/>
+          <p:cNvSpPr/>
+          <p:nvPr/>
+        </p:nvSpPr>
+        <p:spPr>
+          <a:xfrm>
+            <a:off x="5989320" y="3959352"/>
+            <a:ext cx="2606040" cy="640080"/>
+          </a:xfrm>
+          <a:prstGeom prst="roundRect">
+            <a:avLst>
+              <a:gd name="adj" fmla="val 8000"/>
+            </a:avLst>
+          </a:prstGeom>
+          <a:solidFill>
+            <a:srgbClr val="3F2A78"/>
+          </a:solidFill>
+          <a:ln>
+            <a:noFill/>
+          </a:ln>
+        </p:spPr>
+      </p:sp>
+      <p:sp>
+        <p:nvSpPr>
+          <p:cNvPr id="246" name="Text 246"/>
+          <p:cNvSpPr txBox="1"/>
+          <p:nvPr/>
+        </p:nvSpPr>
+        <p:spPr>
+          <a:xfrm>
+            <a:off x="6080760" y="4005072"/>
+            <a:ext cx="2423160" cy="548640"/>
+          </a:xfrm>
+          <a:prstGeom prst="rect">
+            <a:avLst/>
+          </a:prstGeom>
+          <a:noFill/>
+          <a:ln/>
+        </p:spPr>
+        <p:txBody>
+          <a:bodyPr wrap="square" lIns="45720" tIns="0" rIns="45720" bIns="0" rtlCol="0" anchor="ctr"/>
+          <a:lstStyle/>
+          <a:p>
+            <a:pPr algn="l" indent="0" marL="0">
+              <a:buNone/>
+            </a:pPr>
+            <a:r>
+              <a:rPr lang="cs-CZ" sz="1100" b="1" dirty="0">
+                <a:solidFill>
+                  <a:srgbClr val="FFFFFF"/>
+                </a:solidFill>
+                <a:latin typeface="Calibri" pitchFamily="34" charset="0"/>
+                <a:ea typeface="Calibri" pitchFamily="34" charset="-122"/>
+                <a:cs typeface="Calibri" pitchFamily="34" charset="-120"/>
+              </a:rPr>
+              <a:t>Více prostoru pro obsah</a:t>
+            </a:r>
+          </a:p>
+          <a:p>
+            <a:pPr algn="l" indent="0" marL="0">
+              <a:buNone/>
+            </a:pPr>
+            <a:r>
+              <a:rPr lang="cs-CZ" sz="900" dirty="0">
+                <a:solidFill>
+                  <a:srgbClr val="FFFFFF"/>
+                </a:solidFill>
+                <a:latin typeface="Calibri" pitchFamily="34" charset="0"/>
+                <a:ea typeface="Calibri" pitchFamily="34" charset="-122"/>
+                <a:cs typeface="Calibri" pitchFamily="34" charset="-120"/>
+              </a:rPr>
+              <a:t>Čas ušetřený na ovládání zůstává na to podstatné: role, oprávnění, datové toky.</a:t>
+            </a:r>
+          </a:p>
+        </p:txBody>
+      </p:sp>
+      <p:sp>
+        <p:nvSpPr>
+          <p:cNvPr id="16" name="Text 14"/>
+          <p:cNvSpPr txBox="1"/>
+          <p:nvPr/>
+        </p:nvSpPr>
+        <p:spPr>
+          <a:xfrm>
+            <a:off x="548640" y="4754880"/>
+            <a:ext cx="5486400" cy="274320"/>
+          </a:xfrm>
+          <a:prstGeom prst="rect">
+            <a:avLst/>
+          </a:prstGeom>
+          <a:noFill/>
+          <a:ln/>
+        </p:spPr>
+        <p:txBody>
+          <a:bodyPr wrap="square" lIns="0" tIns="0" rIns="0" bIns="0" rtlCol="0" anchor="ctr"/>
+          <a:lstStyle/>
+          <a:p>
+            <a:pPr indent="0" marL="0">
+              <a:buNone/>
+            </a:pPr>
+            <a:r>
+              <a:rPr lang="en-US" sz="900" dirty="0">
+                <a:solidFill>
+                  <a:srgbClr val="6B6680"/>
+                </a:solidFill>
+                <a:latin typeface="Calibri" pitchFamily="34" charset="0"/>
+                <a:ea typeface="Calibri" pitchFamily="34" charset="-122"/>
+                <a:cs typeface="Calibri" pitchFamily="34" charset="-120"/>
+              </a:rPr>
+              <a:t>Edu Stack IS · Obhajoba bakalářské práce · Petr Vích</a:t>
+            </a:r>
+            <a:endParaRPr lang="en-US" sz="900" dirty="0"/>
+          </a:p>
+        </p:txBody>
+      </p:sp>
+      <p:sp>
+        <p:nvSpPr>
+          <p:cNvPr id="17" name="Text 15"/>
+          <p:cNvSpPr txBox="1"/>
+          <p:nvPr/>
+        </p:nvSpPr>
+        <p:spPr>
+          <a:xfrm>
+            <a:off x="8138160" y="4754880"/>
+            <a:ext cx="457200" cy="274320"/>
+          </a:xfrm>
+          <a:prstGeom prst="rect">
+            <a:avLst/>
+          </a:prstGeom>
+          <a:noFill/>
+          <a:ln/>
+        </p:spPr>
+        <p:txBody>
+          <a:bodyPr wrap="square" lIns="0" tIns="0" rIns="0" bIns="0" rtlCol="0" anchor="ctr"/>
+          <a:lstStyle/>
+          <a:p>
+            <a:pPr algn="r" indent="0" marL="0">
+              <a:buNone/>
+            </a:pPr>
+            <a:r>
+              <a:rPr lang="en-US" sz="900" dirty="0">
+                <a:solidFill>
+                  <a:srgbClr val="6B6680"/>
+                </a:solidFill>
+                <a:latin typeface="Calibri" pitchFamily="34" charset="0"/>
+                <a:ea typeface="Calibri" pitchFamily="34" charset="-122"/>
+                <a:cs typeface="Calibri" pitchFamily="34" charset="-120"/>
+              </a:rPr>
+              <a:t>5</a:t>
             </a:r>
             <a:endParaRPr lang="en-US" sz="900" dirty="0"/>
           </a:p>
@@ -4095,7 +6067,7 @@
         <p:spPr>
           <a:xfrm>
             <a:off x="1417320" y="1600200"/>
-            <a:ext cx="7132320" cy="594360"/>
+            <a:ext cx="7132320" cy="640080"/>
           </a:xfrm>
           <a:prstGeom prst="rect">
             <a:avLst/>
@@ -4119,7 +6091,7 @@
                 <a:ea typeface="Calibri" pitchFamily="34" charset="-122"/>
                 <a:cs typeface="Calibri" pitchFamily="34" charset="-120"/>
               </a:rPr>
-              <a:t>Odlišit edukační IS od komerčních provozních systémů i od obecných výukových platforem (analýza podle 4 kritérií).</a:t>
+              <a:t>Odlišit edukační IS od komerčních školních systémů (Bakaláři, EduPage), od low-code nástrojů (Airtable, Notion) i od výukových platforem informatiky (Scratch, Umíme to). Čtyři kritéria: účel · role žáka · prostředí · otevřenost.</a:t>
             </a:r>
             <a:endParaRPr lang="en-US" sz="1300" dirty="0"/>
           </a:p>
@@ -4133,7 +6105,7 @@
         </p:nvSpPr>
         <p:spPr>
           <a:xfrm>
-            <a:off x="640080" y="2377440"/>
+            <a:off x="640080" y="2286000"/>
             <a:ext cx="548640" cy="548640"/>
           </a:xfrm>
           <a:prstGeom prst="ellipse">
@@ -4158,7 +6130,7 @@
         </p:nvSpPr>
         <p:spPr>
           <a:xfrm>
-            <a:off x="640080" y="2377440"/>
+            <a:off x="640080" y="2286000"/>
             <a:ext cx="548640" cy="548640"/>
           </a:xfrm>
           <a:prstGeom prst="rect">
@@ -4197,7 +6169,7 @@
         </p:nvSpPr>
         <p:spPr>
           <a:xfrm>
-            <a:off x="1417320" y="2286000"/>
+            <a:off x="1417320" y="2194560"/>
             <a:ext cx="7132320" cy="365760"/>
           </a:xfrm>
           <a:prstGeom prst="rect">
@@ -4236,24 +6208,27 @@
         </p:nvSpPr>
         <p:spPr>
           <a:xfrm>
-            <a:off x="1417320" y="2651760"/>
-            <a:ext cx="7132320" cy="594360"/>
-          </a:xfrm>
-          <a:prstGeom prst="rect">
-            <a:avLst/>
-          </a:prstGeom>
-          <a:noFill/>
-          <a:ln/>
-        </p:spPr>
-        <p:txBody>
-          <a:bodyPr wrap="square" lIns="0" tIns="0" rIns="0" bIns="0" rtlCol="0" anchor="t"/>
-          <a:lstStyle/>
-          <a:p>
-            <a:pPr indent="0" marL="0">
-              <a:buNone/>
-            </a:pPr>
-            <a:r>
-              <a:rPr lang="en-US" sz="1300" dirty="0">
+            <a:off x="1417320" y="2560320"/>
+            <a:ext cx="7132320" cy="640080"/>
+          </a:xfrm>
+          <a:prstGeom prst="rect">
+            <a:avLst/>
+          </a:prstGeom>
+          <a:noFill/>
+          <a:ln/>
+        </p:spPr>
+        <p:txBody>
+          <a:bodyPr numCol="2" spcCol="182880" wrap="square" lIns="0" tIns="0" rIns="0" bIns="0" rtlCol="0" anchor="t"/>
+          <a:lstStyle/>
+          <a:p>
+            <a:pPr marL="177800" indent="-177800">
+              <a:spcAft>
+                <a:spcPts val="100"/>
+              </a:spcAft>
+              <a:buChar char="•"/>
+            </a:pPr>
+            <a:r>
+              <a:rPr lang="en-US" sz="1200" dirty="0">
                 <a:solidFill>
                   <a:srgbClr val="24203A"/>
                 </a:solidFill>
@@ -4261,9 +6236,84 @@
                 <a:ea typeface="Calibri" pitchFamily="34" charset="-122"/>
                 <a:cs typeface="Calibri" pitchFamily="34" charset="-120"/>
               </a:rPr>
-              <a:t>Doménově věrný škole, otevřený, bezpečně resetovatelný, přístupný ve třech vrstvách hloubky; doplnit pracovní listy.</a:t>
-            </a:r>
-            <a:endParaRPr lang="en-US" sz="1300" dirty="0"/>
+              <a:t>doménový model věrný škole</a:t>
+            </a:r>
+          </a:p>
+          <a:p>
+            <a:pPr marL="177800" indent="-177800">
+              <a:spcAft>
+                <a:spcPts val="100"/>
+              </a:spcAft>
+              <a:buChar char="•"/>
+            </a:pPr>
+            <a:r>
+              <a:rPr lang="en-US" sz="1200" dirty="0">
+                <a:solidFill>
+                  <a:srgbClr val="24203A"/>
+                </a:solidFill>
+                <a:latin typeface="Calibri" pitchFamily="34" charset="0"/>
+                <a:ea typeface="Calibri" pitchFamily="34" charset="-122"/>
+                <a:cs typeface="Calibri" pitchFamily="34" charset="-120"/>
+              </a:rPr>
+              <a:t>otevřený systém (kód, datový model)</a:t>
+            </a:r>
+          </a:p>
+          <a:p>
+            <a:pPr marL="177800" indent="-177800">
+              <a:spcAft>
+                <a:spcPts val="100"/>
+              </a:spcAft>
+              <a:buChar char="•"/>
+            </a:pPr>
+            <a:r>
+              <a:rPr lang="en-US" sz="1200" dirty="0">
+                <a:solidFill>
+                  <a:srgbClr val="24203A"/>
+                </a:solidFill>
+                <a:latin typeface="Calibri" pitchFamily="34" charset="0"/>
+                <a:ea typeface="Calibri" pitchFamily="34" charset="-122"/>
+                <a:cs typeface="Calibri" pitchFamily="34" charset="-120"/>
+              </a:rPr>
+              <a:t>bezpečně resetovatelný sandbox</a:t>
+            </a:r>
+          </a:p>
+          <a:p>
+            <a:pPr marL="177800" indent="-177800">
+              <a:spcAft>
+                <a:spcPts val="100"/>
+              </a:spcAft>
+              <a:buChar char="•"/>
+            </a:pPr>
+            <a:r>
+              <a:rPr lang="en-US" sz="1200" dirty="0">
+                <a:solidFill>
+                  <a:srgbClr val="24203A"/>
+                </a:solidFill>
+                <a:latin typeface="Calibri" pitchFamily="34" charset="0"/>
+                <a:ea typeface="Calibri" pitchFamily="34" charset="-122"/>
+                <a:cs typeface="Calibri" pitchFamily="34" charset="-120"/>
+              </a:rPr>
+              <a:t>tři vrstvy hloubky: uživatelská · konfigurační · vývojářská</a:t>
+            </a:r>
+          </a:p>
+          <a:p>
+            <a:pPr marL="177800" indent="-177800">
+              <a:spcAft>
+                <a:spcPts val="100"/>
+              </a:spcAft>
+              <a:buChar char="•"/>
+            </a:pPr>
+            <a:r>
+              <a:rPr lang="en-US" sz="1200" dirty="0">
+                <a:solidFill>
+                  <a:srgbClr val="24203A"/>
+                </a:solidFill>
+                <a:latin typeface="Calibri" pitchFamily="34" charset="0"/>
+                <a:ea typeface="Calibri" pitchFamily="34" charset="-122"/>
+                <a:cs typeface="Calibri" pitchFamily="34" charset="-120"/>
+              </a:rPr>
+              <a:t>připravit pracovní listy pro podporu přípravy na výuku</a:t>
+            </a:r>
           </a:p>
         </p:txBody>
       </p:sp>
@@ -4275,7 +6325,7 @@
         </p:nvSpPr>
         <p:spPr>
           <a:xfrm>
-            <a:off x="640080" y="3429000"/>
+            <a:off x="640080" y="3337560"/>
             <a:ext cx="548640" cy="548640"/>
           </a:xfrm>
           <a:prstGeom prst="ellipse">
@@ -4300,7 +6350,7 @@
         </p:nvSpPr>
         <p:spPr>
           <a:xfrm>
-            <a:off x="640080" y="3429000"/>
+            <a:off x="640080" y="3337560"/>
             <a:ext cx="548640" cy="548640"/>
           </a:xfrm>
           <a:prstGeom prst="rect">
@@ -4339,7 +6389,7 @@
         </p:nvSpPr>
         <p:spPr>
           <a:xfrm>
-            <a:off x="1417320" y="3337560"/>
+            <a:off x="1417320" y="3246120"/>
             <a:ext cx="7132320" cy="365760"/>
           </a:xfrm>
           <a:prstGeom prst="rect">
@@ -4378,8 +6428,8 @@
         </p:nvSpPr>
         <p:spPr>
           <a:xfrm>
-            <a:off x="1417320" y="3703320"/>
-            <a:ext cx="7132320" cy="594360"/>
+            <a:off x="1417320" y="3611880"/>
+            <a:ext cx="7132320" cy="457200"/>
           </a:xfrm>
           <a:prstGeom prst="rect">
             <a:avLst/>
@@ -4417,8 +6467,8 @@
         </p:nvSpPr>
         <p:spPr>
           <a:xfrm>
-            <a:off x="548640" y="4251960"/>
-            <a:ext cx="8046720" cy="457200"/>
+            <a:off x="548640" y="4160520"/>
+            <a:ext cx="8046720" cy="502920"/>
           </a:xfrm>
           <a:prstGeom prst="roundRect">
             <a:avLst>
@@ -4444,8 +6494,8 @@
         </p:nvSpPr>
         <p:spPr>
           <a:xfrm>
-            <a:off x="731520" y="4251960"/>
-            <a:ext cx="7680960" cy="457200"/>
+            <a:off x="731520" y="4160520"/>
+            <a:ext cx="7680960" cy="502920"/>
           </a:xfrm>
           <a:prstGeom prst="rect">
             <a:avLst/>
@@ -4469,7 +6519,7 @@
                 <a:ea typeface="Calibri" pitchFamily="34" charset="-122"/>
                 <a:cs typeface="Calibri" pitchFamily="34" charset="-120"/>
               </a:rPr>
-              <a:t>Výzkumná otázka: </a:t>
+              <a:t>Předpoklad: </a:t>
             </a:r>
             <a:pPr indent="0" marL="0">
               <a:buNone/>
@@ -4483,7 +6533,7 @@
                 <a:ea typeface="Calibri" pitchFamily="34" charset="-122"/>
                 <a:cs typeface="Calibri" pitchFamily="34" charset="-120"/>
               </a:rPr>
-              <a:t>Lze řízenou simulací správy školy přivést žáka od pasivního používání IS k porozumění jeho rolím, oprávněním a datovým tokům?</a:t>
+              <a:t>Řízená simulace správy školy dovede žáka od pasivního používání IS k porozumění jeho rolím, oprávněním a datovým tokům.</a:t>
             </a:r>
             <a:endParaRPr lang="en-US" sz="1200" dirty="0"/>
           </a:p>
@@ -4632,7 +6682,7 @@
                 <a:ea typeface="Calibri" pitchFamily="34" charset="-122"/>
                 <a:cs typeface="Calibri" pitchFamily="34" charset="-120"/>
               </a:rPr>
-              <a:t>Software je pomůcka, těžiště je didaktické</a:t>
+              <a:t>Nejde o software, jde o to, co se na něm žák naučí</a:t>
             </a:r>
             <a:endParaRPr lang="en-US" sz="3000" dirty="0"/>
           </a:p>
@@ -4646,8 +6696,8 @@
         </p:nvSpPr>
         <p:spPr>
           <a:xfrm>
-            <a:off x="548640" y="1097280"/>
-            <a:ext cx="8046720" cy="640080"/>
+            <a:off x="548640" y="1051560"/>
+            <a:ext cx="8046720" cy="548640"/>
           </a:xfrm>
           <a:prstGeom prst="rect">
             <a:avLst/>
@@ -4663,7 +6713,7 @@
               <a:buNone/>
             </a:pPr>
             <a:r>
-              <a:rPr lang="en-US" sz="1400" dirty="0">
+              <a:rPr lang="en-US" sz="1300" dirty="0">
                 <a:solidFill>
                   <a:srgbClr val="24203A"/>
                 </a:solidFill>
@@ -4671,48 +6721,121 @@
                 <a:ea typeface="Calibri" pitchFamily="34" charset="-122"/>
                 <a:cs typeface="Calibri" pitchFamily="34" charset="-120"/>
               </a:rPr>
-              <a:t>Hlavní text práce je pedagogický: role, procesy, úrovně, úlohy. Technologie jsou vyčleněny do příloh (uživatelská příručka A, technická příloha B).</a:t>
-            </a:r>
-            <a:endParaRPr lang="en-US" sz="1400" dirty="0"/>
-          </a:p>
-        </p:txBody>
-      </p:sp>
-      <p:sp>
-        <p:nvSpPr>
-          <p:cNvPr id="4" name="Shape 2"/>
+              <a:t>Software je pomůcka. Hlavní text práce popisuje role, procesy, úrovně a úlohy; technologie jsou vyčleněny do příloh (uživatelská příručka A, technická příloha B).</a:t>
+            </a:r>
+            <a:endParaRPr lang="en-US" sz="1300" dirty="0"/>
+          </a:p>
+        </p:txBody>
+      </p:sp>
+      <p:sp>
+        <p:nvSpPr>
+          <p:cNvPr id="101" name="Text 101"/>
+          <p:cNvSpPr txBox="1"/>
+          <p:nvPr/>
+        </p:nvSpPr>
+        <p:spPr>
+          <a:xfrm>
+            <a:off x="548640" y="2103120"/>
+            <a:ext cx="2514600" cy="254000"/>
+          </a:xfrm>
+          <a:prstGeom prst="rect">
+            <a:avLst/>
+          </a:prstGeom>
+          <a:noFill/>
+          <a:ln/>
+        </p:spPr>
+        <p:txBody>
+          <a:bodyPr wrap="square" lIns="0" tIns="0" rIns="0" bIns="0" rtlCol="0" anchor="b"/>
+          <a:lstStyle/>
+          <a:p>
+            <a:pPr indent="0" marL="0">
+              <a:buNone/>
+            </a:pPr>
+            <a:r>
+              <a:rPr lang="cs-CZ" sz="1100" i="1" dirty="0">
+                <a:solidFill>
+                  <a:srgbClr val="6B6680"/>
+                </a:solidFill>
+                <a:latin typeface="Calibri" pitchFamily="34" charset="0"/>
+                <a:ea typeface="Calibri" pitchFamily="34" charset="-122"/>
+                <a:cs typeface="Calibri" pitchFamily="34" charset="-120"/>
+              </a:rPr>
+              <a:t>žák jako uživatel</a:t>
+            </a:r>
+          </a:p>
+        </p:txBody>
+      </p:sp>
+      <p:sp>
+        <p:nvSpPr>
+          <p:cNvPr id="102" name="Shape 102"/>
           <p:cNvSpPr/>
           <p:nvPr/>
         </p:nvSpPr>
         <p:spPr>
           <a:xfrm>
-            <a:off x="548640" y="3017520"/>
-            <a:ext cx="2514600" cy="1325880"/>
+            <a:off x="548640" y="2377440"/>
+            <a:ext cx="2514600" cy="914400"/>
           </a:xfrm>
           <a:prstGeom prst="roundRect">
             <a:avLst>
-              <a:gd name="adj" fmla="val 5517"/>
+              <a:gd name="adj" fmla="val 6000"/>
             </a:avLst>
           </a:prstGeom>
           <a:solidFill>
             <a:srgbClr val="B8B0D6"/>
           </a:solidFill>
-          <a:ln w="12700">
-            <a:solidFill>
-              <a:srgbClr val="B8B0D6"/>
-            </a:solidFill>
-            <a:prstDash val="solid"/>
+          <a:ln>
+            <a:noFill/>
           </a:ln>
         </p:spPr>
       </p:sp>
       <p:sp>
         <p:nvSpPr>
-          <p:cNvPr id="5" name="Text 3"/>
-          <p:cNvSpPr txBox="1"/>
-          <p:nvPr/>
-        </p:nvSpPr>
-        <p:spPr>
-          <a:xfrm>
-            <a:off x="685800" y="3127248"/>
+          <p:cNvPr id="103" name="Text 103"/>
+          <p:cNvSpPr txBox="1"/>
+          <p:nvPr/>
+        </p:nvSpPr>
+        <p:spPr>
+          <a:xfrm>
+            <a:off x="685800" y="2487168"/>
+            <a:ext cx="2240280" cy="365760"/>
+          </a:xfrm>
+          <a:prstGeom prst="rect">
+            <a:avLst/>
+          </a:prstGeom>
+          <a:noFill/>
+          <a:ln/>
+        </p:spPr>
+        <p:txBody>
+          <a:bodyPr wrap="square" lIns="0" tIns="0" rIns="0" bIns="0" rtlCol="0" anchor="t"/>
+          <a:lstStyle/>
+          <a:p>
+            <a:pPr indent="0" marL="0">
+              <a:buNone/>
+            </a:pPr>
+            <a:r>
+              <a:rPr lang="cs-CZ" sz="1300" b="1" dirty="0">
+                <a:solidFill>
+                  <a:srgbClr val="FFFFFF"/>
+                </a:solidFill>
+                <a:latin typeface="Calibri" pitchFamily="34" charset="0"/>
+                <a:ea typeface="Calibri" pitchFamily="34" charset="-122"/>
+                <a:cs typeface="Calibri" pitchFamily="34" charset="-120"/>
+              </a:rPr>
+              <a:t>zapamatovat / porozumět</a:t>
+            </a:r>
+          </a:p>
+        </p:txBody>
+      </p:sp>
+      <p:sp>
+        <p:nvSpPr>
+          <p:cNvPr id="104" name="Text 104"/>
+          <p:cNvSpPr txBox="1"/>
+          <p:nvPr/>
+        </p:nvSpPr>
+        <p:spPr>
+          <a:xfrm>
+            <a:off x="685800" y="2834640"/>
             <a:ext cx="2240280" cy="411480"/>
           </a:xfrm>
           <a:prstGeom prst="rect">
@@ -4722,14 +6845,14 @@
           <a:ln/>
         </p:spPr>
         <p:txBody>
-          <a:bodyPr wrap="square" lIns="0" tIns="0" rIns="0" bIns="0" rtlCol="0" anchor="ctr"/>
-          <a:lstStyle/>
-          <a:p>
-            <a:pPr indent="0" marL="0">
-              <a:buNone/>
-            </a:pPr>
-            <a:r>
-              <a:rPr lang="en-US" sz="1300" b="1" dirty="0">
+          <a:bodyPr wrap="square" lIns="0" tIns="0" rIns="0" bIns="0" rtlCol="0" anchor="t"/>
+          <a:lstStyle/>
+          <a:p>
+            <a:pPr indent="0" marL="0">
+              <a:buNone/>
+            </a:pPr>
+            <a:r>
+              <a:rPr lang="cs-CZ" sz="1100" dirty="0">
                 <a:solidFill>
                   <a:srgbClr val="FFFFFF"/>
                 </a:solidFill>
@@ -4737,104 +6860,99 @@
                 <a:ea typeface="Calibri" pitchFamily="34" charset="-122"/>
                 <a:cs typeface="Calibri" pitchFamily="34" charset="-120"/>
               </a:rPr>
-              <a:t>zapamatovat / porozumět</a:t>
-            </a:r>
-            <a:endParaRPr lang="en-US" sz="1300" dirty="0"/>
-          </a:p>
-        </p:txBody>
-      </p:sp>
-      <p:sp>
-        <p:nvSpPr>
-          <p:cNvPr id="6" name="Text 4"/>
-          <p:cNvSpPr txBox="1"/>
-          <p:nvPr/>
-        </p:nvSpPr>
-        <p:spPr>
-          <a:xfrm>
-            <a:off x="685800" y="3520440"/>
-            <a:ext cx="2240280" cy="640080"/>
-          </a:xfrm>
-          <a:prstGeom prst="rect">
-            <a:avLst/>
-          </a:prstGeom>
-          <a:noFill/>
-          <a:ln/>
-        </p:spPr>
-        <p:txBody>
-          <a:bodyPr wrap="square" lIns="0" tIns="0" rIns="0" bIns="0" rtlCol="0" anchor="t"/>
-          <a:lstStyle/>
-          <a:p>
-            <a:pPr indent="0" marL="0">
-              <a:buNone/>
-            </a:pPr>
-            <a:r>
-              <a:rPr lang="en-US" sz="1100" dirty="0">
-                <a:solidFill>
-                  <a:srgbClr val="FFFFFF"/>
-                </a:solidFill>
-                <a:latin typeface="Calibri" pitchFamily="34" charset="0"/>
-                <a:ea typeface="Calibri" pitchFamily="34" charset="-122"/>
-                <a:cs typeface="Calibri" pitchFamily="34" charset="-120"/>
-              </a:rPr>
               <a:t>žák čte známku, kterou eviduje někdo jiný</a:t>
             </a:r>
-            <a:endParaRPr lang="en-US" sz="1100" dirty="0"/>
-          </a:p>
-        </p:txBody>
-      </p:sp>
-      <p:sp>
-        <p:nvSpPr>
-          <p:cNvPr id="7" name="Shape 5"/>
+          </a:p>
+        </p:txBody>
+      </p:sp>
+      <p:sp>
+        <p:nvSpPr>
+          <p:cNvPr id="105" name="Text 105"/>
+          <p:cNvSpPr txBox="1"/>
+          <p:nvPr/>
+        </p:nvSpPr>
+        <p:spPr>
+          <a:xfrm>
+            <a:off x="3246120" y="1874520"/>
+            <a:ext cx="2514600" cy="254000"/>
+          </a:xfrm>
+          <a:prstGeom prst="rect">
+            <a:avLst/>
+          </a:prstGeom>
+          <a:noFill/>
+          <a:ln/>
+        </p:spPr>
+        <p:txBody>
+          <a:bodyPr wrap="square" lIns="0" tIns="0" rIns="0" bIns="0" rtlCol="0" anchor="b"/>
+          <a:lstStyle/>
+          <a:p>
+            <a:pPr indent="0" marL="0">
+              <a:buNone/>
+            </a:pPr>
+            <a:r>
+              <a:rPr lang="cs-CZ" sz="1100" i="1" dirty="0">
+                <a:solidFill>
+                  <a:srgbClr val="6B6680"/>
+                </a:solidFill>
+                <a:latin typeface="Calibri" pitchFamily="34" charset="0"/>
+                <a:ea typeface="Calibri" pitchFamily="34" charset="-122"/>
+                <a:cs typeface="Calibri" pitchFamily="34" charset="-120"/>
+              </a:rPr>
+              <a:t>žák jako správce</a:t>
+            </a:r>
+          </a:p>
+        </p:txBody>
+      </p:sp>
+      <p:sp>
+        <p:nvSpPr>
+          <p:cNvPr id="106" name="Shape 106"/>
           <p:cNvSpPr/>
           <p:nvPr/>
         </p:nvSpPr>
         <p:spPr>
           <a:xfrm>
-            <a:off x="3246120" y="2514600"/>
-            <a:ext cx="2514600" cy="1828800"/>
+            <a:off x="3246120" y="2148840"/>
+            <a:ext cx="2514600" cy="1143000"/>
           </a:xfrm>
           <a:prstGeom prst="roundRect">
             <a:avLst>
-              <a:gd name="adj" fmla="val 4000"/>
+              <a:gd name="adj" fmla="val 6000"/>
             </a:avLst>
           </a:prstGeom>
           <a:solidFill>
             <a:srgbClr val="8F7BCB"/>
           </a:solidFill>
-          <a:ln w="12700">
-            <a:solidFill>
-              <a:srgbClr val="8F7BCB"/>
-            </a:solidFill>
-            <a:prstDash val="solid"/>
+          <a:ln>
+            <a:noFill/>
           </a:ln>
         </p:spPr>
       </p:sp>
       <p:sp>
         <p:nvSpPr>
-          <p:cNvPr id="8" name="Text 6"/>
-          <p:cNvSpPr txBox="1"/>
-          <p:nvPr/>
-        </p:nvSpPr>
-        <p:spPr>
-          <a:xfrm>
-            <a:off x="3383280" y="2624328"/>
-            <a:ext cx="2240280" cy="411480"/>
-          </a:xfrm>
-          <a:prstGeom prst="rect">
-            <a:avLst/>
-          </a:prstGeom>
-          <a:noFill/>
-          <a:ln/>
-        </p:spPr>
-        <p:txBody>
-          <a:bodyPr wrap="square" lIns="0" tIns="0" rIns="0" bIns="0" rtlCol="0" anchor="ctr"/>
-          <a:lstStyle/>
-          <a:p>
-            <a:pPr indent="0" marL="0">
-              <a:buNone/>
-            </a:pPr>
-            <a:r>
-              <a:rPr lang="en-US" sz="1300" b="1" dirty="0">
+          <p:cNvPr id="107" name="Text 107"/>
+          <p:cNvSpPr txBox="1"/>
+          <p:nvPr/>
+        </p:nvSpPr>
+        <p:spPr>
+          <a:xfrm>
+            <a:off x="3383280" y="2258568"/>
+            <a:ext cx="2240280" cy="365760"/>
+          </a:xfrm>
+          <a:prstGeom prst="rect">
+            <a:avLst/>
+          </a:prstGeom>
+          <a:noFill/>
+          <a:ln/>
+        </p:spPr>
+        <p:txBody>
+          <a:bodyPr wrap="square" lIns="0" tIns="0" rIns="0" bIns="0" rtlCol="0" anchor="t"/>
+          <a:lstStyle/>
+          <a:p>
+            <a:pPr indent="0" marL="0">
+              <a:buNone/>
+            </a:pPr>
+            <a:r>
+              <a:rPr lang="cs-CZ" sz="1300" b="1" dirty="0">
                 <a:solidFill>
                   <a:srgbClr val="FFFFFF"/>
                 </a:solidFill>
@@ -4844,19 +6962,18 @@
               </a:rPr>
               <a:t>aplikovat / analyzovat</a:t>
             </a:r>
-            <a:endParaRPr lang="en-US" sz="1300" dirty="0"/>
-          </a:p>
-        </p:txBody>
-      </p:sp>
-      <p:sp>
-        <p:nvSpPr>
-          <p:cNvPr id="9" name="Text 7"/>
-          <p:cNvSpPr txBox="1"/>
-          <p:nvPr/>
-        </p:nvSpPr>
-        <p:spPr>
-          <a:xfrm>
-            <a:off x="3383280" y="3017520"/>
+          </a:p>
+        </p:txBody>
+      </p:sp>
+      <p:sp>
+        <p:nvSpPr>
+          <p:cNvPr id="108" name="Text 108"/>
+          <p:cNvSpPr txBox="1"/>
+          <p:nvPr/>
+        </p:nvSpPr>
+        <p:spPr>
+          <a:xfrm>
+            <a:off x="3383280" y="2606040"/>
             <a:ext cx="2240280" cy="640080"/>
           </a:xfrm>
           <a:prstGeom prst="rect">
@@ -4873,7 +6990,7 @@
               <a:buNone/>
             </a:pPr>
             <a:r>
-              <a:rPr lang="en-US" sz="1100" dirty="0">
+              <a:rPr lang="cs-CZ" sz="1100" dirty="0">
                 <a:solidFill>
                   <a:srgbClr val="FFFFFF"/>
                 </a:solidFill>
@@ -4883,63 +7000,97 @@
               </a:rPr>
               <a:t>žák zakládá třídu, řeší kolizi v rozvrhu</a:t>
             </a:r>
-            <a:endParaRPr lang="en-US" sz="1100" dirty="0"/>
-          </a:p>
-        </p:txBody>
-      </p:sp>
-      <p:sp>
-        <p:nvSpPr>
-          <p:cNvPr id="10" name="Shape 8"/>
+          </a:p>
+        </p:txBody>
+      </p:sp>
+      <p:sp>
+        <p:nvSpPr>
+          <p:cNvPr id="109" name="Text 109"/>
+          <p:cNvSpPr txBox="1"/>
+          <p:nvPr/>
+        </p:nvSpPr>
+        <p:spPr>
+          <a:xfrm>
+            <a:off x="5943600" y="1645920"/>
+            <a:ext cx="2514600" cy="254000"/>
+          </a:xfrm>
+          <a:prstGeom prst="rect">
+            <a:avLst/>
+          </a:prstGeom>
+          <a:noFill/>
+          <a:ln/>
+        </p:spPr>
+        <p:txBody>
+          <a:bodyPr wrap="square" lIns="0" tIns="0" rIns="0" bIns="0" rtlCol="0" anchor="b"/>
+          <a:lstStyle/>
+          <a:p>
+            <a:pPr indent="0" marL="0">
+              <a:buNone/>
+            </a:pPr>
+            <a:r>
+              <a:rPr lang="cs-CZ" sz="1100" i="1" dirty="0">
+                <a:solidFill>
+                  <a:srgbClr val="6B6680"/>
+                </a:solidFill>
+                <a:latin typeface="Calibri" pitchFamily="34" charset="0"/>
+                <a:ea typeface="Calibri" pitchFamily="34" charset="-122"/>
+                <a:cs typeface="Calibri" pitchFamily="34" charset="-120"/>
+              </a:rPr>
+              <a:t>žák jako spolutvůrce</a:t>
+            </a:r>
+          </a:p>
+        </p:txBody>
+      </p:sp>
+      <p:sp>
+        <p:nvSpPr>
+          <p:cNvPr id="110" name="Shape 110"/>
           <p:cNvSpPr/>
           <p:nvPr/>
         </p:nvSpPr>
         <p:spPr>
           <a:xfrm>
-            <a:off x="5943600" y="2011680"/>
-            <a:ext cx="2514600" cy="2331720"/>
+            <a:off x="5943600" y="1920240"/>
+            <a:ext cx="2514600" cy="1371600"/>
           </a:xfrm>
           <a:prstGeom prst="roundRect">
             <a:avLst>
-              <a:gd name="adj" fmla="val 3137"/>
+              <a:gd name="adj" fmla="val 6000"/>
             </a:avLst>
           </a:prstGeom>
           <a:solidFill>
             <a:srgbClr val="6544AF"/>
           </a:solidFill>
-          <a:ln w="12700">
-            <a:solidFill>
-              <a:srgbClr val="6544AF"/>
-            </a:solidFill>
-            <a:prstDash val="solid"/>
+          <a:ln>
+            <a:noFill/>
           </a:ln>
         </p:spPr>
       </p:sp>
       <p:sp>
         <p:nvSpPr>
-          <p:cNvPr id="11" name="Text 9"/>
-          <p:cNvSpPr txBox="1"/>
-          <p:nvPr/>
-        </p:nvSpPr>
-        <p:spPr>
-          <a:xfrm>
-            <a:off x="6080760" y="2121408"/>
-            <a:ext cx="2240280" cy="411480"/>
-          </a:xfrm>
-          <a:prstGeom prst="rect">
-            <a:avLst/>
-          </a:prstGeom>
-          <a:noFill/>
-          <a:ln/>
-        </p:spPr>
-        <p:txBody>
-          <a:bodyPr wrap="square" lIns="0" tIns="0" rIns="0" bIns="0" rtlCol="0" anchor="ctr"/>
-          <a:lstStyle/>
-          <a:p>
-            <a:pPr indent="0" marL="0">
-              <a:buNone/>
-            </a:pPr>
-            <a:r>
-              <a:rPr lang="en-US" sz="1300" b="1" dirty="0">
+          <p:cNvPr id="111" name="Text 111"/>
+          <p:cNvSpPr txBox="1"/>
+          <p:nvPr/>
+        </p:nvSpPr>
+        <p:spPr>
+          <a:xfrm>
+            <a:off x="6080760" y="2029968"/>
+            <a:ext cx="2240280" cy="365760"/>
+          </a:xfrm>
+          <a:prstGeom prst="rect">
+            <a:avLst/>
+          </a:prstGeom>
+          <a:noFill/>
+          <a:ln/>
+        </p:spPr>
+        <p:txBody>
+          <a:bodyPr wrap="square" lIns="0" tIns="0" rIns="0" bIns="0" rtlCol="0" anchor="t"/>
+          <a:lstStyle/>
+          <a:p>
+            <a:pPr indent="0" marL="0">
+              <a:buNone/>
+            </a:pPr>
+            <a:r>
+              <a:rPr lang="cs-CZ" sz="1300" b="1" dirty="0">
                 <a:solidFill>
                   <a:srgbClr val="FFFFFF"/>
                 </a:solidFill>
@@ -4949,20 +7100,19 @@
               </a:rPr>
               <a:t>hodnotit / tvořit</a:t>
             </a:r>
-            <a:endParaRPr lang="en-US" sz="1300" dirty="0"/>
-          </a:p>
-        </p:txBody>
-      </p:sp>
-      <p:sp>
-        <p:nvSpPr>
-          <p:cNvPr id="12" name="Text 10"/>
-          <p:cNvSpPr txBox="1"/>
-          <p:nvPr/>
-        </p:nvSpPr>
-        <p:spPr>
-          <a:xfrm>
-            <a:off x="6080760" y="2514600"/>
-            <a:ext cx="2240280" cy="640080"/>
+          </a:p>
+        </p:txBody>
+      </p:sp>
+      <p:sp>
+        <p:nvSpPr>
+          <p:cNvPr id="112" name="Text 112"/>
+          <p:cNvSpPr txBox="1"/>
+          <p:nvPr/>
+        </p:nvSpPr>
+        <p:spPr>
+          <a:xfrm>
+            <a:off x="6080760" y="2377440"/>
+            <a:ext cx="2240280" cy="868680"/>
           </a:xfrm>
           <a:prstGeom prst="rect">
             <a:avLst/>
@@ -4978,7 +7128,7 @@
               <a:buNone/>
             </a:pPr>
             <a:r>
-              <a:rPr lang="en-US" sz="1100" dirty="0">
+              <a:rPr lang="cs-CZ" sz="1100" dirty="0">
                 <a:solidFill>
                   <a:srgbClr val="FFFFFF"/>
                 </a:solidFill>
@@ -4988,114 +7138,35 @@
               </a:rPr>
               <a:t>žák navrhuje modul, čte ER diagram, volá API</a:t>
             </a:r>
-            <a:endParaRPr lang="en-US" sz="1100" dirty="0"/>
-          </a:p>
-        </p:txBody>
-      </p:sp>
-      <p:sp>
-        <p:nvSpPr>
-          <p:cNvPr id="13" name="Text 11"/>
-          <p:cNvSpPr txBox="1"/>
-          <p:nvPr/>
-        </p:nvSpPr>
-        <p:spPr>
-          <a:xfrm>
-            <a:off x="548640" y="2697480"/>
-            <a:ext cx="2514600" cy="274320"/>
-          </a:xfrm>
-          <a:prstGeom prst="rect">
-            <a:avLst/>
-          </a:prstGeom>
-          <a:noFill/>
-          <a:ln/>
-        </p:spPr>
-        <p:txBody>
-          <a:bodyPr wrap="square" lIns="0" tIns="0" rIns="0" bIns="0" rtlCol="0" anchor="ctr"/>
-          <a:lstStyle/>
-          <a:p>
-            <a:pPr indent="0" marL="0">
-              <a:buNone/>
-            </a:pPr>
-            <a:r>
-              <a:rPr lang="en-US" sz="1100" i="1" dirty="0">
-                <a:solidFill>
-                  <a:srgbClr val="6B6680"/>
-                </a:solidFill>
-                <a:latin typeface="Calibri" pitchFamily="34" charset="0"/>
-                <a:ea typeface="Calibri" pitchFamily="34" charset="-122"/>
-                <a:cs typeface="Calibri" pitchFamily="34" charset="-120"/>
-              </a:rPr>
-              <a:t>Komerční ŠIS</a:t>
-            </a:r>
-            <a:endParaRPr lang="en-US" sz="1100" dirty="0"/>
-          </a:p>
-        </p:txBody>
-      </p:sp>
-      <p:sp>
-        <p:nvSpPr>
-          <p:cNvPr id="14" name="Text 12"/>
-          <p:cNvSpPr txBox="1"/>
-          <p:nvPr/>
-        </p:nvSpPr>
-        <p:spPr>
-          <a:xfrm>
-            <a:off x="5943600" y="1691640"/>
-            <a:ext cx="2514600" cy="274320"/>
-          </a:xfrm>
-          <a:prstGeom prst="rect">
-            <a:avLst/>
-          </a:prstGeom>
-          <a:noFill/>
-          <a:ln/>
-        </p:spPr>
-        <p:txBody>
-          <a:bodyPr wrap="square" lIns="0" tIns="0" rIns="0" bIns="0" rtlCol="0" anchor="ctr"/>
-          <a:lstStyle/>
-          <a:p>
-            <a:pPr indent="0" marL="0">
-              <a:buNone/>
-            </a:pPr>
-            <a:r>
-              <a:rPr lang="en-US" sz="1100" i="1" dirty="0">
-                <a:solidFill>
-                  <a:srgbClr val="6B6680"/>
-                </a:solidFill>
-                <a:latin typeface="Calibri" pitchFamily="34" charset="0"/>
-                <a:ea typeface="Calibri" pitchFamily="34" charset="-122"/>
-                <a:cs typeface="Calibri" pitchFamily="34" charset="-120"/>
-              </a:rPr>
-              <a:t>Edu Stack IS</a:t>
-            </a:r>
-            <a:endParaRPr lang="en-US" sz="1100" dirty="0"/>
-          </a:p>
-        </p:txBody>
-      </p:sp>
-      <p:sp>
-        <p:nvSpPr>
-          <p:cNvPr id="15" name="Text 13"/>
-          <p:cNvSpPr txBox="1"/>
-          <p:nvPr/>
-        </p:nvSpPr>
-        <p:spPr>
-          <a:xfrm>
-            <a:off x="548640" y="4434840"/>
-            <a:ext cx="8046720" cy="274320"/>
-          </a:xfrm>
-          <a:prstGeom prst="rect">
-            <a:avLst/>
-          </a:prstGeom>
-          <a:noFill/>
-          <a:ln/>
-        </p:spPr>
-        <p:txBody>
-          <a:bodyPr wrap="square" lIns="0" tIns="0" rIns="0" bIns="0" rtlCol="0" anchor="ctr"/>
-          <a:lstStyle/>
-          <a:p>
-            <a:pPr indent="0" marL="0">
-              <a:buNone/>
-            </a:pPr>
-            <a:r>
-              <a:rPr lang="en-US" sz="1200" b="1" dirty="0">
+          </a:p>
+        </p:txBody>
+      </p:sp>
+      <p:sp>
+        <p:nvSpPr>
+          <p:cNvPr id="113" name="Text 113"/>
+          <p:cNvSpPr txBox="1"/>
+          <p:nvPr/>
+        </p:nvSpPr>
+        <p:spPr>
+          <a:xfrm>
+            <a:off x="548640" y="3474720"/>
+            <a:ext cx="8046720" cy="254000"/>
+          </a:xfrm>
+          <a:prstGeom prst="rect">
+            <a:avLst/>
+          </a:prstGeom>
+          <a:noFill/>
+          <a:ln/>
+        </p:spPr>
+        <p:txBody>
+          <a:bodyPr wrap="square" lIns="0" tIns="0" rIns="0" bIns="0" rtlCol="0" anchor="t"/>
+          <a:lstStyle/>
+          <a:p>
+            <a:pPr indent="0" marL="0">
+              <a:buNone/>
+            </a:pPr>
+            <a:r>
+              <a:rPr lang="cs-CZ" sz="1200" b="1" dirty="0">
                 <a:solidFill>
                   <a:srgbClr val="3F2A78"/>
                 </a:solidFill>
@@ -5105,7 +7176,6 @@
               </a:rPr>
               <a:t>Posun po Bloomově taxonomii: od uživatele k modeláři a správci</a:t>
             </a:r>
-            <a:endParaRPr lang="en-US" sz="1200" dirty="0"/>
           </a:p>
         </p:txBody>
       </p:sp>
@@ -5357,7 +7427,7 @@
                 <a:ea typeface="Calibri" pitchFamily="34" charset="-122"/>
                 <a:cs typeface="Calibri" pitchFamily="34" charset="-120"/>
               </a:rPr>
-              <a:t>Žádné reálné osoby, žádné GDPR riziko. Cvičnou školu vygeneruje učitel jedním klikem (tisíce záznamů).</a:t>
+              <a:t>Žádné reálné osoby, žádné GDPR riziko. Cvičnou školu vygeneruje učitel na pár kliků (stovky záznamů).</a:t>
             </a:r>
             <a:endParaRPr lang="en-US" sz="1200" dirty="0"/>
           </a:p>
@@ -5462,7 +7532,7 @@
                 <a:ea typeface="Calibri" pitchFamily="34" charset="-122"/>
                 <a:cs typeface="Calibri" pitchFamily="34" charset="-120"/>
               </a:rPr>
-              <a:t>Každá třída má vlastní izolovanou instanci (multitenance). Po hodině se vrátí do výchozího stavu – beze stopy.</a:t>
+              <a:t>Každá cvičná škola má vlastní oddělený datový prostor (multitenance). Po hodině se vrátí do výchozího stavu – beze stopy.</a:t>
             </a:r>
             <a:endParaRPr lang="en-US" sz="1200" dirty="0"/>
           </a:p>
@@ -5684,7 +7754,7 @@
                 <a:ea typeface="Calibri" pitchFamily="34" charset="-122"/>
                 <a:cs typeface="Calibri" pitchFamily="34" charset="-120"/>
               </a:rPr>
-              <a:t>5</a:t>
+              <a:t>7</a:t>
             </a:r>
             <a:endParaRPr lang="en-US" sz="900" dirty="0"/>
           </a:p>
@@ -6580,7 +8650,7 @@
                 <a:ea typeface="Calibri" pitchFamily="34" charset="-122"/>
                 <a:cs typeface="Calibri" pitchFamily="34" charset="-120"/>
               </a:rPr>
-              <a:t>RBAC „zdola“</a:t>
+              <a:t>nejnižší role: co smím vidět a co ne</a:t>
             </a:r>
             <a:endParaRPr lang="en-US" sz="1200" dirty="0"/>
           </a:p>
@@ -7361,7 +9431,7 @@
                 <a:ea typeface="Calibri" pitchFamily="34" charset="-122"/>
                 <a:cs typeface="Calibri" pitchFamily="34" charset="-120"/>
               </a:rPr>
-              <a:t>7</a:t>
+              <a:t>8</a:t>
             </a:r>
             <a:endParaRPr lang="en-US" sz="900" dirty="0"/>
           </a:p>
@@ -8245,7 +10315,7 @@
                 <a:ea typeface="Calibri" pitchFamily="34" charset="-122"/>
                 <a:cs typeface="Calibri" pitchFamily="34" charset="-120"/>
               </a:rPr>
-              <a:t>Cloud (Fly.io + Cloudflare) i lokální běh bez internetu</a:t>
+              <a:t>Nasazení: cloud (Fly.io + Cloudflare) i lokální běh bez internetu</a:t>
             </a:r>
             <a:endParaRPr lang="en-US" sz="1050" dirty="0"/>
           </a:p>
@@ -8266,7 +10336,7 @@
                 <a:ea typeface="Calibri" pitchFamily="34" charset="-122"/>
                 <a:cs typeface="Calibri" pitchFamily="34" charset="-120"/>
               </a:rPr>
-              <a:t>Hesla Argon2, citlivé sloupce šifrované, SSO Google/GitHub/Microsoft</a:t>
+              <a:t>Bezpečnost: hesla Argon2, citlivé sloupce šifrované, SSO Google/GitHub/Microsoft</a:t>
             </a:r>
             <a:endParaRPr lang="en-US" sz="1050" dirty="0"/>
           </a:p>
@@ -8344,7 +10414,7 @@
                 <a:ea typeface="Calibri" pitchFamily="34" charset="-122"/>
                 <a:cs typeface="Calibri" pitchFamily="34" charset="-120"/>
               </a:rPr>
-              <a:t>8</a:t>
+              <a:t>9</a:t>
             </a:r>
             <a:endParaRPr lang="en-US" sz="900" dirty="0"/>
           </a:p>
@@ -9054,7 +11124,7 @@
                 <a:ea typeface="Calibri" pitchFamily="34" charset="-122"/>
                 <a:cs typeface="Calibri" pitchFamily="34" charset="-120"/>
               </a:rPr>
-              <a:t>9</a:t>
+              <a:t>10</a:t>
             </a:r>
             <a:endParaRPr lang="en-US" sz="900" dirty="0"/>
           </a:p>

</xml_diff>

<commit_message>
Prohození slidů 5 a 6: jeden systém před porovnáním nástrojů
Pořadí bloku principů: didaktika (4), jeden systém (5), jeden nástroj (6), chyba (7).
Přečíslované kartičky, časy, věty na přechod, poznámky řečníka, osnova, scénář, PPTX a PDF.

Co-Authored-By: Claude Fable 5.1 <noreply@anthropic.com>
</commit_message>
<xml_diff>
--- a/obhajoba-edustack.pptx
+++ b/obhajoba-edustack.pptx
@@ -9,8 +9,8 @@
     <p:sldId id="257" r:id="rId3"/>
     <p:sldId id="258" r:id="rId4"/>
     <p:sldId id="259" r:id="rId5"/>
+    <p:sldId id="261" r:id="rId7"/>
     <p:sldId id="268" r:id="rId19"/>
-    <p:sldId id="261" r:id="rId7"/>
     <p:sldId id="260" r:id="rId6"/>
     <p:sldId id="262" r:id="rId8"/>
     <p:sldId id="263" r:id="rId9"/>
@@ -866,7 +866,7 @@
           <a:p>
             <a:r>
               <a:rPr lang="en-US" dirty="0"/>
-              <a:t>Proč jeden nástroj. V běžné praxi by žák potřeboval tři prostředí – něco na algoritmy, něco na modelování dat, něco na správu systému – a v každém se znovu učit ovládání. Edu Stack IS pokrývá všechny fáze v jednom prostředí: tatáž škola, tytéž role a data. Nižší kognitivní zátěž – žák se neučí nový nástroj, ale nový pohled na známý systém. Tím zbývá víc času na obsah: role, oprávnění, datové toky. Porovnání vychází ze srovnávací tabulky v kapitole 5 práce. Přechod: a ten jeden systém roste se žákem – tři vrstvy hloubky.</a:t>
+              <a:t>Proč jeden nástroj. V běžné praxi by žák potřeboval tři prostředí – něco na algoritmy, něco na modelování dat, něco na správu systému – a v každém se znovu učit ovládání. Edu Stack IS pokrývá všechny fáze v jednom prostředí: tatáž škola, tytéž role a data. Nižší kognitivní zátěž – žák se neučí nový nástroj, ale nový pohled na známý systém. Tím zbývá víc času na obsah: role, oprávnění, datové toky. Porovnání vychází ze srovnávací tabulky v kapitole 5 práce. Přechod: aby to fungovalo, musí být dovoleno dělat chyby.</a:t>
             </a:r>
             <a:endParaRPr lang="en-US" dirty="0"/>
           </a:p>
@@ -889,7 +889,7 @@
           <a:p>
             <a:fld id="{F7021451-1387-4CA6-816F-3879F97B5CBC}" type="slidenum">
               <a:rPr lang="en-US"/>
-              <a:t>5</a:t>
+              <a:t>6</a:t>
             </a:fld>
             <a:endParaRPr lang="en-US"/>
           </a:p>
@@ -1130,7 +1130,7 @@
           <a:p>
             <a:r>
               <a:rPr lang="en-US" dirty="0"/>
-              <a:t>Nejde o technickou práci. Software je pomůcka; hlavní text je didaktický a technika je v přílohách. Pedagogické jádro: posun po Bloomově taxonomii – žák jako uživatel jen čte známku; jako správce aplikuje a analyzuje (založí třídu, řeší kolizi); jako spolutvůrce hodnotí a tvoří (navrhne modul, čte ER diagram). Přechod: a proč na to stačí jeden nástroj.</a:t>
+              <a:t>Nejde o technickou práci. Software je pomůcka; hlavní text je didaktický a technika je v přílohách. Pedagogické jádro: posun po Bloomově taxonomii – žák jako uživatel jen čte známku; jako správce aplikuje a analyzuje (založí třídu, řeší kolizi); jako spolutvůrce hodnotí a tvoří (navrhne modul, čte ER diagram). Přechod: a jak jeden systém roste se žákem.</a:t>
             </a:r>
             <a:endParaRPr lang="en-US" dirty="0"/>
           </a:p>
@@ -1306,7 +1306,7 @@
           <a:p>
             <a:r>
               <a:rPr lang="en-US" dirty="0"/>
-              <a:t>Druhý princip: není to tři různé aplikace, ale jeden plnohodnotný systém se třemi vrstvami hloubky. Na 1. stupni žák pozoruje – role jako pohled. Na 2. stupni spravuje strukturu – třídy, předměty, rozvrh. Na SŠ jde pod kapotu – ER diagram, API, vlastní modul. Mění se jen kompetence žáka v čase, systém zůstává. Podle stupňů existují tři pracovní listy s klíčem pro učitele. Přechod: aby to fungovalo, musí být dovoleno dělat chyby.</a:t>
+              <a:t>Druhý princip: není to tři různé aplikace, ale jeden plnohodnotný systém se třemi vrstvami hloubky. Na 1. stupni žák pozoruje – role jako pohled. Na 2. stupni spravuje strukturu – třídy, předměty, rozvrh. Na SŠ jde pod kapotu – ER diagram, API, vlastní modul. Mění se jen kompetence žáka v čase, systém zůstává. Podle stupňů existují tři pracovní listy s klíčem pro učitele. Přechod: a proč na to stačí jeden nástroj.</a:t>
             </a:r>
             <a:endParaRPr lang="en-US" dirty="0"/>
           </a:p>
@@ -1329,7 +1329,7 @@
           <a:p>
             <a:fld id="{F7021451-1387-4CA6-816F-3879F97B5CBC}" type="slidenum">
               <a:rPr lang="en-US"/>
-              <a:t>6</a:t>
+              <a:t>5</a:t>
             </a:fld>
             <a:endParaRPr lang="en-US"/>
           </a:p>
@@ -5473,7 +5473,7 @@
                 <a:ea typeface="Calibri" pitchFamily="34" charset="-122"/>
                 <a:cs typeface="Calibri" pitchFamily="34" charset="-120"/>
               </a:rPr>
-              <a:t>5</a:t>
+              <a:t>6</a:t>
             </a:r>
             <a:endParaRPr lang="en-US" sz="900" dirty="0"/>
           </a:p>
@@ -8308,7 +8308,7 @@
                 <a:ea typeface="Calibri" pitchFamily="34" charset="-122"/>
                 <a:cs typeface="Calibri" pitchFamily="34" charset="-120"/>
               </a:rPr>
-              <a:t>6</a:t>
+              <a:t>5</a:t>
             </a:r>
             <a:endParaRPr lang="en-US" sz="900" dirty="0"/>
           </a:p>

</xml_diff>

<commit_message>
Sloučení slidů 4 a 5: Jeden systém pro všechny s Bloomovým žebříkem
Nadpis a vrstvy podle stupňů školy ze slidu 5, vizuál (žebřík) a didaktický
rámec ze slidu 4. Prezentace má 11 slidů + doplňující. Přečíslované kartičky
(16 karet, 3 strany), časy, poznámky řečníka, osnova, scénář, rozcestník
a README; PPTX a PDF přestavěné, PPTX validováno.

Co-Authored-By: Claude Fable 5.1 <noreply@anthropic.com>
</commit_message>
<xml_diff>
--- a/obhajoba-edustack.pptx
+++ b/obhajoba-edustack.pptx
@@ -9,7 +9,6 @@
     <p:sldId id="257" r:id="rId3"/>
     <p:sldId id="258" r:id="rId4"/>
     <p:sldId id="259" r:id="rId5"/>
-    <p:sldId id="261" r:id="rId7"/>
     <p:sldId id="268" r:id="rId19"/>
     <p:sldId id="260" r:id="rId6"/>
     <p:sldId id="262" r:id="rId8"/>
@@ -625,7 +624,7 @@
           <a:p>
             <a:fld id="{F7021451-1387-4CA6-816F-3879F97B5CBC}" type="slidenum">
               <a:rPr lang="en-US"/>
-              <a:t>11</a:t>
+              <a:t>10</a:t>
             </a:fld>
             <a:endParaRPr lang="en-US"/>
           </a:p>
@@ -713,7 +712,7 @@
           <a:p>
             <a:fld id="{F7021451-1387-4CA6-816F-3879F97B5CBC}" type="slidenum">
               <a:rPr lang="en-US"/>
-              <a:t>12</a:t>
+              <a:t>11</a:t>
             </a:fld>
             <a:endParaRPr lang="en-US"/>
           </a:p>
@@ -801,7 +800,7 @@
           <a:p>
             <a:fld id="{F7021451-1387-4CA6-816F-3879F97B5CBC}" type="slidenum">
               <a:rPr lang="en-US"/>
-              <a:t>13</a:t>
+              <a:t>12</a:t>
             </a:fld>
             <a:endParaRPr lang="en-US"/>
           </a:p>
@@ -889,7 +888,7 @@
           <a:p>
             <a:fld id="{F7021451-1387-4CA6-816F-3879F97B5CBC}" type="slidenum">
               <a:rPr lang="en-US"/>
-              <a:t>6</a:t>
+              <a:t>5</a:t>
             </a:fld>
             <a:endParaRPr lang="en-US"/>
           </a:p>
@@ -1130,7 +1129,7 @@
           <a:p>
             <a:r>
               <a:rPr lang="en-US" dirty="0"/>
-              <a:t>Nejde o technickou práci. Software je pomůcka; hlavní text je didaktický a technika je v přílohách. Pedagogické jádro: posun po Bloomově taxonomii – žák jako uživatel jen čte známku; jako správce aplikuje a analyzuje (založí třídu, řeší kolizi); jako spolutvůrce hodnotí a tvoří (navrhne modul, čte ER diagram). Přechod: a jak jeden systém roste se žákem.</a:t>
+              <a:t>Nejde o technickou práci: software je pomůcka, hlavní text je didaktický, technika je v přílohách. Druhý princip: jeden plnohodnotný systém se třemi vrstvami hloubky – systém zůstává, mění se kompetence žáka v čase. 1. stupeň – uživatelská vrstva: žák pozoruje, role jako pohled, zapíše známku (Bloom: zapamatovat, porozumět). 2. stupeň – konfigurační vrstva: žák jako správce zakládá třídy a předměty, řeší kolizi v rozvrhu (aplikovat, analyzovat). SŠ – vývojářská vrstva: žák jako spolutvůrce jde pod kapotu – ER diagram, API, vlastní modul (hodnotit, tvořit). Spirálové kurikulum: tatáž známka se vrací na vyšší úrovni abstrakce. Ke každému stupni je pracovní list s klíčem pro učitele. Přechod: a proč na to stačí jeden nástroj.</a:t>
             </a:r>
             <a:endParaRPr lang="en-US" dirty="0"/>
           </a:p>
@@ -1241,95 +1240,7 @@
           <a:p>
             <a:fld id="{F7021451-1387-4CA6-816F-3879F97B5CBC}" type="slidenum">
               <a:rPr lang="en-US"/>
-              <a:t>7</a:t>
-            </a:fld>
-            <a:endParaRPr lang="en-US"/>
-          </a:p>
-        </p:txBody>
-      </p:sp>
-    </p:spTree>
-    <p:extLst>
-      <p:ext uri="{BB962C8B-B14F-4D97-AF65-F5344CB8AC3E}">
-        <p14:creationId xmlns:p14="http://schemas.microsoft.com/office/powerpoint/2010/main" val="1024086991"/>
-      </p:ext>
-    </p:extLst>
-  </p:cSld>
-  <p:clrMapOvr>
-    <a:masterClrMapping/>
-  </p:clrMapOvr>
-</p:notes>
-</file>
-
-<file path=ppt/notesSlides/notesSlide6.xml><?xml version="1.0" encoding="utf-8"?>
-<p:notes xmlns:a="http://schemas.openxmlformats.org/drawingml/2006/main" xmlns:r="http://schemas.openxmlformats.org/officeDocument/2006/relationships" xmlns:p="http://schemas.openxmlformats.org/presentationml/2006/main">
-  <p:cSld>
-    <p:spTree>
-      <p:nvGrpSpPr>
-        <p:cNvPr id="1" name=""/>
-        <p:cNvGrpSpPr/>
-        <p:nvPr/>
-      </p:nvGrpSpPr>
-      <p:grpSpPr>
-        <a:xfrm>
-          <a:off x="0" y="0"/>
-          <a:ext cx="0" cy="0"/>
-          <a:chOff x="0" y="0"/>
-          <a:chExt cx="0" cy="0"/>
-        </a:xfrm>
-      </p:grpSpPr>
-      <p:sp>
-        <p:nvSpPr>
-          <p:cNvPr id="2" name="Slide Image Placeholder 1"/>
-          <p:cNvSpPr>
-            <a:spLocks noGrp="1" noRot="1" noChangeAspect="1"/>
-          </p:cNvSpPr>
-          <p:nvPr>
-            <p:ph type="sldImg"/>
-          </p:nvPr>
-        </p:nvSpPr>
-        <p:spPr/>
-      </p:sp>
-      <p:sp>
-        <p:nvSpPr>
-          <p:cNvPr id="3" name="Notes Placeholder 2"/>
-          <p:cNvSpPr>
-            <a:spLocks noGrp="1"/>
-          </p:cNvSpPr>
-          <p:nvPr>
-            <p:ph type="body" idx="1"/>
-          </p:nvPr>
-        </p:nvSpPr>
-        <p:spPr/>
-        <p:txBody>
-          <a:bodyPr/>
-          <a:lstStyle/>
-          <a:p>
-            <a:r>
-              <a:rPr lang="en-US" dirty="0"/>
-              <a:t>Druhý princip: není to tři různé aplikace, ale jeden plnohodnotný systém se třemi vrstvami hloubky. Na 1. stupni žák pozoruje – role jako pohled. Na 2. stupni spravuje strukturu – třídy, předměty, rozvrh. Na SŠ jde pod kapotu – ER diagram, API, vlastní modul. Mění se jen kompetence žáka v čase, systém zůstává. Podle stupňů existují tři pracovní listy s klíčem pro učitele. Přechod: a proč na to stačí jeden nástroj.</a:t>
-            </a:r>
-            <a:endParaRPr lang="en-US" dirty="0"/>
-          </a:p>
-        </p:txBody>
-      </p:sp>
-      <p:sp>
-        <p:nvSpPr>
-          <p:cNvPr id="4" name="Slide Number Placeholder 3"/>
-          <p:cNvSpPr>
-            <a:spLocks noGrp="1"/>
-          </p:cNvSpPr>
-          <p:nvPr>
-            <p:ph type="sldNum" sz="quarter" idx="10"/>
-          </p:nvPr>
-        </p:nvSpPr>
-        <p:spPr/>
-        <p:txBody>
-          <a:bodyPr/>
-          <a:lstStyle/>
-          <a:p>
-            <a:fld id="{F7021451-1387-4CA6-816F-3879F97B5CBC}" type="slidenum">
-              <a:rPr lang="en-US"/>
-              <a:t>5</a:t>
+              <a:t>6</a:t>
             </a:fld>
             <a:endParaRPr lang="en-US"/>
           </a:p>
@@ -1417,7 +1328,7 @@
           <a:p>
             <a:fld id="{F7021451-1387-4CA6-816F-3879F97B5CBC}" type="slidenum">
               <a:rPr lang="en-US"/>
-              <a:t>8</a:t>
+              <a:t>7</a:t>
             </a:fld>
             <a:endParaRPr lang="en-US"/>
           </a:p>
@@ -1505,7 +1416,7 @@
           <a:p>
             <a:fld id="{F7021451-1387-4CA6-816F-3879F97B5CBC}" type="slidenum">
               <a:rPr lang="en-US"/>
-              <a:t>9</a:t>
+              <a:t>8</a:t>
             </a:fld>
             <a:endParaRPr lang="en-US"/>
           </a:p>
@@ -1593,7 +1504,7 @@
           <a:p>
             <a:fld id="{F7021451-1387-4CA6-816F-3879F97B5CBC}" type="slidenum">
               <a:rPr lang="en-US"/>
-              <a:t>10</a:t>
+              <a:t>9</a:t>
             </a:fld>
             <a:endParaRPr lang="en-US"/>
           </a:p>
@@ -2750,7 +2661,7 @@
                 <a:ea typeface="Calibri" pitchFamily="34" charset="-122"/>
                 <a:cs typeface="Calibri" pitchFamily="34" charset="-120"/>
               </a:rPr>
-              <a:t>11</a:t>
+              <a:t>10</a:t>
             </a:r>
             <a:endParaRPr lang="en-US" sz="900" dirty="0"/>
           </a:p>
@@ -3116,7 +3027,7 @@
                 <a:ea typeface="Calibri" pitchFamily="34" charset="-122"/>
                 <a:cs typeface="Calibri" pitchFamily="34" charset="-120"/>
               </a:rPr>
-              <a:t>12</a:t>
+              <a:t>11</a:t>
             </a:r>
             <a:endParaRPr lang="en-US" sz="900" dirty="0"/>
           </a:p>
@@ -3630,7 +3541,7 @@
                 <a:ea typeface="Calibri" pitchFamily="34" charset="-122"/>
                 <a:cs typeface="Calibri" pitchFamily="34" charset="-120"/>
               </a:rPr>
-              <a:t>13</a:t>
+              <a:t>12</a:t>
             </a:r>
             <a:endParaRPr lang="en-US" sz="900" dirty="0"/>
           </a:p>
@@ -5473,7 +5384,7 @@
                 <a:ea typeface="Calibri" pitchFamily="34" charset="-122"/>
                 <a:cs typeface="Calibri" pitchFamily="34" charset="-120"/>
               </a:rPr>
-              <a:t>6</a:t>
+              <a:t>5</a:t>
             </a:r>
             <a:endParaRPr lang="en-US" sz="900" dirty="0"/>
           </a:p>
@@ -6674,7 +6585,7 @@
               <a:buNone/>
             </a:pPr>
             <a:r>
-              <a:rPr lang="en-US" sz="3000" b="1" dirty="0">
+              <a:rPr lang="en-US" sz="2600" b="1" dirty="0">
                 <a:solidFill>
                   <a:srgbClr val="3F2A78"/>
                 </a:solidFill>
@@ -6682,9 +6593,9 @@
                 <a:ea typeface="Calibri" pitchFamily="34" charset="-122"/>
                 <a:cs typeface="Calibri" pitchFamily="34" charset="-120"/>
               </a:rPr>
-              <a:t>Nejde o software, jde o to, co se na něm žák naučí</a:t>
-            </a:r>
-            <a:endParaRPr lang="en-US" sz="3000" dirty="0"/>
+              <a:t>Jeden systém pro všechny – mění se jen kompetence</a:t>
+            </a:r>
+            <a:endParaRPr lang="en-US" sz="2600" dirty="0"/>
           </a:p>
         </p:txBody>
       </p:sp>
@@ -6696,8 +6607,8 @@
         </p:nvSpPr>
         <p:spPr>
           <a:xfrm>
-            <a:off x="548640" y="1051560"/>
-            <a:ext cx="8046720" cy="548640"/>
+            <a:off x="548640" y="1005840"/>
+            <a:ext cx="8046720" cy="502920"/>
           </a:xfrm>
           <a:prstGeom prst="rect">
             <a:avLst/>
@@ -6721,7 +6632,7 @@
                 <a:ea typeface="Calibri" pitchFamily="34" charset="-122"/>
                 <a:cs typeface="Calibri" pitchFamily="34" charset="-120"/>
               </a:rPr>
-              <a:t>Software je pomůcka. Hlavní text práce popisuje role, procesy, úrovně a úlohy; technologie jsou vyčleněny do příloh (uživatelská příručka A, technická příloha B).</a:t>
+              <a:t>Software je pomůcka; hlavní text práce popisuje role, procesy, úrovně a úlohy (technika je v přílohách A a B). Systém zůstává stejný – mění se jen to, co v něm žák smí a umí.</a:t>
             </a:r>
             <a:endParaRPr lang="en-US" sz="1300" dirty="0"/>
           </a:p>
@@ -6729,14 +6640,14 @@
       </p:sp>
       <p:sp>
         <p:nvSpPr>
-          <p:cNvPr id="101" name="Text 101"/>
-          <p:cNvSpPr txBox="1"/>
-          <p:nvPr/>
-        </p:nvSpPr>
-        <p:spPr>
-          <a:xfrm>
-            <a:off x="548640" y="2103120"/>
-            <a:ext cx="2514600" cy="254000"/>
+          <p:cNvPr id="301" name="Text 301"/>
+          <p:cNvSpPr txBox="1"/>
+          <p:nvPr/>
+        </p:nvSpPr>
+        <p:spPr>
+          <a:xfrm>
+            <a:off x="548640" y="2249424"/>
+            <a:ext cx="2514600" cy="246888"/>
           </a:xfrm>
           <a:prstGeom prst="rect">
             <a:avLst/>
@@ -6752,7 +6663,7 @@
               <a:buNone/>
             </a:pPr>
             <a:r>
-              <a:rPr lang="cs-CZ" sz="1100" i="1" dirty="0">
+              <a:rPr lang="cs-CZ" sz="1000" i="1" dirty="0">
                 <a:solidFill>
                   <a:srgbClr val="6B6680"/>
                 </a:solidFill>
@@ -6760,21 +6671,21 @@
                 <a:ea typeface="Calibri" pitchFamily="34" charset="-122"/>
                 <a:cs typeface="Calibri" pitchFamily="34" charset="-120"/>
               </a:rPr>
-              <a:t>žák jako uživatel</a:t>
-            </a:r>
-          </a:p>
-        </p:txBody>
-      </p:sp>
-      <p:sp>
-        <p:nvSpPr>
-          <p:cNvPr id="102" name="Shape 102"/>
+              <a:t>1. stupeň ZŠ · uživatelská vrstva</a:t>
+            </a:r>
+          </a:p>
+        </p:txBody>
+      </p:sp>
+      <p:sp>
+        <p:nvSpPr>
+          <p:cNvPr id="302" name="Shape 302"/>
           <p:cNvSpPr/>
           <p:nvPr/>
         </p:nvSpPr>
         <p:spPr>
           <a:xfrm>
-            <a:off x="548640" y="2377440"/>
-            <a:ext cx="2514600" cy="914400"/>
+            <a:off x="548640" y="2514600"/>
+            <a:ext cx="2514600" cy="1508760"/>
           </a:xfrm>
           <a:prstGeom prst="roundRect">
             <a:avLst>
@@ -6791,14 +6702,14 @@
       </p:sp>
       <p:sp>
         <p:nvSpPr>
-          <p:cNvPr id="103" name="Text 103"/>
-          <p:cNvSpPr txBox="1"/>
-          <p:nvPr/>
-        </p:nvSpPr>
-        <p:spPr>
-          <a:xfrm>
-            <a:off x="685800" y="2487168"/>
-            <a:ext cx="2240280" cy="365760"/>
+          <p:cNvPr id="303" name="Text 303"/>
+          <p:cNvSpPr txBox="1"/>
+          <p:nvPr/>
+        </p:nvSpPr>
+        <p:spPr>
+          <a:xfrm>
+            <a:off x="685800" y="2624328"/>
+            <a:ext cx="2240280" cy="411480"/>
           </a:xfrm>
           <a:prstGeom prst="rect">
             <a:avLst/>
@@ -6822,21 +6733,32 @@
                 <a:ea typeface="Calibri" pitchFamily="34" charset="-122"/>
                 <a:cs typeface="Calibri" pitchFamily="34" charset="-120"/>
               </a:rPr>
-              <a:t>zapamatovat / porozumět</a:t>
-            </a:r>
-          </a:p>
-        </p:txBody>
-      </p:sp>
-      <p:sp>
-        <p:nvSpPr>
-          <p:cNvPr id="104" name="Text 104"/>
-          <p:cNvSpPr txBox="1"/>
-          <p:nvPr/>
-        </p:nvSpPr>
-        <p:spPr>
-          <a:xfrm>
-            <a:off x="685800" y="2834640"/>
-            <a:ext cx="2240280" cy="411480"/>
+              <a:t>žák jako uživatel</a:t>
+            </a:r>
+            <a:r>
+              <a:rPr lang="cs-CZ" sz="1000" dirty="0">
+                <a:solidFill>
+                  <a:srgbClr val="FFFFFF"/>
+                </a:solidFill>
+                <a:latin typeface="Calibri" pitchFamily="34" charset="0"/>
+                <a:ea typeface="Calibri" pitchFamily="34" charset="-122"/>
+                <a:cs typeface="Calibri" pitchFamily="34" charset="-120"/>
+              </a:rPr>
+              <a:t> · zapamatovat / porozumět</a:t>
+            </a:r>
+          </a:p>
+        </p:txBody>
+      </p:sp>
+      <p:sp>
+        <p:nvSpPr>
+          <p:cNvPr id="304" name="Text 304"/>
+          <p:cNvSpPr txBox="1"/>
+          <p:nvPr/>
+        </p:nvSpPr>
+        <p:spPr>
+          <a:xfrm>
+            <a:off x="685800" y="3035808"/>
+            <a:ext cx="2240280" cy="941832"/>
           </a:xfrm>
           <a:prstGeom prst="rect">
             <a:avLst/>
@@ -6860,21 +6782,21 @@
                 <a:ea typeface="Calibri" pitchFamily="34" charset="-122"/>
                 <a:cs typeface="Calibri" pitchFamily="34" charset="-120"/>
               </a:rPr>
-              <a:t>žák čte známku, kterou eviduje někdo jiný</a:t>
-            </a:r>
-          </a:p>
-        </p:txBody>
-      </p:sp>
-      <p:sp>
-        <p:nvSpPr>
-          <p:cNvPr id="105" name="Text 105"/>
-          <p:cNvSpPr txBox="1"/>
-          <p:nvPr/>
-        </p:nvSpPr>
-        <p:spPr>
-          <a:xfrm>
-            <a:off x="3246120" y="1874520"/>
-            <a:ext cx="2514600" cy="254000"/>
+              <a:t>Role jako pohled: přihlásím se jako žák, učitel, ředitel – co vidím a co smím? Zápis jedné známky.</a:t>
+            </a:r>
+          </a:p>
+        </p:txBody>
+      </p:sp>
+      <p:sp>
+        <p:nvSpPr>
+          <p:cNvPr id="305" name="Text 305"/>
+          <p:cNvSpPr txBox="1"/>
+          <p:nvPr/>
+        </p:nvSpPr>
+        <p:spPr>
+          <a:xfrm>
+            <a:off x="3246120" y="1975104"/>
+            <a:ext cx="2514600" cy="246888"/>
           </a:xfrm>
           <a:prstGeom prst="rect">
             <a:avLst/>
@@ -6890,7 +6812,7 @@
               <a:buNone/>
             </a:pPr>
             <a:r>
-              <a:rPr lang="cs-CZ" sz="1100" i="1" dirty="0">
+              <a:rPr lang="cs-CZ" sz="1000" i="1" dirty="0">
                 <a:solidFill>
                   <a:srgbClr val="6B6680"/>
                 </a:solidFill>
@@ -6898,21 +6820,21 @@
                 <a:ea typeface="Calibri" pitchFamily="34" charset="-122"/>
                 <a:cs typeface="Calibri" pitchFamily="34" charset="-120"/>
               </a:rPr>
-              <a:t>žák jako správce</a:t>
-            </a:r>
-          </a:p>
-        </p:txBody>
-      </p:sp>
-      <p:sp>
-        <p:nvSpPr>
-          <p:cNvPr id="106" name="Shape 106"/>
+              <a:t>2. stupeň ZŠ · konfigurační vrstva</a:t>
+            </a:r>
+          </a:p>
+        </p:txBody>
+      </p:sp>
+      <p:sp>
+        <p:nvSpPr>
+          <p:cNvPr id="306" name="Shape 306"/>
           <p:cNvSpPr/>
           <p:nvPr/>
         </p:nvSpPr>
         <p:spPr>
           <a:xfrm>
-            <a:off x="3246120" y="2148840"/>
-            <a:ext cx="2514600" cy="1143000"/>
+            <a:off x="3246120" y="2240280"/>
+            <a:ext cx="2514600" cy="1783080"/>
           </a:xfrm>
           <a:prstGeom prst="roundRect">
             <a:avLst>
@@ -6929,14 +6851,14 @@
       </p:sp>
       <p:sp>
         <p:nvSpPr>
-          <p:cNvPr id="107" name="Text 107"/>
-          <p:cNvSpPr txBox="1"/>
-          <p:nvPr/>
-        </p:nvSpPr>
-        <p:spPr>
-          <a:xfrm>
-            <a:off x="3383280" y="2258568"/>
-            <a:ext cx="2240280" cy="365760"/>
+          <p:cNvPr id="307" name="Text 307"/>
+          <p:cNvSpPr txBox="1"/>
+          <p:nvPr/>
+        </p:nvSpPr>
+        <p:spPr>
+          <a:xfrm>
+            <a:off x="3383280" y="2350008"/>
+            <a:ext cx="2240280" cy="411480"/>
           </a:xfrm>
           <a:prstGeom prst="rect">
             <a:avLst/>
@@ -6960,21 +6882,32 @@
                 <a:ea typeface="Calibri" pitchFamily="34" charset="-122"/>
                 <a:cs typeface="Calibri" pitchFamily="34" charset="-120"/>
               </a:rPr>
-              <a:t>aplikovat / analyzovat</a:t>
-            </a:r>
-          </a:p>
-        </p:txBody>
-      </p:sp>
-      <p:sp>
-        <p:nvSpPr>
-          <p:cNvPr id="108" name="Text 108"/>
-          <p:cNvSpPr txBox="1"/>
-          <p:nvPr/>
-        </p:nvSpPr>
-        <p:spPr>
-          <a:xfrm>
-            <a:off x="3383280" y="2606040"/>
-            <a:ext cx="2240280" cy="640080"/>
+              <a:t>žák jako správce</a:t>
+            </a:r>
+            <a:r>
+              <a:rPr lang="cs-CZ" sz="1000" dirty="0">
+                <a:solidFill>
+                  <a:srgbClr val="FFFFFF"/>
+                </a:solidFill>
+                <a:latin typeface="Calibri" pitchFamily="34" charset="0"/>
+                <a:ea typeface="Calibri" pitchFamily="34" charset="-122"/>
+                <a:cs typeface="Calibri" pitchFamily="34" charset="-120"/>
+              </a:rPr>
+              <a:t> · aplikovat / analyzovat</a:t>
+            </a:r>
+          </a:p>
+        </p:txBody>
+      </p:sp>
+      <p:sp>
+        <p:nvSpPr>
+          <p:cNvPr id="308" name="Text 308"/>
+          <p:cNvSpPr txBox="1"/>
+          <p:nvPr/>
+        </p:nvSpPr>
+        <p:spPr>
+          <a:xfrm>
+            <a:off x="3383280" y="2761488"/>
+            <a:ext cx="2240280" cy="1216152"/>
           </a:xfrm>
           <a:prstGeom prst="rect">
             <a:avLst/>
@@ -6998,21 +6931,21 @@
                 <a:ea typeface="Calibri" pitchFamily="34" charset="-122"/>
                 <a:cs typeface="Calibri" pitchFamily="34" charset="-120"/>
               </a:rPr>
-              <a:t>žák zakládá třídu, řeší kolizi v rozvrhu</a:t>
-            </a:r>
-          </a:p>
-        </p:txBody>
-      </p:sp>
-      <p:sp>
-        <p:nvSpPr>
-          <p:cNvPr id="109" name="Text 109"/>
-          <p:cNvSpPr txBox="1"/>
-          <p:nvPr/>
-        </p:nvSpPr>
-        <p:spPr>
-          <a:xfrm>
-            <a:off x="5943600" y="1645920"/>
-            <a:ext cx="2514600" cy="254000"/>
+              <a:t>Struktura jako řemeslo: založení třídy a předmětu, rozvrh s detekcí kolizí, AI asistent, impersonace.</a:t>
+            </a:r>
+          </a:p>
+        </p:txBody>
+      </p:sp>
+      <p:sp>
+        <p:nvSpPr>
+          <p:cNvPr id="309" name="Text 309"/>
+          <p:cNvSpPr txBox="1"/>
+          <p:nvPr/>
+        </p:nvSpPr>
+        <p:spPr>
+          <a:xfrm>
+            <a:off x="5943600" y="1700784"/>
+            <a:ext cx="2514600" cy="246888"/>
           </a:xfrm>
           <a:prstGeom prst="rect">
             <a:avLst/>
@@ -7028,7 +6961,7 @@
               <a:buNone/>
             </a:pPr>
             <a:r>
-              <a:rPr lang="cs-CZ" sz="1100" i="1" dirty="0">
+              <a:rPr lang="cs-CZ" sz="1000" i="1" dirty="0">
                 <a:solidFill>
                   <a:srgbClr val="6B6680"/>
                 </a:solidFill>
@@ -7036,21 +6969,21 @@
                 <a:ea typeface="Calibri" pitchFamily="34" charset="-122"/>
                 <a:cs typeface="Calibri" pitchFamily="34" charset="-120"/>
               </a:rPr>
-              <a:t>žák jako spolutvůrce</a:t>
-            </a:r>
-          </a:p>
-        </p:txBody>
-      </p:sp>
-      <p:sp>
-        <p:nvSpPr>
-          <p:cNvPr id="110" name="Shape 110"/>
+              <a:t>Střední škola · vývojářská vrstva</a:t>
+            </a:r>
+          </a:p>
+        </p:txBody>
+      </p:sp>
+      <p:sp>
+        <p:nvSpPr>
+          <p:cNvPr id="310" name="Shape 310"/>
           <p:cNvSpPr/>
           <p:nvPr/>
         </p:nvSpPr>
         <p:spPr>
           <a:xfrm>
-            <a:off x="5943600" y="1920240"/>
-            <a:ext cx="2514600" cy="1371600"/>
+            <a:off x="5943600" y="1965960"/>
+            <a:ext cx="2514600" cy="2057400"/>
           </a:xfrm>
           <a:prstGeom prst="roundRect">
             <a:avLst>
@@ -7067,14 +7000,14 @@
       </p:sp>
       <p:sp>
         <p:nvSpPr>
-          <p:cNvPr id="111" name="Text 111"/>
-          <p:cNvSpPr txBox="1"/>
-          <p:nvPr/>
-        </p:nvSpPr>
-        <p:spPr>
-          <a:xfrm>
-            <a:off x="6080760" y="2029968"/>
-            <a:ext cx="2240280" cy="365760"/>
+          <p:cNvPr id="311" name="Text 311"/>
+          <p:cNvSpPr txBox="1"/>
+          <p:nvPr/>
+        </p:nvSpPr>
+        <p:spPr>
+          <a:xfrm>
+            <a:off x="6080760" y="2075688"/>
+            <a:ext cx="2240280" cy="411480"/>
           </a:xfrm>
           <a:prstGeom prst="rect">
             <a:avLst/>
@@ -7098,21 +7031,32 @@
                 <a:ea typeface="Calibri" pitchFamily="34" charset="-122"/>
                 <a:cs typeface="Calibri" pitchFamily="34" charset="-120"/>
               </a:rPr>
-              <a:t>hodnotit / tvořit</a:t>
-            </a:r>
-          </a:p>
-        </p:txBody>
-      </p:sp>
-      <p:sp>
-        <p:nvSpPr>
-          <p:cNvPr id="112" name="Text 112"/>
-          <p:cNvSpPr txBox="1"/>
-          <p:nvPr/>
-        </p:nvSpPr>
-        <p:spPr>
-          <a:xfrm>
-            <a:off x="6080760" y="2377440"/>
-            <a:ext cx="2240280" cy="868680"/>
+              <a:t>žák jako spolutvůrce</a:t>
+            </a:r>
+            <a:r>
+              <a:rPr lang="cs-CZ" sz="1000" dirty="0">
+                <a:solidFill>
+                  <a:srgbClr val="FFFFFF"/>
+                </a:solidFill>
+                <a:latin typeface="Calibri" pitchFamily="34" charset="0"/>
+                <a:ea typeface="Calibri" pitchFamily="34" charset="-122"/>
+                <a:cs typeface="Calibri" pitchFamily="34" charset="-120"/>
+              </a:rPr>
+              <a:t> · hodnotit / tvořit</a:t>
+            </a:r>
+          </a:p>
+        </p:txBody>
+      </p:sp>
+      <p:sp>
+        <p:nvSpPr>
+          <p:cNvPr id="312" name="Text 312"/>
+          <p:cNvSpPr txBox="1"/>
+          <p:nvPr/>
+        </p:nvSpPr>
+        <p:spPr>
+          <a:xfrm>
+            <a:off x="6080760" y="2487168"/>
+            <a:ext cx="2240280" cy="1490472"/>
           </a:xfrm>
           <a:prstGeom prst="rect">
             <a:avLst/>
@@ -7136,21 +7080,21 @@
                 <a:ea typeface="Calibri" pitchFamily="34" charset="-122"/>
                 <a:cs typeface="Calibri" pitchFamily="34" charset="-120"/>
               </a:rPr>
-              <a:t>žák navrhuje modul, čte ER diagram, volá API</a:t>
-            </a:r>
-          </a:p>
-        </p:txBody>
-      </p:sp>
-      <p:sp>
-        <p:nvSpPr>
-          <p:cNvPr id="113" name="Text 113"/>
-          <p:cNvSpPr txBox="1"/>
-          <p:nvPr/>
-        </p:nvSpPr>
-        <p:spPr>
-          <a:xfrm>
-            <a:off x="548640" y="3474720"/>
-            <a:ext cx="8046720" cy="254000"/>
+              <a:t>Systém jako platforma: ER diagram, REST a MCP API, vlastní skript, návrh nového modulu, šifrování a anonymizace.</a:t>
+            </a:r>
+          </a:p>
+        </p:txBody>
+      </p:sp>
+      <p:sp>
+        <p:nvSpPr>
+          <p:cNvPr id="313" name="Text 313"/>
+          <p:cNvSpPr txBox="1"/>
+          <p:nvPr/>
+        </p:nvSpPr>
+        <p:spPr>
+          <a:xfrm>
+            <a:off x="548640" y="4114800"/>
+            <a:ext cx="8046720" cy="457200"/>
           </a:xfrm>
           <a:prstGeom prst="rect">
             <a:avLst/>
@@ -7166,7 +7110,7 @@
               <a:buNone/>
             </a:pPr>
             <a:r>
-              <a:rPr lang="cs-CZ" sz="1200" b="1" dirty="0">
+              <a:rPr lang="cs-CZ" sz="1100" b="1" dirty="0">
                 <a:solidFill>
                   <a:srgbClr val="3F2A78"/>
                 </a:solidFill>
@@ -7174,7 +7118,18 @@
                 <a:ea typeface="Calibri" pitchFamily="34" charset="-122"/>
                 <a:cs typeface="Calibri" pitchFamily="34" charset="-120"/>
               </a:rPr>
-              <a:t>Posun po Bloomově taxonomii: od uživatele k modeláři a správci</a:t>
+              <a:t>Posun po Bloomově taxonomii</a:t>
+            </a:r>
+            <a:r>
+              <a:rPr lang="cs-CZ" sz="1000" dirty="0">
+                <a:solidFill>
+                  <a:srgbClr val="6B6680"/>
+                </a:solidFill>
+                <a:latin typeface="Calibri" pitchFamily="34" charset="0"/>
+                <a:ea typeface="Calibri" pitchFamily="34" charset="-122"/>
+                <a:cs typeface="Calibri" pitchFamily="34" charset="-120"/>
+              </a:rPr>
+              <a:t> · spirálové kurikulum: tatáž známka se vrací v každém stupni na vyšší úrovni abstrakce · ke každému stupni pracovní list s klíčem pro učitele (Příloha C).</a:t>
             </a:r>
           </a:p>
         </p:txBody>
@@ -7754,561 +7709,7 @@
                 <a:ea typeface="Calibri" pitchFamily="34" charset="-122"/>
                 <a:cs typeface="Calibri" pitchFamily="34" charset="-120"/>
               </a:rPr>
-              <a:t>7</a:t>
-            </a:r>
-            <a:endParaRPr lang="en-US" sz="900" dirty="0"/>
-          </a:p>
-        </p:txBody>
-      </p:sp>
-    </p:spTree>
-  </p:cSld>
-  <p:clrMapOvr>
-    <a:masterClrMapping/>
-  </p:clrMapOvr>
-</p:sld>
-</file>
-
-<file path=ppt/slides/slide6.xml><?xml version="1.0" encoding="utf-8"?>
-<p:sld xmlns:a="http://schemas.openxmlformats.org/drawingml/2006/main" xmlns:r="http://schemas.openxmlformats.org/officeDocument/2006/relationships" xmlns:p="http://schemas.openxmlformats.org/presentationml/2006/main">
-  <p:cSld name="Slide 6">
-    <p:bg>
-      <p:bgPr>
-        <a:solidFill>
-          <a:srgbClr val="FFFFFF"/>
-        </a:solidFill>
-      </p:bgPr>
-    </p:bg>
-    <p:spTree>
-      <p:nvGrpSpPr>
-        <p:cNvPr id="1" name=""/>
-        <p:cNvGrpSpPr/>
-        <p:nvPr/>
-      </p:nvGrpSpPr>
-      <p:grpSpPr>
-        <a:xfrm>
-          <a:off x="0" y="0"/>
-          <a:ext cx="0" cy="0"/>
-          <a:chOff x="0" y="0"/>
-          <a:chExt cx="0" cy="0"/>
-        </a:xfrm>
-      </p:grpSpPr>
-      <p:sp>
-        <p:nvSpPr>
-          <p:cNvPr id="2" name="Text 0"/>
-          <p:cNvSpPr txBox="1"/>
-          <p:nvPr/>
-        </p:nvSpPr>
-        <p:spPr>
-          <a:xfrm>
-            <a:off x="548640" y="320040"/>
-            <a:ext cx="8046720" cy="640080"/>
-          </a:xfrm>
-          <a:prstGeom prst="rect">
-            <a:avLst/>
-          </a:prstGeom>
-          <a:noFill/>
-          <a:ln/>
-        </p:spPr>
-        <p:txBody>
-          <a:bodyPr wrap="square" lIns="0" tIns="0" rIns="0" bIns="0" rtlCol="0" anchor="ctr"/>
-          <a:lstStyle/>
-          <a:p>
-            <a:pPr indent="0" marL="0">
-              <a:buNone/>
-            </a:pPr>
-            <a:r>
-              <a:rPr lang="en-US" sz="2600" b="1" dirty="0">
-                <a:solidFill>
-                  <a:srgbClr val="3F2A78"/>
-                </a:solidFill>
-                <a:latin typeface="Calibri" pitchFamily="34" charset="0"/>
-                <a:ea typeface="Calibri" pitchFamily="34" charset="-122"/>
-                <a:cs typeface="Calibri" pitchFamily="34" charset="-120"/>
-              </a:rPr>
-              <a:t>Jeden systém pro všechny – mění se jen kompetence</a:t>
-            </a:r>
-            <a:endParaRPr lang="en-US" sz="2600" dirty="0"/>
-          </a:p>
-        </p:txBody>
-      </p:sp>
-      <p:sp>
-        <p:nvSpPr>
-          <p:cNvPr id="3" name="Shape 1"/>
-          <p:cNvSpPr/>
-          <p:nvPr/>
-        </p:nvSpPr>
-        <p:spPr>
-          <a:xfrm>
-            <a:off x="548640" y="1188720"/>
-            <a:ext cx="1828800" cy="914400"/>
-          </a:xfrm>
-          <a:prstGeom prst="roundRect">
-            <a:avLst>
-              <a:gd name="adj" fmla="val 10000"/>
-            </a:avLst>
-          </a:prstGeom>
-          <a:solidFill>
-            <a:srgbClr val="7EC3E4"/>
-          </a:solidFill>
-          <a:ln w="12700">
-            <a:solidFill>
-              <a:srgbClr val="7EC3E4"/>
-            </a:solidFill>
-            <a:prstDash val="solid"/>
-          </a:ln>
-        </p:spPr>
-      </p:sp>
-      <p:sp>
-        <p:nvSpPr>
-          <p:cNvPr id="4" name="Text 2"/>
-          <p:cNvSpPr txBox="1"/>
-          <p:nvPr/>
-        </p:nvSpPr>
-        <p:spPr>
-          <a:xfrm>
-            <a:off x="685800" y="1188720"/>
-            <a:ext cx="1600200" cy="914400"/>
-          </a:xfrm>
-          <a:prstGeom prst="rect">
-            <a:avLst/>
-          </a:prstGeom>
-          <a:noFill/>
-          <a:ln/>
-        </p:spPr>
-        <p:txBody>
-          <a:bodyPr wrap="square" lIns="0" tIns="0" rIns="0" bIns="0" rtlCol="0" anchor="ctr"/>
-          <a:lstStyle/>
-          <a:p>
-            <a:pPr indent="0" marL="0">
-              <a:buNone/>
-            </a:pPr>
-            <a:r>
-              <a:rPr lang="en-US" sz="1400" b="1" dirty="0">
-                <a:solidFill>
-                  <a:srgbClr val="FFFFFF"/>
-                </a:solidFill>
-                <a:latin typeface="Calibri" pitchFamily="34" charset="0"/>
-                <a:ea typeface="Calibri" pitchFamily="34" charset="-122"/>
-                <a:cs typeface="Calibri" pitchFamily="34" charset="-120"/>
-              </a:rPr>
-              <a:t>1. stupeň ZŠ</a:t>
-            </a:r>
-            <a:endParaRPr lang="en-US" sz="1400" dirty="0"/>
-          </a:p>
-          <a:p>
-            <a:pPr indent="0" marL="0">
-              <a:buNone/>
-            </a:pPr>
-            <a:r>
-              <a:rPr lang="en-US" sz="1100" dirty="0">
-                <a:solidFill>
-                  <a:srgbClr val="FFFFFF"/>
-                </a:solidFill>
-                <a:latin typeface="Calibri" pitchFamily="34" charset="0"/>
-                <a:ea typeface="Calibri" pitchFamily="34" charset="-122"/>
-                <a:cs typeface="Calibri" pitchFamily="34" charset="-120"/>
-              </a:rPr>
-              <a:t>Uživatelská vrstva</a:t>
-            </a:r>
-            <a:endParaRPr lang="en-US" sz="1400" dirty="0"/>
-          </a:p>
-        </p:txBody>
-      </p:sp>
-      <p:sp>
-        <p:nvSpPr>
-          <p:cNvPr id="5" name="Text 3"/>
-          <p:cNvSpPr txBox="1"/>
-          <p:nvPr/>
-        </p:nvSpPr>
-        <p:spPr>
-          <a:xfrm>
-            <a:off x="2606040" y="1234440"/>
-            <a:ext cx="5989320" cy="868680"/>
-          </a:xfrm>
-          <a:prstGeom prst="rect">
-            <a:avLst/>
-          </a:prstGeom>
-          <a:noFill/>
-          <a:ln/>
-        </p:spPr>
-        <p:txBody>
-          <a:bodyPr wrap="square" lIns="0" tIns="0" rIns="0" bIns="0" rtlCol="0" anchor="ctr"/>
-          <a:lstStyle/>
-          <a:p>
-            <a:pPr indent="0" marL="0">
-              <a:buNone/>
-            </a:pPr>
-            <a:r>
-              <a:rPr lang="en-US" sz="1300" dirty="0">
-                <a:solidFill>
-                  <a:srgbClr val="24203A"/>
-                </a:solidFill>
-                <a:latin typeface="Calibri" pitchFamily="34" charset="0"/>
-                <a:ea typeface="Calibri" pitchFamily="34" charset="-122"/>
-                <a:cs typeface="Calibri" pitchFamily="34" charset="-120"/>
-              </a:rPr>
-              <a:t>Role jako pohled: přihlásím se jako žák, učitel, ředitel – co vidím a co smím? Zápis jedné známky, diskuse o odpovědnosti.</a:t>
-            </a:r>
-            <a:endParaRPr lang="en-US" sz="1300" dirty="0"/>
-          </a:p>
-        </p:txBody>
-      </p:sp>
-      <p:sp>
-        <p:nvSpPr>
-          <p:cNvPr id="6" name="Shape 4"/>
-          <p:cNvSpPr/>
-          <p:nvPr/>
-        </p:nvSpPr>
-        <p:spPr>
-          <a:xfrm>
-            <a:off x="548640" y="2240280"/>
-            <a:ext cx="1828800" cy="914400"/>
-          </a:xfrm>
-          <a:prstGeom prst="roundRect">
-            <a:avLst>
-              <a:gd name="adj" fmla="val 10000"/>
-            </a:avLst>
-          </a:prstGeom>
-          <a:solidFill>
-            <a:srgbClr val="6544AF"/>
-          </a:solidFill>
-          <a:ln w="12700">
-            <a:solidFill>
-              <a:srgbClr val="6544AF"/>
-            </a:solidFill>
-            <a:prstDash val="solid"/>
-          </a:ln>
-        </p:spPr>
-      </p:sp>
-      <p:sp>
-        <p:nvSpPr>
-          <p:cNvPr id="7" name="Text 5"/>
-          <p:cNvSpPr txBox="1"/>
-          <p:nvPr/>
-        </p:nvSpPr>
-        <p:spPr>
-          <a:xfrm>
-            <a:off x="685800" y="2240280"/>
-            <a:ext cx="1600200" cy="914400"/>
-          </a:xfrm>
-          <a:prstGeom prst="rect">
-            <a:avLst/>
-          </a:prstGeom>
-          <a:noFill/>
-          <a:ln/>
-        </p:spPr>
-        <p:txBody>
-          <a:bodyPr wrap="square" lIns="0" tIns="0" rIns="0" bIns="0" rtlCol="0" anchor="ctr"/>
-          <a:lstStyle/>
-          <a:p>
-            <a:pPr indent="0" marL="0">
-              <a:buNone/>
-            </a:pPr>
-            <a:r>
-              <a:rPr lang="en-US" sz="1400" b="1" dirty="0">
-                <a:solidFill>
-                  <a:srgbClr val="FFFFFF"/>
-                </a:solidFill>
-                <a:latin typeface="Calibri" pitchFamily="34" charset="0"/>
-                <a:ea typeface="Calibri" pitchFamily="34" charset="-122"/>
-                <a:cs typeface="Calibri" pitchFamily="34" charset="-120"/>
-              </a:rPr>
-              <a:t>2. stupeň ZŠ</a:t>
-            </a:r>
-            <a:endParaRPr lang="en-US" sz="1400" dirty="0"/>
-          </a:p>
-          <a:p>
-            <a:pPr indent="0" marL="0">
-              <a:buNone/>
-            </a:pPr>
-            <a:r>
-              <a:rPr lang="en-US" sz="1100" dirty="0">
-                <a:solidFill>
-                  <a:srgbClr val="FFFFFF"/>
-                </a:solidFill>
-                <a:latin typeface="Calibri" pitchFamily="34" charset="0"/>
-                <a:ea typeface="Calibri" pitchFamily="34" charset="-122"/>
-                <a:cs typeface="Calibri" pitchFamily="34" charset="-120"/>
-              </a:rPr>
-              <a:t>Konfigurační vrstva</a:t>
-            </a:r>
-            <a:endParaRPr lang="en-US" sz="1400" dirty="0"/>
-          </a:p>
-        </p:txBody>
-      </p:sp>
-      <p:sp>
-        <p:nvSpPr>
-          <p:cNvPr id="8" name="Text 6"/>
-          <p:cNvSpPr txBox="1"/>
-          <p:nvPr/>
-        </p:nvSpPr>
-        <p:spPr>
-          <a:xfrm>
-            <a:off x="2606040" y="2286000"/>
-            <a:ext cx="5989320" cy="868680"/>
-          </a:xfrm>
-          <a:prstGeom prst="rect">
-            <a:avLst/>
-          </a:prstGeom>
-          <a:noFill/>
-          <a:ln/>
-        </p:spPr>
-        <p:txBody>
-          <a:bodyPr wrap="square" lIns="0" tIns="0" rIns="0" bIns="0" rtlCol="0" anchor="ctr"/>
-          <a:lstStyle/>
-          <a:p>
-            <a:pPr indent="0" marL="0">
-              <a:buNone/>
-            </a:pPr>
-            <a:r>
-              <a:rPr lang="en-US" sz="1300" dirty="0">
-                <a:solidFill>
-                  <a:srgbClr val="24203A"/>
-                </a:solidFill>
-                <a:latin typeface="Calibri" pitchFamily="34" charset="0"/>
-                <a:ea typeface="Calibri" pitchFamily="34" charset="-122"/>
-                <a:cs typeface="Calibri" pitchFamily="34" charset="-120"/>
-              </a:rPr>
-              <a:t>Struktura jako řemeslo: založení třídy, předmětu, rozvrh s detekcí kolizí, AI asistent, otázka impersonace.</a:t>
-            </a:r>
-            <a:endParaRPr lang="en-US" sz="1300" dirty="0"/>
-          </a:p>
-        </p:txBody>
-      </p:sp>
-      <p:sp>
-        <p:nvSpPr>
-          <p:cNvPr id="9" name="Shape 7"/>
-          <p:cNvSpPr/>
-          <p:nvPr/>
-        </p:nvSpPr>
-        <p:spPr>
-          <a:xfrm>
-            <a:off x="548640" y="3291840"/>
-            <a:ext cx="1828800" cy="914400"/>
-          </a:xfrm>
-          <a:prstGeom prst="roundRect">
-            <a:avLst>
-              <a:gd name="adj" fmla="val 10000"/>
-            </a:avLst>
-          </a:prstGeom>
-          <a:solidFill>
-            <a:srgbClr val="E24D8D"/>
-          </a:solidFill>
-          <a:ln w="12700">
-            <a:solidFill>
-              <a:srgbClr val="E24D8D"/>
-            </a:solidFill>
-            <a:prstDash val="solid"/>
-          </a:ln>
-        </p:spPr>
-      </p:sp>
-      <p:sp>
-        <p:nvSpPr>
-          <p:cNvPr id="10" name="Text 8"/>
-          <p:cNvSpPr txBox="1"/>
-          <p:nvPr/>
-        </p:nvSpPr>
-        <p:spPr>
-          <a:xfrm>
-            <a:off x="685800" y="3291840"/>
-            <a:ext cx="1600200" cy="914400"/>
-          </a:xfrm>
-          <a:prstGeom prst="rect">
-            <a:avLst/>
-          </a:prstGeom>
-          <a:noFill/>
-          <a:ln/>
-        </p:spPr>
-        <p:txBody>
-          <a:bodyPr wrap="square" lIns="0" tIns="0" rIns="0" bIns="0" rtlCol="0" anchor="ctr"/>
-          <a:lstStyle/>
-          <a:p>
-            <a:pPr indent="0" marL="0">
-              <a:buNone/>
-            </a:pPr>
-            <a:r>
-              <a:rPr lang="en-US" sz="1400" b="1" dirty="0">
-                <a:solidFill>
-                  <a:srgbClr val="FFFFFF"/>
-                </a:solidFill>
-                <a:latin typeface="Calibri" pitchFamily="34" charset="0"/>
-                <a:ea typeface="Calibri" pitchFamily="34" charset="-122"/>
-                <a:cs typeface="Calibri" pitchFamily="34" charset="-120"/>
-              </a:rPr>
-              <a:t>Střední škola</a:t>
-            </a:r>
-            <a:endParaRPr lang="en-US" sz="1400" dirty="0"/>
-          </a:p>
-          <a:p>
-            <a:pPr indent="0" marL="0">
-              <a:buNone/>
-            </a:pPr>
-            <a:r>
-              <a:rPr lang="en-US" sz="1100" dirty="0">
-                <a:solidFill>
-                  <a:srgbClr val="FFFFFF"/>
-                </a:solidFill>
-                <a:latin typeface="Calibri" pitchFamily="34" charset="0"/>
-                <a:ea typeface="Calibri" pitchFamily="34" charset="-122"/>
-                <a:cs typeface="Calibri" pitchFamily="34" charset="-120"/>
-              </a:rPr>
-              <a:t>Vývojářská vrstva</a:t>
-            </a:r>
-            <a:endParaRPr lang="en-US" sz="1400" dirty="0"/>
-          </a:p>
-        </p:txBody>
-      </p:sp>
-      <p:sp>
-        <p:nvSpPr>
-          <p:cNvPr id="11" name="Text 9"/>
-          <p:cNvSpPr txBox="1"/>
-          <p:nvPr/>
-        </p:nvSpPr>
-        <p:spPr>
-          <a:xfrm>
-            <a:off x="2606040" y="3337560"/>
-            <a:ext cx="5989320" cy="868680"/>
-          </a:xfrm>
-          <a:prstGeom prst="rect">
-            <a:avLst/>
-          </a:prstGeom>
-          <a:noFill/>
-          <a:ln/>
-        </p:spPr>
-        <p:txBody>
-          <a:bodyPr wrap="square" lIns="0" tIns="0" rIns="0" bIns="0" rtlCol="0" anchor="ctr"/>
-          <a:lstStyle/>
-          <a:p>
-            <a:pPr indent="0" marL="0">
-              <a:buNone/>
-            </a:pPr>
-            <a:r>
-              <a:rPr lang="en-US" sz="1300" dirty="0">
-                <a:solidFill>
-                  <a:srgbClr val="24203A"/>
-                </a:solidFill>
-                <a:latin typeface="Calibri" pitchFamily="34" charset="0"/>
-                <a:ea typeface="Calibri" pitchFamily="34" charset="-122"/>
-                <a:cs typeface="Calibri" pitchFamily="34" charset="-120"/>
-              </a:rPr>
-              <a:t>Systém jako platforma: ER diagram, REST a MCP API, vlastní skript, návrh nového modulu, šifrování a anonymizace.</a:t>
-            </a:r>
-            <a:endParaRPr lang="en-US" sz="1300" dirty="0"/>
-          </a:p>
-        </p:txBody>
-      </p:sp>
-      <p:sp>
-        <p:nvSpPr>
-          <p:cNvPr id="12" name="Text 10"/>
-          <p:cNvSpPr txBox="1"/>
-          <p:nvPr/>
-        </p:nvSpPr>
-        <p:spPr>
-          <a:xfrm>
-            <a:off x="548640" y="4343400"/>
-            <a:ext cx="8046720" cy="411480"/>
-          </a:xfrm>
-          <a:prstGeom prst="rect">
-            <a:avLst/>
-          </a:prstGeom>
-          <a:noFill/>
-          <a:ln/>
-        </p:spPr>
-        <p:txBody>
-          <a:bodyPr wrap="square" lIns="0" tIns="0" rIns="0" bIns="0" rtlCol="0" anchor="ctr"/>
-          <a:lstStyle/>
-          <a:p>
-            <a:pPr indent="0" marL="0">
-              <a:buNone/>
-            </a:pPr>
-            <a:r>
-              <a:rPr lang="en-US" sz="1100" dirty="0">
-                <a:solidFill>
-                  <a:srgbClr val="6B6680"/>
-                </a:solidFill>
-                <a:latin typeface="Calibri" pitchFamily="34" charset="0"/>
-                <a:ea typeface="Calibri" pitchFamily="34" charset="-122"/>
-                <a:cs typeface="Calibri" pitchFamily="34" charset="-120"/>
-              </a:rPr>
-              <a:t>Spirálové kurikulum: tatáž známka nebo rozvrh se vrací v každém stupni na vyšší úrovni abstrakce. Žák, který dnes klikne na známku, ji za pár let přečte ze svého skriptu – a pozná, že je to tatáž věc.</a:t>
-            </a:r>
-            <a:endParaRPr lang="en-US" sz="1100" dirty="0"/>
-          </a:p>
-        </p:txBody>
-      </p:sp>
-      <p:sp>
-        <p:nvSpPr>
-          <p:cNvPr id="13" name="Text 11"/>
-          <p:cNvSpPr txBox="1"/>
-          <p:nvPr/>
-        </p:nvSpPr>
-        <p:spPr>
-          <a:xfrm>
-            <a:off x="548640" y="4754880"/>
-            <a:ext cx="5486400" cy="274320"/>
-          </a:xfrm>
-          <a:prstGeom prst="rect">
-            <a:avLst/>
-          </a:prstGeom>
-          <a:noFill/>
-          <a:ln/>
-        </p:spPr>
-        <p:txBody>
-          <a:bodyPr wrap="square" lIns="0" tIns="0" rIns="0" bIns="0" rtlCol="0" anchor="ctr"/>
-          <a:lstStyle/>
-          <a:p>
-            <a:pPr indent="0" marL="0">
-              <a:buNone/>
-            </a:pPr>
-            <a:r>
-              <a:rPr lang="en-US" sz="900" dirty="0">
-                <a:solidFill>
-                  <a:srgbClr val="6B6680"/>
-                </a:solidFill>
-                <a:latin typeface="Calibri" pitchFamily="34" charset="0"/>
-                <a:ea typeface="Calibri" pitchFamily="34" charset="-122"/>
-                <a:cs typeface="Calibri" pitchFamily="34" charset="-120"/>
-              </a:rPr>
-              <a:t>Edu Stack IS · Obhajoba bakalářské práce · Petr Vích</a:t>
-            </a:r>
-            <a:endParaRPr lang="en-US" sz="900" dirty="0"/>
-          </a:p>
-        </p:txBody>
-      </p:sp>
-      <p:sp>
-        <p:nvSpPr>
-          <p:cNvPr id="14" name="Text 12"/>
-          <p:cNvSpPr txBox="1"/>
-          <p:nvPr/>
-        </p:nvSpPr>
-        <p:spPr>
-          <a:xfrm>
-            <a:off x="8138160" y="4754880"/>
-            <a:ext cx="457200" cy="274320"/>
-          </a:xfrm>
-          <a:prstGeom prst="rect">
-            <a:avLst/>
-          </a:prstGeom>
-          <a:noFill/>
-          <a:ln/>
-        </p:spPr>
-        <p:txBody>
-          <a:bodyPr wrap="square" lIns="0" tIns="0" rIns="0" bIns="0" rtlCol="0" anchor="ctr"/>
-          <a:lstStyle/>
-          <a:p>
-            <a:pPr algn="r" indent="0" marL="0">
-              <a:buNone/>
-            </a:pPr>
-            <a:r>
-              <a:rPr lang="en-US" sz="900" dirty="0">
-                <a:solidFill>
-                  <a:srgbClr val="6B6680"/>
-                </a:solidFill>
-                <a:latin typeface="Calibri" pitchFamily="34" charset="0"/>
-                <a:ea typeface="Calibri" pitchFamily="34" charset="-122"/>
-                <a:cs typeface="Calibri" pitchFamily="34" charset="-120"/>
-              </a:rPr>
-              <a:t>5</a:t>
+              <a:t>6</a:t>
             </a:r>
             <a:endParaRPr lang="en-US" sz="900" dirty="0"/>
           </a:p>
@@ -9431,7 +8832,7 @@
                 <a:ea typeface="Calibri" pitchFamily="34" charset="-122"/>
                 <a:cs typeface="Calibri" pitchFamily="34" charset="-120"/>
               </a:rPr>
-              <a:t>8</a:t>
+              <a:t>7</a:t>
             </a:r>
             <a:endParaRPr lang="en-US" sz="900" dirty="0"/>
           </a:p>
@@ -10414,7 +9815,7 @@
                 <a:ea typeface="Calibri" pitchFamily="34" charset="-122"/>
                 <a:cs typeface="Calibri" pitchFamily="34" charset="-120"/>
               </a:rPr>
-              <a:t>9</a:t>
+              <a:t>8</a:t>
             </a:r>
             <a:endParaRPr lang="en-US" sz="900" dirty="0"/>
           </a:p>
@@ -11124,7 +10525,7 @@
                 <a:ea typeface="Calibri" pitchFamily="34" charset="-122"/>
                 <a:cs typeface="Calibri" pitchFamily="34" charset="-120"/>
               </a:rPr>
-              <a:t>10</a:t>
+              <a:t>9</a:t>
             </a:r>
             <a:endParaRPr lang="en-US" sz="900" dirty="0"/>
           </a:p>

</xml_diff>

<commit_message>
Slide 4: nadpis „Systém zůstává, roste žák“
Co-Authored-By: Claude Fable 5.1 <noreply@anthropic.com>
</commit_message>
<xml_diff>
--- a/obhajoba-edustack.pptx
+++ b/obhajoba-edustack.pptx
@@ -6585,7 +6585,7 @@
               <a:buNone/>
             </a:pPr>
             <a:r>
-              <a:rPr lang="en-US" sz="2600" b="1" dirty="0">
+              <a:rPr lang="en-US" sz="3000" b="1" dirty="0">
                 <a:solidFill>
                   <a:srgbClr val="3F2A78"/>
                 </a:solidFill>
@@ -6593,9 +6593,9 @@
                 <a:ea typeface="Calibri" pitchFamily="34" charset="-122"/>
                 <a:cs typeface="Calibri" pitchFamily="34" charset="-120"/>
               </a:rPr>
-              <a:t>Jeden systém pro všechny – mění se jen kompetence</a:t>
-            </a:r>
-            <a:endParaRPr lang="en-US" sz="2600" dirty="0"/>
+              <a:t>Systém zůstává, roste žák</a:t>
+            </a:r>
+            <a:endParaRPr lang="en-US" sz="3000" dirty="0"/>
           </a:p>
         </p:txBody>
       </p:sp>

</xml_diff>